<commit_message>
Add Cedar Bayou 5 project-of-interest appendix (A9) to Rev 10
Internet-validated facts from the Cedar Bayou 5 project template:
721 MW CCGT brownfield, $562M TEF loan (3%, 20-yr, 60% of $936M),
mid-2028 COD, TIC/Kiewit EPC, GE Vernova H-class. Corrections applied
(Chambers County, mid-2028 COD, $936M total). Internal sales data
excluded from the customer-facing slide.

Co-Authored-By: Claude Fable 5 <noreply@anthropic.com>
Claude-Session: https://claude.ai/code/session_01DUeyPCeDvcPsyTcH6oQXEK
</commit_message>
<xml_diff>
--- a/teaser-rework/Southwire_NRG_Protecting_Time_to_Power_Rev10.pptx
+++ b/teaser-rework/Southwire_NRG_Protecting_Time_to_Power_Rev10.pptx
@@ -25,6 +25,7 @@
     <p:sldId id="270" r:id="rId1"/>
     <p:sldId id="271" r:id="rId2"/>
     <p:sldId id="272" r:id="rId3"/>
+    <p:sldId id="273" r:id="rId4"/>
   </p:sldIdLst>
   <p:sldSz cx="12192000" cy="6858000"/>
   <p:notesSz cx="6858000" cy="9144000"/>
@@ -12123,6 +12124,1429 @@
 </p:sld>
 </file>
 
+<file path=ppt/slides/slide18.xml><?xml version="1.0" encoding="utf-8"?>
+<p:sld xmlns:p="http://schemas.openxmlformats.org/presentationml/2006/main" xmlns:a="http://schemas.openxmlformats.org/drawingml/2006/main" xmlns:r="http://schemas.openxmlformats.org/officeDocument/2006/relationships">
+  <p:cSld>
+    <p:bg>
+      <p:bgPr>
+        <a:solidFill>
+          <a:srgbClr val="F6F3EE"/>
+        </a:solidFill>
+      </p:bgPr>
+    </p:bg>
+    <p:spTree>
+      <p:nvGrpSpPr>
+        <p:cNvPr id="1" name=""/>
+        <p:cNvGrpSpPr/>
+        <p:nvPr/>
+      </p:nvGrpSpPr>
+      <p:grpSpPr>
+        <a:xfrm/>
+      </p:grpSpPr>
+      <p:sp>
+        <p:nvSpPr>
+          <p:cNvPr id="201" name=""/>
+          <p:cNvSpPr>
+            <a:spLocks noGrp="1"/>
+          </p:cNvSpPr>
+          <p:nvPr/>
+        </p:nvSpPr>
+        <p:spPr>
+          <a:xfrm>
+            <a:off x="0" y="0"/>
+            <a:ext cx="12192000" cy="57150"/>
+          </a:xfrm>
+          <a:prstGeom prst="rect">
+            <a:avLst/>
+          </a:prstGeom>
+          <a:solidFill>
+            <a:srgbClr val="C9783E"/>
+          </a:solidFill>
+          <a:ln w="0">
+            <a:noFill/>
+            <a:prstDash val="solid"/>
+          </a:ln>
+        </p:spPr>
+      </p:sp>
+      <p:pic>
+        <p:nvPicPr>
+          <p:cNvPr id="202" name=""/>
+          <p:cNvPicPr>
+            <a:picLocks noChangeAspect="1"/>
+          </p:cNvPicPr>
+          <p:nvPr/>
+        </p:nvPicPr>
+        <p:blipFill>
+          <a:blip r:embed="R48e2a3d3733b4264"/>
+          <a:stretch/>
+        </p:blipFill>
+        <p:spPr>
+          <a:xfrm>
+            <a:off x="719138" y="200025"/>
+            <a:ext cx="2066925" cy="590550"/>
+          </a:xfrm>
+          <a:prstGeom prst="rect">
+            <a:avLst/>
+          </a:prstGeom>
+        </p:spPr>
+      </p:pic>
+      <p:sp>
+        <p:nvSpPr>
+          <p:cNvPr id="203" name=""/>
+          <p:cNvSpPr>
+            <a:spLocks noGrp="1"/>
+          </p:cNvSpPr>
+          <p:nvPr/>
+        </p:nvSpPr>
+        <p:spPr>
+          <a:xfrm>
+            <a:off x="7325360" y="323850"/>
+            <a:ext cx="3857000" cy="228600"/>
+          </a:xfrm>
+          <a:prstGeom prst="rect">
+            <a:avLst/>
+          </a:prstGeom>
+          <a:noFill/>
+          <a:ln w="0">
+            <a:noFill/>
+            <a:prstDash val="solid"/>
+          </a:ln>
+        </p:spPr>
+        <p:txBody>
+          <a:bodyPr wrap="square" lIns="0" tIns="0" rIns="0" bIns="0" anchor="t">
+            <a:normAutofit fontScale="100000"/>
+          </a:bodyPr>
+          <a:lstStyle/>
+          <a:p>
+            <a:pPr algn="r">
+              <a:lnSpc>
+                <a:spcPct val="100000"/>
+              </a:lnSpc>
+              <a:buNone/>
+            </a:pPr>
+            <a:r>
+              <a:rPr sz="975" b="1" i="0">
+                <a:solidFill>
+                  <a:srgbClr val="9D4E24"/>
+                </a:solidFill>
+                <a:latin typeface="Arial Narrow"/>
+                <a:ea typeface="Arial Narrow"/>
+                <a:cs typeface="Arial Narrow"/>
+              </a:rPr>
+              <a:t>APPENDIX A9 · PROJECT OF INTEREST</a:t>
+            </a:r>
+          </a:p>
+        </p:txBody>
+      </p:sp>
+      <p:sp>
+        <p:nvSpPr>
+          <p:cNvPr id="204" name=""/>
+          <p:cNvSpPr>
+            <a:spLocks noGrp="1"/>
+          </p:cNvSpPr>
+          <p:nvPr/>
+        </p:nvSpPr>
+        <p:spPr>
+          <a:xfrm>
+            <a:off x="11334750" y="323850"/>
+            <a:ext cx="323850" cy="228600"/>
+          </a:xfrm>
+          <a:prstGeom prst="rect">
+            <a:avLst/>
+          </a:prstGeom>
+          <a:noFill/>
+          <a:ln w="0">
+            <a:noFill/>
+            <a:prstDash val="solid"/>
+          </a:ln>
+        </p:spPr>
+        <p:txBody>
+          <a:bodyPr wrap="square" lIns="0" tIns="0" rIns="0" bIns="0" anchor="t">
+            <a:normAutofit fontScale="100000"/>
+          </a:bodyPr>
+          <a:lstStyle/>
+          <a:p>
+            <a:pPr algn="r">
+              <a:lnSpc>
+                <a:spcPct val="100000"/>
+              </a:lnSpc>
+              <a:buNone/>
+            </a:pPr>
+            <a:r>
+              <a:rPr sz="975" b="1" i="0">
+                <a:solidFill>
+                  <a:srgbClr val="8B9094"/>
+                </a:solidFill>
+                <a:latin typeface="Arial Narrow"/>
+                <a:ea typeface="Arial Narrow"/>
+                <a:cs typeface="Arial Narrow"/>
+              </a:rPr>
+              <a:t>18</a:t>
+            </a:r>
+          </a:p>
+        </p:txBody>
+      </p:sp>
+      <p:sp>
+        <p:nvSpPr>
+          <p:cNvPr id="205" name=""/>
+          <p:cNvSpPr>
+            <a:spLocks noGrp="1"/>
+          </p:cNvSpPr>
+          <p:nvPr/>
+        </p:nvSpPr>
+        <p:spPr>
+          <a:xfrm>
+            <a:off x="719138" y="1005840"/>
+            <a:ext cx="8500000" cy="228600"/>
+          </a:xfrm>
+          <a:prstGeom prst="rect">
+            <a:avLst/>
+          </a:prstGeom>
+          <a:noFill/>
+          <a:ln w="0">
+            <a:noFill/>
+            <a:prstDash val="solid"/>
+          </a:ln>
+        </p:spPr>
+        <p:txBody>
+          <a:bodyPr wrap="square" lIns="0" tIns="0" rIns="0" bIns="0" anchor="t">
+            <a:normAutofit fontScale="100000"/>
+          </a:bodyPr>
+          <a:lstStyle/>
+          <a:p>
+            <a:pPr algn="l">
+              <a:lnSpc>
+                <a:spcPct val="100000"/>
+              </a:lnSpc>
+              <a:buNone/>
+            </a:pPr>
+            <a:r>
+              <a:rPr sz="1050" b="1" i="0">
+                <a:solidFill>
+                  <a:srgbClr val="C9783E"/>
+                </a:solidFill>
+                <a:latin typeface="Arial Narrow"/>
+                <a:ea typeface="Arial Narrow"/>
+                <a:cs typeface="Arial Narrow"/>
+              </a:rPr>
+              <a:t>CEDAR BAYOU UNIT 5 · BAYTOWN, TEXAS (CHAMBERS COUNTY)</a:t>
+            </a:r>
+          </a:p>
+        </p:txBody>
+      </p:sp>
+      <p:sp>
+        <p:nvSpPr>
+          <p:cNvPr id="206" name=""/>
+          <p:cNvSpPr>
+            <a:spLocks noGrp="1"/>
+          </p:cNvSpPr>
+          <p:nvPr/>
+        </p:nvSpPr>
+        <p:spPr>
+          <a:xfrm>
+            <a:off x="719138" y="1280160"/>
+            <a:ext cx="10753724" cy="500000"/>
+          </a:xfrm>
+          <a:prstGeom prst="rect">
+            <a:avLst/>
+          </a:prstGeom>
+          <a:noFill/>
+          <a:ln w="0">
+            <a:noFill/>
+            <a:prstDash val="solid"/>
+          </a:ln>
+        </p:spPr>
+        <p:txBody>
+          <a:bodyPr wrap="square" lIns="0" tIns="0" rIns="0" bIns="0" anchor="t">
+            <a:normAutofit fontScale="100000"/>
+          </a:bodyPr>
+          <a:lstStyle/>
+          <a:p>
+            <a:pPr algn="l">
+              <a:lnSpc>
+                <a:spcPct val="104000"/>
+              </a:lnSpc>
+              <a:buNone/>
+            </a:pPr>
+            <a:r>
+              <a:rPr sz="2850" b="1" i="0">
+                <a:solidFill>
+                  <a:srgbClr val="17191C"/>
+                </a:solidFill>
+                <a:latin typeface="Arial"/>
+                <a:ea typeface="Arial"/>
+                <a:cs typeface="Arial"/>
+              </a:rPr>
+              <a:t>Cedar Bayou 5 is the natural first live scope.</a:t>
+            </a:r>
+          </a:p>
+        </p:txBody>
+      </p:sp>
+      <p:sp>
+        <p:nvSpPr>
+          <p:cNvPr id="207" name=""/>
+          <p:cNvSpPr>
+            <a:spLocks noGrp="1"/>
+          </p:cNvSpPr>
+          <p:nvPr/>
+        </p:nvSpPr>
+        <p:spPr>
+          <a:xfrm>
+            <a:off x="719138" y="1950720"/>
+            <a:ext cx="10753724" cy="500000"/>
+          </a:xfrm>
+          <a:prstGeom prst="rect">
+            <a:avLst/>
+          </a:prstGeom>
+          <a:noFill/>
+          <a:ln w="0">
+            <a:noFill/>
+            <a:prstDash val="solid"/>
+          </a:ln>
+        </p:spPr>
+        <p:txBody>
+          <a:bodyPr wrap="square" lIns="0" tIns="0" rIns="0" bIns="0" anchor="t">
+            <a:normAutofit fontScale="100000"/>
+          </a:bodyPr>
+          <a:lstStyle/>
+          <a:p>
+            <a:pPr algn="l">
+              <a:lnSpc>
+                <a:spcPct val="108000"/>
+              </a:lnSpc>
+              <a:buNone/>
+            </a:pPr>
+            <a:r>
+              <a:rPr sz="1050" b="0" i="0">
+                <a:solidFill>
+                  <a:srgbClr val="6A6F73"/>
+                </a:solidFill>
+                <a:latin typeface="Arial"/>
+                <a:ea typeface="Arial"/>
+                <a:cs typeface="Arial"/>
+              </a:rPr>
+              <a:t>A 721 MW combined-cycle brownfield expansion at NRG's existing Cedar Bayou station — the anchor TEF unit in the NRG / GE Vernova / Kiewit framework, in active construction toward a mid-2028 COD.</a:t>
+            </a:r>
+          </a:p>
+        </p:txBody>
+      </p:sp>
+      <p:sp>
+        <p:nvSpPr>
+          <p:cNvPr id="208" name=""/>
+          <p:cNvSpPr>
+            <a:spLocks noGrp="1"/>
+          </p:cNvSpPr>
+          <p:nvPr/>
+        </p:nvSpPr>
+        <p:spPr>
+          <a:xfrm>
+            <a:off x="719138" y="2606040"/>
+            <a:ext cx="4900000" cy="228600"/>
+          </a:xfrm>
+          <a:prstGeom prst="rect">
+            <a:avLst/>
+          </a:prstGeom>
+          <a:noFill/>
+          <a:ln w="0">
+            <a:noFill/>
+            <a:prstDash val="solid"/>
+          </a:ln>
+        </p:spPr>
+        <p:txBody>
+          <a:bodyPr wrap="square" lIns="0" tIns="0" rIns="0" bIns="0" anchor="t">
+            <a:normAutofit fontScale="100000"/>
+          </a:bodyPr>
+          <a:lstStyle/>
+          <a:p>
+            <a:pPr algn="l">
+              <a:lnSpc>
+                <a:spcPct val="100000"/>
+              </a:lnSpc>
+              <a:buNone/>
+            </a:pPr>
+            <a:r>
+              <a:rPr sz="975" b="1" i="0">
+                <a:solidFill>
+                  <a:srgbClr val="9D4E24"/>
+                </a:solidFill>
+                <a:latin typeface="Arial Narrow"/>
+                <a:ea typeface="Arial Narrow"/>
+                <a:cs typeface="Arial Narrow"/>
+              </a:rPr>
+              <a:t>PROJECT FACTS — VALIDATED AUG 2026</a:t>
+            </a:r>
+          </a:p>
+        </p:txBody>
+      </p:sp>
+      <p:sp>
+        <p:nvSpPr>
+          <p:cNvPr id="209" name=""/>
+          <p:cNvSpPr>
+            <a:spLocks noGrp="1"/>
+          </p:cNvSpPr>
+          <p:nvPr/>
+        </p:nvSpPr>
+        <p:spPr>
+          <a:xfrm>
+            <a:off x="719138" y="2925840"/>
+            <a:ext cx="4900000" cy="228600"/>
+          </a:xfrm>
+          <a:prstGeom prst="rect">
+            <a:avLst/>
+          </a:prstGeom>
+          <a:noFill/>
+          <a:ln w="0">
+            <a:noFill/>
+            <a:prstDash val="solid"/>
+          </a:ln>
+        </p:spPr>
+        <p:txBody>
+          <a:bodyPr wrap="square" lIns="0" tIns="0" rIns="0" bIns="0" anchor="t">
+            <a:normAutofit fontScale="100000"/>
+          </a:bodyPr>
+          <a:lstStyle/>
+          <a:p>
+            <a:pPr algn="l">
+              <a:lnSpc>
+                <a:spcPct val="100000"/>
+              </a:lnSpc>
+              <a:buNone/>
+            </a:pPr>
+            <a:r>
+              <a:rPr sz="1050" b="1" i="0">
+                <a:solidFill>
+                  <a:srgbClr val="9D4E24"/>
+                </a:solidFill>
+                <a:latin typeface="Arial Narrow"/>
+                <a:ea typeface="Arial Narrow"/>
+                <a:cs typeface="Arial Narrow"/>
+              </a:rPr>
+              <a:t>721 MW CCGT · BROWNFIELD</a:t>
+            </a:r>
+          </a:p>
+        </p:txBody>
+      </p:sp>
+      <p:sp>
+        <p:nvSpPr>
+          <p:cNvPr id="210" name=""/>
+          <p:cNvSpPr>
+            <a:spLocks noGrp="1"/>
+          </p:cNvSpPr>
+          <p:nvPr/>
+        </p:nvSpPr>
+        <p:spPr>
+          <a:xfrm>
+            <a:off x="719138" y="3154440"/>
+            <a:ext cx="4900000" cy="560000"/>
+          </a:xfrm>
+          <a:prstGeom prst="rect">
+            <a:avLst/>
+          </a:prstGeom>
+          <a:noFill/>
+          <a:ln w="0">
+            <a:noFill/>
+            <a:prstDash val="solid"/>
+          </a:ln>
+        </p:spPr>
+        <p:txBody>
+          <a:bodyPr wrap="square" lIns="0" tIns="0" rIns="0" bIns="0" anchor="t">
+            <a:normAutofit fontScale="100000"/>
+          </a:bodyPr>
+          <a:lstStyle/>
+          <a:p>
+            <a:pPr algn="l">
+              <a:lnSpc>
+                <a:spcPct val="106000"/>
+              </a:lnSpc>
+              <a:buNone/>
+            </a:pPr>
+            <a:r>
+              <a:rPr sz="975" b="0" i="0">
+                <a:solidFill>
+                  <a:srgbClr val="6A6F73"/>
+                </a:solidFill>
+                <a:latin typeface="Arial"/>
+                <a:ea typeface="Arial"/>
+                <a:cs typeface="Arial"/>
+              </a:rPr>
+              <a:t>GE Vernova H-class train at the existing station; ERCOT Houston Load Zone; existing 345 kV switchyard, cooling water and site infrastructure.</a:t>
+            </a:r>
+          </a:p>
+        </p:txBody>
+      </p:sp>
+      <p:sp>
+        <p:nvSpPr>
+          <p:cNvPr id="211" name=""/>
+          <p:cNvSpPr>
+            <a:spLocks noGrp="1"/>
+          </p:cNvSpPr>
+          <p:nvPr/>
+        </p:nvSpPr>
+        <p:spPr>
+          <a:xfrm>
+            <a:off x="719138" y="3725940"/>
+            <a:ext cx="4900000" cy="228600"/>
+          </a:xfrm>
+          <a:prstGeom prst="rect">
+            <a:avLst/>
+          </a:prstGeom>
+          <a:noFill/>
+          <a:ln w="0">
+            <a:noFill/>
+            <a:prstDash val="solid"/>
+          </a:ln>
+        </p:spPr>
+        <p:txBody>
+          <a:bodyPr wrap="square" lIns="0" tIns="0" rIns="0" bIns="0" anchor="t">
+            <a:normAutofit fontScale="100000"/>
+          </a:bodyPr>
+          <a:lstStyle/>
+          <a:p>
+            <a:pPr algn="l">
+              <a:lnSpc>
+                <a:spcPct val="100000"/>
+              </a:lnSpc>
+              <a:buNone/>
+            </a:pPr>
+            <a:r>
+              <a:rPr sz="1050" b="1" i="0">
+                <a:solidFill>
+                  <a:srgbClr val="9D4E24"/>
+                </a:solidFill>
+                <a:latin typeface="Arial Narrow"/>
+                <a:ea typeface="Arial Narrow"/>
+                <a:cs typeface="Arial Narrow"/>
+              </a:rPr>
+              <a:t>$562M TEF LOAN · 3% · 20-YEAR</a:t>
+            </a:r>
+          </a:p>
+        </p:txBody>
+      </p:sp>
+      <p:sp>
+        <p:nvSpPr>
+          <p:cNvPr id="212" name=""/>
+          <p:cNvSpPr>
+            <a:spLocks noGrp="1"/>
+          </p:cNvSpPr>
+          <p:nvPr/>
+        </p:nvSpPr>
+        <p:spPr>
+          <a:xfrm>
+            <a:off x="719138" y="3954540"/>
+            <a:ext cx="4900000" cy="560000"/>
+          </a:xfrm>
+          <a:prstGeom prst="rect">
+            <a:avLst/>
+          </a:prstGeom>
+          <a:noFill/>
+          <a:ln w="0">
+            <a:noFill/>
+            <a:prstDash val="solid"/>
+          </a:ln>
+        </p:spPr>
+        <p:txBody>
+          <a:bodyPr wrap="square" lIns="0" tIns="0" rIns="0" bIns="0" anchor="t">
+            <a:normAutofit fontScale="100000"/>
+          </a:bodyPr>
+          <a:lstStyle/>
+          <a:p>
+            <a:pPr algn="l">
+              <a:lnSpc>
+                <a:spcPct val="106000"/>
+              </a:lnSpc>
+              <a:buNone/>
+            </a:pPr>
+            <a:r>
+              <a:rPr sz="975" b="0" i="0">
+                <a:solidFill>
+                  <a:srgbClr val="6A6F73"/>
+                </a:solidFill>
+                <a:latin typeface="Arial"/>
+                <a:ea typeface="Arial"/>
+                <a:cs typeface="Arial"/>
+              </a:rPr>
+              <a:t>Signed September 2025 — 60% of the $936M project cost; part of $1.15B TEF financing plus $66M tax abatements across the three-unit program.</a:t>
+            </a:r>
+          </a:p>
+        </p:txBody>
+      </p:sp>
+      <p:sp>
+        <p:nvSpPr>
+          <p:cNvPr id="213" name=""/>
+          <p:cNvSpPr>
+            <a:spLocks noGrp="1"/>
+          </p:cNvSpPr>
+          <p:nvPr/>
+        </p:nvSpPr>
+        <p:spPr>
+          <a:xfrm>
+            <a:off x="719138" y="4526040"/>
+            <a:ext cx="4900000" cy="228600"/>
+          </a:xfrm>
+          <a:prstGeom prst="rect">
+            <a:avLst/>
+          </a:prstGeom>
+          <a:noFill/>
+          <a:ln w="0">
+            <a:noFill/>
+            <a:prstDash val="solid"/>
+          </a:ln>
+        </p:spPr>
+        <p:txBody>
+          <a:bodyPr wrap="square" lIns="0" tIns="0" rIns="0" bIns="0" anchor="t">
+            <a:normAutofit fontScale="100000"/>
+          </a:bodyPr>
+          <a:lstStyle/>
+          <a:p>
+            <a:pPr algn="l">
+              <a:lnSpc>
+                <a:spcPct val="100000"/>
+              </a:lnSpc>
+              <a:buNone/>
+            </a:pPr>
+            <a:r>
+              <a:rPr sz="1050" b="1" i="0">
+                <a:solidFill>
+                  <a:srgbClr val="9D4E24"/>
+                </a:solidFill>
+                <a:latin typeface="Arial Narrow"/>
+                <a:ea typeface="Arial Narrow"/>
+                <a:cs typeface="Arial Narrow"/>
+              </a:rPr>
+              <a:t>COD TARGET MID-2028</a:t>
+            </a:r>
+          </a:p>
+        </p:txBody>
+      </p:sp>
+      <p:sp>
+        <p:nvSpPr>
+          <p:cNvPr id="214" name=""/>
+          <p:cNvSpPr>
+            <a:spLocks noGrp="1"/>
+          </p:cNvSpPr>
+          <p:nvPr/>
+        </p:nvSpPr>
+        <p:spPr>
+          <a:xfrm>
+            <a:off x="719138" y="4754640"/>
+            <a:ext cx="4900000" cy="560000"/>
+          </a:xfrm>
+          <a:prstGeom prst="rect">
+            <a:avLst/>
+          </a:prstGeom>
+          <a:noFill/>
+          <a:ln w="0">
+            <a:noFill/>
+            <a:prstDash val="solid"/>
+          </a:ln>
+        </p:spPr>
+        <p:txBody>
+          <a:bodyPr wrap="square" lIns="0" tIns="0" rIns="0" bIns="0" anchor="t">
+            <a:normAutofit fontScale="100000"/>
+          </a:bodyPr>
+          <a:lstStyle/>
+          <a:p>
+            <a:pPr algn="l">
+              <a:lnSpc>
+                <a:spcPct val="106000"/>
+              </a:lnSpc>
+              <a:buNone/>
+            </a:pPr>
+            <a:r>
+              <a:rPr sz="975" b="0" i="0">
+                <a:solidFill>
+                  <a:srgbClr val="6A6F73"/>
+                </a:solidFill>
+                <a:latin typeface="Arial"/>
+                <a:ea typeface="Arial"/>
+                <a:cs typeface="Arial"/>
+              </a:rPr>
+              <a:t>First TEF unit to advance construction; T.H. Wharton (415 MW) completes mid-2026, Greens Bayou 6 follows in 2028.</a:t>
+            </a:r>
+          </a:p>
+        </p:txBody>
+      </p:sp>
+      <p:sp>
+        <p:nvSpPr>
+          <p:cNvPr id="215" name=""/>
+          <p:cNvSpPr>
+            <a:spLocks noGrp="1"/>
+          </p:cNvSpPr>
+          <p:nvPr/>
+        </p:nvSpPr>
+        <p:spPr>
+          <a:xfrm>
+            <a:off x="719138" y="5326140"/>
+            <a:ext cx="4900000" cy="228600"/>
+          </a:xfrm>
+          <a:prstGeom prst="rect">
+            <a:avLst/>
+          </a:prstGeom>
+          <a:noFill/>
+          <a:ln w="0">
+            <a:noFill/>
+            <a:prstDash val="solid"/>
+          </a:ln>
+        </p:spPr>
+        <p:txBody>
+          <a:bodyPr wrap="square" lIns="0" tIns="0" rIns="0" bIns="0" anchor="t">
+            <a:normAutofit fontScale="100000"/>
+          </a:bodyPr>
+          <a:lstStyle/>
+          <a:p>
+            <a:pPr algn="l">
+              <a:lnSpc>
+                <a:spcPct val="100000"/>
+              </a:lnSpc>
+              <a:buNone/>
+            </a:pPr>
+            <a:r>
+              <a:rPr sz="1050" b="1" i="0">
+                <a:solidFill>
+                  <a:srgbClr val="9D4E24"/>
+                </a:solidFill>
+                <a:latin typeface="Arial Narrow"/>
+                <a:ea typeface="Arial Narrow"/>
+                <a:cs typeface="Arial Narrow"/>
+              </a:rPr>
+              <a:t>EPC: TIC / KIEWIT · OEM: GE VERNOVA</a:t>
+            </a:r>
+          </a:p>
+        </p:txBody>
+      </p:sp>
+      <p:sp>
+        <p:nvSpPr>
+          <p:cNvPr id="216" name=""/>
+          <p:cNvSpPr>
+            <a:spLocks noGrp="1"/>
+          </p:cNvSpPr>
+          <p:nvPr/>
+        </p:nvSpPr>
+        <p:spPr>
+          <a:xfrm>
+            <a:off x="719138" y="5554740"/>
+            <a:ext cx="4900000" cy="560000"/>
+          </a:xfrm>
+          <a:prstGeom prst="rect">
+            <a:avLst/>
+          </a:prstGeom>
+          <a:noFill/>
+          <a:ln w="0">
+            <a:noFill/>
+            <a:prstDash val="solid"/>
+          </a:ln>
+        </p:spPr>
+        <p:txBody>
+          <a:bodyPr wrap="square" lIns="0" tIns="0" rIns="0" bIns="0" anchor="t">
+            <a:normAutofit fontScale="100000"/>
+          </a:bodyPr>
+          <a:lstStyle/>
+          <a:p>
+            <a:pPr algn="l">
+              <a:lnSpc>
+                <a:spcPct val="106000"/>
+              </a:lnSpc>
+              <a:buNone/>
+            </a:pPr>
+            <a:r>
+              <a:rPr sz="975" b="0" i="0">
+                <a:solidFill>
+                  <a:srgbClr val="6A6F73"/>
+                </a:solidFill>
+                <a:latin typeface="Arial"/>
+                <a:ea typeface="Arial"/>
+                <a:cs typeface="Arial"/>
+              </a:rPr>
+              <a:t>Delivered under the 5.4 GW development framework — 1.2 GW in service by 2029, 1.2 GW by 2030, 3 GW more through 2032.</a:t>
+            </a:r>
+          </a:p>
+        </p:txBody>
+      </p:sp>
+      <p:sp>
+        <p:nvSpPr>
+          <p:cNvPr id="217" name=""/>
+          <p:cNvSpPr>
+            <a:spLocks noGrp="1"/>
+          </p:cNvSpPr>
+          <p:nvPr/>
+        </p:nvSpPr>
+        <p:spPr>
+          <a:xfrm>
+            <a:off x="6120130" y="2606040"/>
+            <a:ext cx="5352732" cy="228600"/>
+          </a:xfrm>
+          <a:prstGeom prst="rect">
+            <a:avLst/>
+          </a:prstGeom>
+          <a:noFill/>
+          <a:ln w="0">
+            <a:noFill/>
+            <a:prstDash val="solid"/>
+          </a:ln>
+        </p:spPr>
+        <p:txBody>
+          <a:bodyPr wrap="square" lIns="0" tIns="0" rIns="0" bIns="0" anchor="t">
+            <a:normAutofit fontScale="100000"/>
+          </a:bodyPr>
+          <a:lstStyle/>
+          <a:p>
+            <a:pPr algn="l">
+              <a:lnSpc>
+                <a:spcPct val="100000"/>
+              </a:lnSpc>
+              <a:buNone/>
+            </a:pPr>
+            <a:r>
+              <a:rPr sz="975" b="1" i="0">
+                <a:solidFill>
+                  <a:srgbClr val="9D4E24"/>
+                </a:solidFill>
+                <a:latin typeface="Arial Narrow"/>
+                <a:ea typeface="Arial Narrow"/>
+                <a:cs typeface="Arial Narrow"/>
+              </a:rPr>
+              <a:t>POTENTIAL SCOPE SELECTIONS</a:t>
+            </a:r>
+          </a:p>
+        </p:txBody>
+      </p:sp>
+      <p:sp>
+        <p:nvSpPr>
+          <p:cNvPr id="218" name=""/>
+          <p:cNvSpPr>
+            <a:spLocks noGrp="1"/>
+          </p:cNvSpPr>
+          <p:nvPr/>
+        </p:nvSpPr>
+        <p:spPr>
+          <a:xfrm>
+            <a:off x="6120130" y="2984840"/>
+            <a:ext cx="91440" cy="91440"/>
+          </a:xfrm>
+          <a:prstGeom prst="rect">
+            <a:avLst/>
+          </a:prstGeom>
+          <a:solidFill>
+            <a:srgbClr val="C9783E"/>
+          </a:solidFill>
+          <a:ln w="0">
+            <a:noFill/>
+            <a:prstDash val="solid"/>
+          </a:ln>
+        </p:spPr>
+      </p:sp>
+      <p:sp>
+        <p:nvSpPr>
+          <p:cNvPr id="219" name=""/>
+          <p:cNvSpPr>
+            <a:spLocks noGrp="1"/>
+          </p:cNvSpPr>
+          <p:nvPr/>
+        </p:nvSpPr>
+        <p:spPr>
+          <a:xfrm>
+            <a:off x="6348730" y="2925840"/>
+            <a:ext cx="5124132" cy="420000"/>
+          </a:xfrm>
+          <a:prstGeom prst="rect">
+            <a:avLst/>
+          </a:prstGeom>
+          <a:noFill/>
+          <a:ln w="0">
+            <a:noFill/>
+            <a:prstDash val="solid"/>
+          </a:ln>
+        </p:spPr>
+        <p:txBody>
+          <a:bodyPr wrap="square" lIns="0" tIns="0" rIns="0" bIns="0" anchor="t">
+            <a:normAutofit fontScale="100000"/>
+          </a:bodyPr>
+          <a:lstStyle/>
+          <a:p>
+            <a:pPr algn="l">
+              <a:lnSpc>
+                <a:spcPct val="104000"/>
+              </a:lnSpc>
+              <a:buNone/>
+            </a:pPr>
+            <a:r>
+              <a:rPr sz="1050" b="0" i="0">
+                <a:solidFill>
+                  <a:srgbClr val="6A6F73"/>
+                </a:solidFill>
+                <a:latin typeface="Arial"/>
+                <a:ea typeface="Arial"/>
+                <a:cs typeface="Arial"/>
+              </a:rPr>
+              <a:t>HV generator leads and brownfield 345 kV switchyard tie-in for the H-class train</a:t>
+            </a:r>
+          </a:p>
+        </p:txBody>
+      </p:sp>
+      <p:sp>
+        <p:nvSpPr>
+          <p:cNvPr id="220" name=""/>
+          <p:cNvSpPr>
+            <a:spLocks noGrp="1"/>
+          </p:cNvSpPr>
+          <p:nvPr/>
+        </p:nvSpPr>
+        <p:spPr>
+          <a:xfrm>
+            <a:off x="6120130" y="3442040"/>
+            <a:ext cx="91440" cy="91440"/>
+          </a:xfrm>
+          <a:prstGeom prst="rect">
+            <a:avLst/>
+          </a:prstGeom>
+          <a:solidFill>
+            <a:srgbClr val="C9783E"/>
+          </a:solidFill>
+          <a:ln w="0">
+            <a:noFill/>
+            <a:prstDash val="solid"/>
+          </a:ln>
+        </p:spPr>
+      </p:sp>
+      <p:sp>
+        <p:nvSpPr>
+          <p:cNvPr id="221" name=""/>
+          <p:cNvSpPr>
+            <a:spLocks noGrp="1"/>
+          </p:cNvSpPr>
+          <p:nvPr/>
+        </p:nvSpPr>
+        <p:spPr>
+          <a:xfrm>
+            <a:off x="6348730" y="3383040"/>
+            <a:ext cx="5124132" cy="420000"/>
+          </a:xfrm>
+          <a:prstGeom prst="rect">
+            <a:avLst/>
+          </a:prstGeom>
+          <a:noFill/>
+          <a:ln w="0">
+            <a:noFill/>
+            <a:prstDash val="solid"/>
+          </a:ln>
+        </p:spPr>
+        <p:txBody>
+          <a:bodyPr wrap="square" lIns="0" tIns="0" rIns="0" bIns="0" anchor="t">
+            <a:normAutofit fontScale="100000"/>
+          </a:bodyPr>
+          <a:lstStyle/>
+          <a:p>
+            <a:pPr algn="l">
+              <a:lnSpc>
+                <a:spcPct val="104000"/>
+              </a:lnSpc>
+              <a:buNone/>
+            </a:pPr>
+            <a:r>
+              <a:rPr sz="1050" b="0" i="0">
+                <a:solidFill>
+                  <a:srgbClr val="6A6F73"/>
+                </a:solidFill>
+                <a:latin typeface="Arial"/>
+                <a:ea typeface="Arial"/>
+                <a:cs typeface="Arial"/>
+              </a:rPr>
+              <a:t>MV plant auxiliary distribution, 5–35 kV, across the new unit and interfaces</a:t>
+            </a:r>
+          </a:p>
+        </p:txBody>
+      </p:sp>
+      <p:sp>
+        <p:nvSpPr>
+          <p:cNvPr id="222" name=""/>
+          <p:cNvSpPr>
+            <a:spLocks noGrp="1"/>
+          </p:cNvSpPr>
+          <p:nvPr/>
+        </p:nvSpPr>
+        <p:spPr>
+          <a:xfrm>
+            <a:off x="6120130" y="3899240"/>
+            <a:ext cx="91440" cy="91440"/>
+          </a:xfrm>
+          <a:prstGeom prst="rect">
+            <a:avLst/>
+          </a:prstGeom>
+          <a:solidFill>
+            <a:srgbClr val="C9783E"/>
+          </a:solidFill>
+          <a:ln w="0">
+            <a:noFill/>
+            <a:prstDash val="solid"/>
+          </a:ln>
+        </p:spPr>
+      </p:sp>
+      <p:sp>
+        <p:nvSpPr>
+          <p:cNvPr id="223" name=""/>
+          <p:cNvSpPr>
+            <a:spLocks noGrp="1"/>
+          </p:cNvSpPr>
+          <p:nvPr/>
+        </p:nvSpPr>
+        <p:spPr>
+          <a:xfrm>
+            <a:off x="6348730" y="3840240"/>
+            <a:ext cx="5124132" cy="420000"/>
+          </a:xfrm>
+          <a:prstGeom prst="rect">
+            <a:avLst/>
+          </a:prstGeom>
+          <a:noFill/>
+          <a:ln w="0">
+            <a:noFill/>
+            <a:prstDash val="solid"/>
+          </a:ln>
+        </p:spPr>
+        <p:txBody>
+          <a:bodyPr wrap="square" lIns="0" tIns="0" rIns="0" bIns="0" anchor="t">
+            <a:normAutofit fontScale="100000"/>
+          </a:bodyPr>
+          <a:lstStyle/>
+          <a:p>
+            <a:pPr algn="l">
+              <a:lnSpc>
+                <a:spcPct val="104000"/>
+              </a:lnSpc>
+              <a:buNone/>
+            </a:pPr>
+            <a:r>
+              <a:rPr sz="1050" b="0" i="0">
+                <a:solidFill>
+                  <a:srgbClr val="6A6F73"/>
+                </a:solidFill>
+                <a:latin typeface="Arial"/>
+                <a:ea typeface="Arial"/>
+                <a:cs typeface="Arial"/>
+              </a:rPr>
+              <a:t>LV 600 V power and control — turbine hall, HRSG and balance of plant</a:t>
+            </a:r>
+          </a:p>
+        </p:txBody>
+      </p:sp>
+      <p:sp>
+        <p:nvSpPr>
+          <p:cNvPr id="224" name=""/>
+          <p:cNvSpPr>
+            <a:spLocks noGrp="1"/>
+          </p:cNvSpPr>
+          <p:nvPr/>
+        </p:nvSpPr>
+        <p:spPr>
+          <a:xfrm>
+            <a:off x="6120130" y="4356440"/>
+            <a:ext cx="91440" cy="91440"/>
+          </a:xfrm>
+          <a:prstGeom prst="rect">
+            <a:avLst/>
+          </a:prstGeom>
+          <a:solidFill>
+            <a:srgbClr val="C9783E"/>
+          </a:solidFill>
+          <a:ln w="0">
+            <a:noFill/>
+            <a:prstDash val="solid"/>
+          </a:ln>
+        </p:spPr>
+      </p:sp>
+      <p:sp>
+        <p:nvSpPr>
+          <p:cNvPr id="225" name=""/>
+          <p:cNvSpPr>
+            <a:spLocks noGrp="1"/>
+          </p:cNvSpPr>
+          <p:nvPr/>
+        </p:nvSpPr>
+        <p:spPr>
+          <a:xfrm>
+            <a:off x="6348730" y="4297440"/>
+            <a:ext cx="5124132" cy="420000"/>
+          </a:xfrm>
+          <a:prstGeom prst="rect">
+            <a:avLst/>
+          </a:prstGeom>
+          <a:noFill/>
+          <a:ln w="0">
+            <a:noFill/>
+            <a:prstDash val="solid"/>
+          </a:ln>
+        </p:spPr>
+        <p:txBody>
+          <a:bodyPr wrap="square" lIns="0" tIns="0" rIns="0" bIns="0" anchor="t">
+            <a:normAutofit fontScale="100000"/>
+          </a:bodyPr>
+          <a:lstStyle/>
+          <a:p>
+            <a:pPr algn="l">
+              <a:lnSpc>
+                <a:spcPct val="104000"/>
+              </a:lnSpc>
+              <a:buNone/>
+            </a:pPr>
+            <a:r>
+              <a:rPr sz="1050" b="0" i="0">
+                <a:solidFill>
+                  <a:srgbClr val="6A6F73"/>
+                </a:solidFill>
+                <a:latin typeface="Arial"/>
+                <a:ea typeface="Arial"/>
+                <a:cs typeface="Arial"/>
+              </a:rPr>
+              <a:t>I&amp;C, DCS and fiber — integration with the existing station and ERCOT SCADA</a:t>
+            </a:r>
+          </a:p>
+        </p:txBody>
+      </p:sp>
+      <p:sp>
+        <p:nvSpPr>
+          <p:cNvPr id="226" name=""/>
+          <p:cNvSpPr>
+            <a:spLocks noGrp="1"/>
+          </p:cNvSpPr>
+          <p:nvPr/>
+        </p:nvSpPr>
+        <p:spPr>
+          <a:xfrm>
+            <a:off x="6120130" y="4813640"/>
+            <a:ext cx="91440" cy="91440"/>
+          </a:xfrm>
+          <a:prstGeom prst="rect">
+            <a:avLst/>
+          </a:prstGeom>
+          <a:solidFill>
+            <a:srgbClr val="C9783E"/>
+          </a:solidFill>
+          <a:ln w="0">
+            <a:noFill/>
+            <a:prstDash val="solid"/>
+          </a:ln>
+        </p:spPr>
+      </p:sp>
+      <p:sp>
+        <p:nvSpPr>
+          <p:cNvPr id="227" name=""/>
+          <p:cNvSpPr>
+            <a:spLocks noGrp="1"/>
+          </p:cNvSpPr>
+          <p:nvPr/>
+        </p:nvSpPr>
+        <p:spPr>
+          <a:xfrm>
+            <a:off x="6348730" y="4754640"/>
+            <a:ext cx="5124132" cy="420000"/>
+          </a:xfrm>
+          <a:prstGeom prst="rect">
+            <a:avLst/>
+          </a:prstGeom>
+          <a:noFill/>
+          <a:ln w="0">
+            <a:noFill/>
+            <a:prstDash val="solid"/>
+          </a:ln>
+        </p:spPr>
+        <p:txBody>
+          <a:bodyPr wrap="square" lIns="0" tIns="0" rIns="0" bIns="0" anchor="t">
+            <a:normAutofit fontScale="100000"/>
+          </a:bodyPr>
+          <a:lstStyle/>
+          <a:p>
+            <a:pPr algn="l">
+              <a:lnSpc>
+                <a:spcPct val="104000"/>
+              </a:lnSpc>
+              <a:buNone/>
+            </a:pPr>
+            <a:r>
+              <a:rPr sz="1050" b="0" i="0">
+                <a:solidFill>
+                  <a:srgbClr val="6A6F73"/>
+                </a:solidFill>
+                <a:latin typeface="Arial"/>
+                <a:ea typeface="Arial"/>
+                <a:cs typeface="Arial"/>
+              </a:rPr>
+              <a:t>Grounding-grid extension into the heritage plant grid</a:t>
+            </a:r>
+          </a:p>
+        </p:txBody>
+      </p:sp>
+      <p:sp>
+        <p:nvSpPr>
+          <p:cNvPr id="228" name=""/>
+          <p:cNvSpPr>
+            <a:spLocks noGrp="1"/>
+          </p:cNvSpPr>
+          <p:nvPr/>
+        </p:nvSpPr>
+        <p:spPr>
+          <a:xfrm>
+            <a:off x="6120130" y="5270840"/>
+            <a:ext cx="91440" cy="91440"/>
+          </a:xfrm>
+          <a:prstGeom prst="rect">
+            <a:avLst/>
+          </a:prstGeom>
+          <a:solidFill>
+            <a:srgbClr val="C9783E"/>
+          </a:solidFill>
+          <a:ln w="0">
+            <a:noFill/>
+            <a:prstDash val="solid"/>
+          </a:ln>
+        </p:spPr>
+      </p:sp>
+      <p:sp>
+        <p:nvSpPr>
+          <p:cNvPr id="229" name=""/>
+          <p:cNvSpPr>
+            <a:spLocks noGrp="1"/>
+          </p:cNvSpPr>
+          <p:nvPr/>
+        </p:nvSpPr>
+        <p:spPr>
+          <a:xfrm>
+            <a:off x="6348730" y="5211840"/>
+            <a:ext cx="5124132" cy="420000"/>
+          </a:xfrm>
+          <a:prstGeom prst="rect">
+            <a:avLst/>
+          </a:prstGeom>
+          <a:noFill/>
+          <a:ln w="0">
+            <a:noFill/>
+            <a:prstDash val="solid"/>
+          </a:ln>
+        </p:spPr>
+        <p:txBody>
+          <a:bodyPr wrap="square" lIns="0" tIns="0" rIns="0" bIns="0" anchor="t">
+            <a:normAutofit fontScale="100000"/>
+          </a:bodyPr>
+          <a:lstStyle/>
+          <a:p>
+            <a:pPr algn="l">
+              <a:lnSpc>
+                <a:spcPct val="104000"/>
+              </a:lnSpc>
+              <a:buNone/>
+            </a:pPr>
+            <a:r>
+              <a:rPr sz="1050" b="0" i="0">
+                <a:solidFill>
+                  <a:srgbClr val="6A6F73"/>
+                </a:solidFill>
+                <a:latin typeface="Arial"/>
+                <a:ea typeface="Arial"/>
+                <a:cs typeface="Arial"/>
+              </a:rPr>
+              <a:t>Sequenced reels, cut lengths and kits against 2026–2028 procurement windows</a:t>
+            </a:r>
+          </a:p>
+        </p:txBody>
+      </p:sp>
+      <p:sp>
+        <p:nvSpPr>
+          <p:cNvPr id="230" name=""/>
+          <p:cNvSpPr>
+            <a:spLocks noGrp="1"/>
+          </p:cNvSpPr>
+          <p:nvPr/>
+        </p:nvSpPr>
+        <p:spPr>
+          <a:xfrm>
+            <a:off x="6120130" y="5728040"/>
+            <a:ext cx="91440" cy="91440"/>
+          </a:xfrm>
+          <a:prstGeom prst="rect">
+            <a:avLst/>
+          </a:prstGeom>
+          <a:solidFill>
+            <a:srgbClr val="C9783E"/>
+          </a:solidFill>
+          <a:ln w="0">
+            <a:noFill/>
+            <a:prstDash val="solid"/>
+          </a:ln>
+        </p:spPr>
+      </p:sp>
+      <p:sp>
+        <p:nvSpPr>
+          <p:cNvPr id="231" name=""/>
+          <p:cNvSpPr>
+            <a:spLocks noGrp="1"/>
+          </p:cNvSpPr>
+          <p:nvPr/>
+        </p:nvSpPr>
+        <p:spPr>
+          <a:xfrm>
+            <a:off x="6348730" y="5669040"/>
+            <a:ext cx="5124132" cy="420000"/>
+          </a:xfrm>
+          <a:prstGeom prst="rect">
+            <a:avLst/>
+          </a:prstGeom>
+          <a:noFill/>
+          <a:ln w="0">
+            <a:noFill/>
+            <a:prstDash val="solid"/>
+          </a:ln>
+        </p:spPr>
+        <p:txBody>
+          <a:bodyPr wrap="square" lIns="0" tIns="0" rIns="0" bIns="0" anchor="t">
+            <a:normAutofit fontScale="100000"/>
+          </a:bodyPr>
+          <a:lstStyle/>
+          <a:p>
+            <a:pPr algn="l">
+              <a:lnSpc>
+                <a:spcPct val="104000"/>
+              </a:lnSpc>
+              <a:buNone/>
+            </a:pPr>
+            <a:r>
+              <a:rPr sz="1050" b="0" i="0">
+                <a:solidFill>
+                  <a:srgbClr val="6A6F73"/>
+                </a:solidFill>
+                <a:latin typeface="Arial"/>
+                <a:ea typeface="Arial"/>
+                <a:cs typeface="Arial"/>
+              </a:rPr>
+              <a:t>Post-COD continuity — records, spares and MRO carried into the operating fleet</a:t>
+            </a:r>
+          </a:p>
+        </p:txBody>
+      </p:sp>
+      <p:sp>
+        <p:nvSpPr>
+          <p:cNvPr id="232" name=""/>
+          <p:cNvSpPr>
+            <a:spLocks noGrp="1"/>
+          </p:cNvSpPr>
+          <p:nvPr/>
+        </p:nvSpPr>
+        <p:spPr>
+          <a:xfrm>
+            <a:off x="719138" y="6032500"/>
+            <a:ext cx="10753724" cy="200000"/>
+          </a:xfrm>
+          <a:prstGeom prst="rect">
+            <a:avLst/>
+          </a:prstGeom>
+          <a:noFill/>
+          <a:ln w="0">
+            <a:noFill/>
+            <a:prstDash val="solid"/>
+          </a:ln>
+        </p:spPr>
+        <p:txBody>
+          <a:bodyPr wrap="square" lIns="0" tIns="0" rIns="0" bIns="0" anchor="t">
+            <a:normAutofit fontScale="100000"/>
+          </a:bodyPr>
+          <a:lstStyle/>
+          <a:p>
+            <a:pPr algn="l">
+              <a:lnSpc>
+                <a:spcPct val="100000"/>
+              </a:lnSpc>
+              <a:buNone/>
+            </a:pPr>
+            <a:r>
+              <a:rPr sz="825" b="0" i="1">
+                <a:solidFill>
+                  <a:srgbClr val="6A6F73"/>
+                </a:solidFill>
+                <a:latin typeface="Arial"/>
+                <a:ea typeface="Arial"/>
+                <a:cs typeface="Arial"/>
+              </a:rPr>
+              <a:t>Validated against public sources, Aug 2026: PUCT / Texas Energy Fund announcements, Utility Dive, NRG investor materials. Capacity reported 689–721 MW across sources; 721 MW per the PUCT loan announcement.</a:t>
+            </a:r>
+          </a:p>
+        </p:txBody>
+      </p:sp>
+      <p:sp>
+        <p:nvSpPr>
+          <p:cNvPr id="233" name=""/>
+          <p:cNvSpPr>
+            <a:spLocks noGrp="1"/>
+          </p:cNvSpPr>
+          <p:nvPr/>
+        </p:nvSpPr>
+        <p:spPr>
+          <a:xfrm>
+            <a:off x="719138" y="6315000"/>
+            <a:ext cx="10753724" cy="400000"/>
+          </a:xfrm>
+          <a:prstGeom prst="rect">
+            <a:avLst/>
+          </a:prstGeom>
+          <a:solidFill>
+            <a:srgbClr val="17191C"/>
+          </a:solidFill>
+          <a:ln w="0">
+            <a:noFill/>
+            <a:prstDash val="solid"/>
+          </a:ln>
+        </p:spPr>
+      </p:sp>
+      <p:sp>
+        <p:nvSpPr>
+          <p:cNvPr id="234" name=""/>
+          <p:cNvSpPr>
+            <a:spLocks noGrp="1"/>
+          </p:cNvSpPr>
+          <p:nvPr/>
+        </p:nvSpPr>
+        <p:spPr>
+          <a:xfrm>
+            <a:off x="719138" y="6315000"/>
+            <a:ext cx="10753724" cy="400000"/>
+          </a:xfrm>
+          <a:prstGeom prst="rect">
+            <a:avLst/>
+          </a:prstGeom>
+          <a:noFill/>
+          <a:ln w="0">
+            <a:noFill/>
+            <a:prstDash val="solid"/>
+          </a:ln>
+        </p:spPr>
+        <p:txBody>
+          <a:bodyPr wrap="square" lIns="0" tIns="0" rIns="0" bIns="0" anchor="ctr">
+            <a:normAutofit fontScale="100000"/>
+          </a:bodyPr>
+          <a:lstStyle/>
+          <a:p>
+            <a:pPr algn="ctr">
+              <a:lnSpc>
+                <a:spcPct val="100000"/>
+              </a:lnSpc>
+              <a:buNone/>
+            </a:pPr>
+            <a:r>
+              <a:rPr sz="1050" b="1" i="0">
+                <a:solidFill>
+                  <a:srgbClr val="FFFFFF"/>
+                </a:solidFill>
+                <a:latin typeface="Arial Narrow"/>
+                <a:ea typeface="Arial Narrow"/>
+                <a:cs typeface="Arial Narrow"/>
+              </a:rPr>
+              <a:t>IN ACTIVE PROCUREMENT NOW — THE OBVIOUS CANDIDATE FOR THE ONE-LIVE-SCOPE VALIDATION PATH ON SLIDE 8.</a:t>
+            </a:r>
+          </a:p>
+        </p:txBody>
+      </p:sp>
+    </p:spTree>
+  </p:cSld>
+</p:sld>
+</file>
+
 <file path=ppt/slides/slide2.xml><?xml version="1.0" encoding="utf-8"?>
 <p:sld xmlns:p="http://schemas.openxmlformats.org/presentationml/2006/main">
   <p:cSld>

</xml_diff>

<commit_message>
Name Cedar Bayou 5 as suggested first scope on validation-path slide
One-line callout on slide 8 linking the ask to Appendix A9, framed as
suggestion with the decision left to NRG. Rest of slide unchanged.

Co-Authored-By: Claude Fable 5 <noreply@anthropic.com>
Claude-Session: https://claude.ai/code/session_01DUeyPCeDvcPsyTcH6oQXEK
</commit_message>
<xml_diff>
--- a/teaser-rework/Southwire_NRG_Protecting_Time_to_Power_Rev10.pptx
+++ b/teaser-rework/Southwire_NRG_Protecting_Time_to_Power_Rev10.pptx
@@ -23593,6 +23593,76 @@
           </a:p>
         </p:txBody>
       </p:sp>
+      <p:sp>
+        <p:nvSpPr>
+          <p:cNvPr id="300" name=""/>
+          <p:cNvSpPr>
+            <a:spLocks xmlns:a="http://schemas.openxmlformats.org/drawingml/2006/main" noGrp="1"/>
+          </p:cNvSpPr>
+          <p:nvPr/>
+        </p:nvSpPr>
+        <p:spPr>
+          <a:xfrm xmlns:a="http://schemas.openxmlformats.org/drawingml/2006/main">
+            <a:off x="552450" y="2381250"/>
+            <a:ext cx="11087100" cy="266700"/>
+          </a:xfrm>
+          <a:prstGeom xmlns:a="http://schemas.openxmlformats.org/drawingml/2006/main" prst="rect">
+            <a:avLst/>
+          </a:prstGeom>
+          <a:noFill xmlns:a="http://schemas.openxmlformats.org/drawingml/2006/main"/>
+          <a:ln xmlns:a="http://schemas.openxmlformats.org/drawingml/2006/main" w="0">
+            <a:noFill/>
+            <a:prstDash val="solid"/>
+          </a:ln>
+        </p:spPr>
+        <p:txBody>
+          <a:bodyPr xmlns:a="http://schemas.openxmlformats.org/drawingml/2006/main" wrap="square" lIns="0" tIns="0" rIns="0" bIns="0" anchor="t">
+            <a:normAutofit fontScale="100000"/>
+          </a:bodyPr>
+          <a:lstStyle xmlns:a="http://schemas.openxmlformats.org/drawingml/2006/main"/>
+          <a:p xmlns:a="http://schemas.openxmlformats.org/drawingml/2006/main">
+            <a:pPr algn="l">
+              <a:lnSpc>
+                <a:spcPct val="100000"/>
+              </a:lnSpc>
+              <a:buNone/>
+            </a:pPr>
+            <a:r xmlns:a="http://schemas.openxmlformats.org/drawingml/2006/main">
+              <a:rPr sz="1050" b="1" i="0">
+                <a:solidFill>
+                  <a:srgbClr val="9D4E24"/>
+                </a:solidFill>
+                <a:latin typeface="Arial Narrow"/>
+                <a:ea typeface="Arial Narrow"/>
+                <a:cs typeface="Arial Narrow"/>
+              </a:rPr>
+              <a:t>SUGGESTED FIRST SCOPE:  </a:t>
+            </a:r>
+            <a:r xmlns:a="http://schemas.openxmlformats.org/drawingml/2006/main">
+              <a:rPr sz="1050" b="1" i="0">
+                <a:solidFill>
+                  <a:srgbClr val="17191C"/>
+                </a:solidFill>
+                <a:latin typeface="Arial Narrow"/>
+                <a:ea typeface="Arial Narrow"/>
+                <a:cs typeface="Arial Narrow"/>
+              </a:rPr>
+              <a:t>CEDAR BAYOU 5 — ACTIVE TEF UNIT, MID-2028 COD</a:t>
+            </a:r>
+            <a:r xmlns:a="http://schemas.openxmlformats.org/drawingml/2006/main">
+              <a:rPr sz="1050" b="1" i="0">
+                <a:solidFill>
+                  <a:srgbClr val="6A6F73"/>
+                </a:solidFill>
+                <a:latin typeface="Arial Narrow"/>
+                <a:ea typeface="Arial Narrow"/>
+                <a:cs typeface="Arial Narrow"/>
+              </a:rPr>
+              <a:t>   ·   OUR SUGGESTION, YOUR CALL   ·   DETAIL IN APPENDIX A9</a:t>
+            </a:r>
+          </a:p>
+        </p:txBody>
+      </p:sp>
     </p:spTree>
     <p:extLst>
       <p:ext uri="{BB962C8B-B14F-4D97-AF65-F5344CB8AC3E}">

</xml_diff>

<commit_message>
Add Finance + ESG appendix (A10) from positioning one-pagers
Consolidates the new content from four supplied positioning PDFs:
pre-EPC offerings and finance/ESG documentation (EPDs, Scope 3 data,
BOM transparency, domestic-content records). Overlapping scope content
not duplicated; ITC/PTC claim softened for gas-asset accuracy.

Co-Authored-By: Claude Fable 5 <noreply@anthropic.com>
Claude-Session: https://claude.ai/code/session_01DUeyPCeDvcPsyTcH6oQXEK
</commit_message>
<xml_diff>
--- a/teaser-rework/Southwire_NRG_Protecting_Time_to_Power_Rev10.pptx
+++ b/teaser-rework/Southwire_NRG_Protecting_Time_to_Power_Rev10.pptx
@@ -26,6 +26,7 @@
     <p:sldId id="271" r:id="rId2"/>
     <p:sldId id="272" r:id="rId3"/>
     <p:sldId id="273" r:id="rId4"/>
+    <p:sldId id="274" r:id="rId5"/>
   </p:sldIdLst>
   <p:sldSz cx="12192000" cy="6858000"/>
   <p:notesSz cx="6858000" cy="9144000"/>
@@ -13547,6 +13548,1264 @@
 </p:sld>
 </file>
 
+<file path=ppt/slides/slide19.xml><?xml version="1.0" encoding="utf-8"?>
+<p:sld xmlns:p="http://schemas.openxmlformats.org/presentationml/2006/main" xmlns:a="http://schemas.openxmlformats.org/drawingml/2006/main" xmlns:r="http://schemas.openxmlformats.org/officeDocument/2006/relationships">
+  <p:cSld>
+    <p:bg>
+      <p:bgPr>
+        <a:solidFill>
+          <a:srgbClr val="F6F3EE"/>
+        </a:solidFill>
+      </p:bgPr>
+    </p:bg>
+    <p:spTree>
+      <p:nvGrpSpPr>
+        <p:cNvPr id="1" name=""/>
+        <p:cNvGrpSpPr/>
+        <p:nvPr/>
+      </p:nvGrpSpPr>
+      <p:grpSpPr>
+        <a:xfrm/>
+      </p:grpSpPr>
+      <p:sp>
+        <p:nvSpPr>
+          <p:cNvPr id="401" name=""/>
+          <p:cNvSpPr>
+            <a:spLocks noGrp="1"/>
+          </p:cNvSpPr>
+          <p:nvPr/>
+        </p:nvSpPr>
+        <p:spPr>
+          <a:xfrm>
+            <a:off x="0" y="0"/>
+            <a:ext cx="12192000" cy="57150"/>
+          </a:xfrm>
+          <a:prstGeom prst="rect">
+            <a:avLst/>
+          </a:prstGeom>
+          <a:solidFill>
+            <a:srgbClr val="C9783E"/>
+          </a:solidFill>
+          <a:ln w="0">
+            <a:noFill/>
+            <a:prstDash val="solid"/>
+          </a:ln>
+        </p:spPr>
+      </p:sp>
+      <p:pic>
+        <p:nvPicPr>
+          <p:cNvPr id="402" name=""/>
+          <p:cNvPicPr>
+            <a:picLocks noChangeAspect="1"/>
+          </p:cNvPicPr>
+          <p:nvPr/>
+        </p:nvPicPr>
+        <p:blipFill>
+          <a:blip r:embed="R48e2a3d3733b4264"/>
+          <a:stretch/>
+        </p:blipFill>
+        <p:spPr>
+          <a:xfrm>
+            <a:off x="719138" y="200025"/>
+            <a:ext cx="2066925" cy="590550"/>
+          </a:xfrm>
+          <a:prstGeom prst="rect">
+            <a:avLst/>
+          </a:prstGeom>
+        </p:spPr>
+      </p:pic>
+      <p:sp>
+        <p:nvSpPr>
+          <p:cNvPr id="403" name=""/>
+          <p:cNvSpPr>
+            <a:spLocks noGrp="1"/>
+          </p:cNvSpPr>
+          <p:nvPr/>
+        </p:nvSpPr>
+        <p:spPr>
+          <a:xfrm>
+            <a:off x="7325360" y="323850"/>
+            <a:ext cx="3857000" cy="228600"/>
+          </a:xfrm>
+          <a:prstGeom prst="rect">
+            <a:avLst/>
+          </a:prstGeom>
+          <a:noFill/>
+          <a:ln w="0">
+            <a:noFill/>
+            <a:prstDash val="solid"/>
+          </a:ln>
+        </p:spPr>
+        <p:txBody>
+          <a:bodyPr wrap="square" lIns="0" tIns="0" rIns="0" bIns="0" anchor="t">
+            <a:normAutofit fontScale="100000"/>
+          </a:bodyPr>
+          <a:lstStyle/>
+          <a:p>
+            <a:pPr algn="r">
+              <a:lnSpc>
+                <a:spcPct val="100000"/>
+              </a:lnSpc>
+              <a:buNone/>
+            </a:pPr>
+            <a:r>
+              <a:rPr sz="975" b="1" i="0">
+                <a:solidFill>
+                  <a:srgbClr val="9D4E24"/>
+                </a:solidFill>
+                <a:latin typeface="Arial Narrow"/>
+                <a:ea typeface="Arial Narrow"/>
+                <a:cs typeface="Arial Narrow"/>
+              </a:rPr>
+              <a:t>APPENDIX A10 · FINANCE + ESG</a:t>
+            </a:r>
+          </a:p>
+        </p:txBody>
+      </p:sp>
+      <p:sp>
+        <p:nvSpPr>
+          <p:cNvPr id="404" name=""/>
+          <p:cNvSpPr>
+            <a:spLocks noGrp="1"/>
+          </p:cNvSpPr>
+          <p:nvPr/>
+        </p:nvSpPr>
+        <p:spPr>
+          <a:xfrm>
+            <a:off x="11334750" y="323850"/>
+            <a:ext cx="323850" cy="228600"/>
+          </a:xfrm>
+          <a:prstGeom prst="rect">
+            <a:avLst/>
+          </a:prstGeom>
+          <a:noFill/>
+          <a:ln w="0">
+            <a:noFill/>
+            <a:prstDash val="solid"/>
+          </a:ln>
+        </p:spPr>
+        <p:txBody>
+          <a:bodyPr wrap="square" lIns="0" tIns="0" rIns="0" bIns="0" anchor="t">
+            <a:normAutofit fontScale="100000"/>
+          </a:bodyPr>
+          <a:lstStyle/>
+          <a:p>
+            <a:pPr algn="r">
+              <a:lnSpc>
+                <a:spcPct val="100000"/>
+              </a:lnSpc>
+              <a:buNone/>
+            </a:pPr>
+            <a:r>
+              <a:rPr sz="975" b="1" i="0">
+                <a:solidFill>
+                  <a:srgbClr val="8B9094"/>
+                </a:solidFill>
+                <a:latin typeface="Arial Narrow"/>
+                <a:ea typeface="Arial Narrow"/>
+                <a:cs typeface="Arial Narrow"/>
+              </a:rPr>
+              <a:t>19</a:t>
+            </a:r>
+          </a:p>
+        </p:txBody>
+      </p:sp>
+      <p:sp>
+        <p:nvSpPr>
+          <p:cNvPr id="405" name=""/>
+          <p:cNvSpPr>
+            <a:spLocks noGrp="1"/>
+          </p:cNvSpPr>
+          <p:nvPr/>
+        </p:nvSpPr>
+        <p:spPr>
+          <a:xfrm>
+            <a:off x="719138" y="1005840"/>
+            <a:ext cx="8500000" cy="228600"/>
+          </a:xfrm>
+          <a:prstGeom prst="rect">
+            <a:avLst/>
+          </a:prstGeom>
+          <a:noFill/>
+          <a:ln w="0">
+            <a:noFill/>
+            <a:prstDash val="solid"/>
+          </a:ln>
+        </p:spPr>
+        <p:txBody>
+          <a:bodyPr wrap="square" lIns="0" tIns="0" rIns="0" bIns="0" anchor="t">
+            <a:normAutofit fontScale="100000"/>
+          </a:bodyPr>
+          <a:lstStyle/>
+          <a:p>
+            <a:pPr algn="l">
+              <a:lnSpc>
+                <a:spcPct val="100000"/>
+              </a:lnSpc>
+              <a:buNone/>
+            </a:pPr>
+            <a:r>
+              <a:rPr sz="1050" b="1" i="0">
+                <a:solidFill>
+                  <a:srgbClr val="C9783E"/>
+                </a:solidFill>
+                <a:latin typeface="Arial Narrow"/>
+                <a:ea typeface="Arial Narrow"/>
+                <a:cs typeface="Arial Narrow"/>
+              </a:rPr>
+              <a:t>EARLY ENGAGEMENT, UNDERWRITING-GRADE DOCUMENTATION</a:t>
+            </a:r>
+          </a:p>
+        </p:txBody>
+      </p:sp>
+      <p:sp>
+        <p:nvSpPr>
+          <p:cNvPr id="406" name=""/>
+          <p:cNvSpPr>
+            <a:spLocks noGrp="1"/>
+          </p:cNvSpPr>
+          <p:nvPr/>
+        </p:nvSpPr>
+        <p:spPr>
+          <a:xfrm>
+            <a:off x="719138" y="1280160"/>
+            <a:ext cx="10753724" cy="500000"/>
+          </a:xfrm>
+          <a:prstGeom prst="rect">
+            <a:avLst/>
+          </a:prstGeom>
+          <a:noFill/>
+          <a:ln w="0">
+            <a:noFill/>
+            <a:prstDash val="solid"/>
+          </a:ln>
+        </p:spPr>
+        <p:txBody>
+          <a:bodyPr wrap="square" lIns="0" tIns="0" rIns="0" bIns="0" anchor="t">
+            <a:normAutofit fontScale="100000"/>
+          </a:bodyPr>
+          <a:lstStyle/>
+          <a:p>
+            <a:pPr algn="l">
+              <a:lnSpc>
+                <a:spcPct val="104000"/>
+              </a:lnSpc>
+              <a:buNone/>
+            </a:pPr>
+            <a:r>
+              <a:rPr sz="2850" b="1" i="0">
+                <a:solidFill>
+                  <a:srgbClr val="17191C"/>
+                </a:solidFill>
+                <a:latin typeface="Arial"/>
+                <a:ea typeface="Arial"/>
+                <a:cs typeface="Arial"/>
+              </a:rPr>
+              <a:t>What early engagement includes — and what finance gets out of it.</a:t>
+            </a:r>
+          </a:p>
+        </p:txBody>
+      </p:sp>
+      <p:sp>
+        <p:nvSpPr>
+          <p:cNvPr id="407" name=""/>
+          <p:cNvSpPr>
+            <a:spLocks noGrp="1"/>
+          </p:cNvSpPr>
+          <p:nvPr/>
+        </p:nvSpPr>
+        <p:spPr>
+          <a:xfrm>
+            <a:off x="719138" y="1950720"/>
+            <a:ext cx="10753724" cy="300000"/>
+          </a:xfrm>
+          <a:prstGeom prst="rect">
+            <a:avLst/>
+          </a:prstGeom>
+          <a:noFill/>
+          <a:ln w="0">
+            <a:noFill/>
+            <a:prstDash val="solid"/>
+          </a:ln>
+        </p:spPr>
+        <p:txBody>
+          <a:bodyPr wrap="square" lIns="0" tIns="0" rIns="0" bIns="0" anchor="t">
+            <a:normAutofit fontScale="100000"/>
+          </a:bodyPr>
+          <a:lstStyle/>
+          <a:p>
+            <a:pPr algn="l">
+              <a:lnSpc>
+                <a:spcPct val="108000"/>
+              </a:lnSpc>
+              <a:buNone/>
+            </a:pPr>
+            <a:r>
+              <a:rPr sz="1050" b="0" i="0">
+                <a:solidFill>
+                  <a:srgbClr val="6A6F73"/>
+                </a:solidFill>
+                <a:latin typeface="Arial"/>
+                <a:ea typeface="Arial"/>
+                <a:cs typeface="Arial"/>
+              </a:rPr>
+              <a:t>Technical readiness converts into underwriting inputs: cost, schedule, sourcing and carbon visibility before the EPC bid hardens contingency.</a:t>
+            </a:r>
+          </a:p>
+        </p:txBody>
+      </p:sp>
+      <p:sp>
+        <p:nvSpPr>
+          <p:cNvPr id="408" name=""/>
+          <p:cNvSpPr>
+            <a:spLocks noGrp="1"/>
+          </p:cNvSpPr>
+          <p:nvPr/>
+        </p:nvSpPr>
+        <p:spPr>
+          <a:xfrm>
+            <a:off x="719138" y="2515235"/>
+            <a:ext cx="4900000" cy="228600"/>
+          </a:xfrm>
+          <a:prstGeom prst="rect">
+            <a:avLst/>
+          </a:prstGeom>
+          <a:noFill/>
+          <a:ln w="0">
+            <a:noFill/>
+            <a:prstDash val="solid"/>
+          </a:ln>
+        </p:spPr>
+        <p:txBody>
+          <a:bodyPr wrap="square" lIns="0" tIns="0" rIns="0" bIns="0" anchor="t">
+            <a:normAutofit fontScale="100000"/>
+          </a:bodyPr>
+          <a:lstStyle/>
+          <a:p>
+            <a:pPr algn="l">
+              <a:lnSpc>
+                <a:spcPct val="100000"/>
+              </a:lnSpc>
+              <a:buNone/>
+            </a:pPr>
+            <a:r>
+              <a:rPr sz="975" b="1" i="0">
+                <a:solidFill>
+                  <a:srgbClr val="9D4E24"/>
+                </a:solidFill>
+                <a:latin typeface="Arial Narrow"/>
+                <a:ea typeface="Arial Narrow"/>
+                <a:cs typeface="Arial Narrow"/>
+              </a:rPr>
+              <a:t>PRE-EPC OFFERINGS</a:t>
+            </a:r>
+          </a:p>
+        </p:txBody>
+      </p:sp>
+      <p:sp>
+        <p:nvSpPr>
+          <p:cNvPr id="409" name=""/>
+          <p:cNvSpPr>
+            <a:spLocks noGrp="1"/>
+          </p:cNvSpPr>
+          <p:nvPr/>
+        </p:nvSpPr>
+        <p:spPr>
+          <a:xfrm>
+            <a:off x="719138" y="2894035"/>
+            <a:ext cx="91440" cy="91440"/>
+          </a:xfrm>
+          <a:prstGeom prst="rect">
+            <a:avLst/>
+          </a:prstGeom>
+          <a:solidFill>
+            <a:srgbClr val="C9783E"/>
+          </a:solidFill>
+          <a:ln w="0">
+            <a:noFill/>
+            <a:prstDash val="solid"/>
+          </a:ln>
+        </p:spPr>
+      </p:sp>
+      <p:sp>
+        <p:nvSpPr>
+          <p:cNvPr id="410" name=""/>
+          <p:cNvSpPr>
+            <a:spLocks noGrp="1"/>
+          </p:cNvSpPr>
+          <p:nvPr/>
+        </p:nvSpPr>
+        <p:spPr>
+          <a:xfrm>
+            <a:off x="947738" y="2835035"/>
+            <a:ext cx="4671400" cy="520000"/>
+          </a:xfrm>
+          <a:prstGeom prst="rect">
+            <a:avLst/>
+          </a:prstGeom>
+          <a:noFill/>
+          <a:ln w="0">
+            <a:noFill/>
+            <a:prstDash val="solid"/>
+          </a:ln>
+        </p:spPr>
+        <p:txBody>
+          <a:bodyPr wrap="square" lIns="0" tIns="0" rIns="0" bIns="0" anchor="t">
+            <a:normAutofit fontScale="100000"/>
+          </a:bodyPr>
+          <a:lstStyle/>
+          <a:p>
+            <a:pPr algn="l">
+              <a:lnSpc>
+                <a:spcPct val="104000"/>
+              </a:lnSpc>
+              <a:buNone/>
+            </a:pPr>
+            <a:r>
+              <a:rPr sz="1050" b="0" i="0">
+                <a:solidFill>
+                  <a:srgbClr val="6A6F73"/>
+                </a:solidFill>
+                <a:latin typeface="Arial"/>
+                <a:ea typeface="Arial"/>
+                <a:cs typeface="Arial"/>
+              </a:rPr>
+              <a:t>Master planning workshop — conceptual design and interface mapping for complex sites</a:t>
+            </a:r>
+          </a:p>
+        </p:txBody>
+      </p:sp>
+      <p:sp>
+        <p:nvSpPr>
+          <p:cNvPr id="411" name=""/>
+          <p:cNvSpPr>
+            <a:spLocks noGrp="1"/>
+          </p:cNvSpPr>
+          <p:nvPr/>
+        </p:nvSpPr>
+        <p:spPr>
+          <a:xfrm>
+            <a:off x="719138" y="3488395"/>
+            <a:ext cx="91440" cy="91440"/>
+          </a:xfrm>
+          <a:prstGeom prst="rect">
+            <a:avLst/>
+          </a:prstGeom>
+          <a:solidFill>
+            <a:srgbClr val="C9783E"/>
+          </a:solidFill>
+          <a:ln w="0">
+            <a:noFill/>
+            <a:prstDash val="solid"/>
+          </a:ln>
+        </p:spPr>
+      </p:sp>
+      <p:sp>
+        <p:nvSpPr>
+          <p:cNvPr id="412" name=""/>
+          <p:cNvSpPr>
+            <a:spLocks noGrp="1"/>
+          </p:cNvSpPr>
+          <p:nvPr/>
+        </p:nvSpPr>
+        <p:spPr>
+          <a:xfrm>
+            <a:off x="947738" y="3429395"/>
+            <a:ext cx="4671400" cy="520000"/>
+          </a:xfrm>
+          <a:prstGeom prst="rect">
+            <a:avLst/>
+          </a:prstGeom>
+          <a:noFill/>
+          <a:ln w="0">
+            <a:noFill/>
+            <a:prstDash val="solid"/>
+          </a:ln>
+        </p:spPr>
+        <p:txBody>
+          <a:bodyPr wrap="square" lIns="0" tIns="0" rIns="0" bIns="0" anchor="t">
+            <a:normAutofit fontScale="100000"/>
+          </a:bodyPr>
+          <a:lstStyle/>
+          <a:p>
+            <a:pPr algn="l">
+              <a:lnSpc>
+                <a:spcPct val="104000"/>
+              </a:lnSpc>
+              <a:buNone/>
+            </a:pPr>
+            <a:r>
+              <a:rPr sz="1050" b="0" i="0">
+                <a:solidFill>
+                  <a:srgbClr val="6A6F73"/>
+                </a:solidFill>
+                <a:latin typeface="Arial"/>
+                <a:ea typeface="Arial"/>
+                <a:cs typeface="Arial"/>
+              </a:rPr>
+              <a:t>Conceptual cable solution design and electrical spine architecture</a:t>
+            </a:r>
+          </a:p>
+        </p:txBody>
+      </p:sp>
+      <p:sp>
+        <p:nvSpPr>
+          <p:cNvPr id="413" name=""/>
+          <p:cNvSpPr>
+            <a:spLocks noGrp="1"/>
+          </p:cNvSpPr>
+          <p:nvPr/>
+        </p:nvSpPr>
+        <p:spPr>
+          <a:xfrm>
+            <a:off x="719138" y="4082755"/>
+            <a:ext cx="91440" cy="91440"/>
+          </a:xfrm>
+          <a:prstGeom prst="rect">
+            <a:avLst/>
+          </a:prstGeom>
+          <a:solidFill>
+            <a:srgbClr val="C9783E"/>
+          </a:solidFill>
+          <a:ln w="0">
+            <a:noFill/>
+            <a:prstDash val="solid"/>
+          </a:ln>
+        </p:spPr>
+      </p:sp>
+      <p:sp>
+        <p:nvSpPr>
+          <p:cNvPr id="414" name=""/>
+          <p:cNvSpPr>
+            <a:spLocks noGrp="1"/>
+          </p:cNvSpPr>
+          <p:nvPr/>
+        </p:nvSpPr>
+        <p:spPr>
+          <a:xfrm>
+            <a:off x="947738" y="4023755"/>
+            <a:ext cx="4671400" cy="520000"/>
+          </a:xfrm>
+          <a:prstGeom prst="rect">
+            <a:avLst/>
+          </a:prstGeom>
+          <a:noFill/>
+          <a:ln w="0">
+            <a:noFill/>
+            <a:prstDash val="solid"/>
+          </a:ln>
+        </p:spPr>
+        <p:txBody>
+          <a:bodyPr wrap="square" lIns="0" tIns="0" rIns="0" bIns="0" anchor="t">
+            <a:normAutofit fontScale="100000"/>
+          </a:bodyPr>
+          <a:lstStyle/>
+          <a:p>
+            <a:pPr algn="l">
+              <a:lnSpc>
+                <a:spcPct val="104000"/>
+              </a:lnSpc>
+              <a:buNone/>
+            </a:pPr>
+            <a:r>
+              <a:rPr sz="1050" b="0" i="0">
+                <a:solidFill>
+                  <a:srgbClr val="6A6F73"/>
+                </a:solidFill>
+                <a:latin typeface="Arial"/>
+                <a:ea typeface="Arial"/>
+                <a:cs typeface="Arial"/>
+              </a:rPr>
+              <a:t>Procurement risk register and schedule visibility</a:t>
+            </a:r>
+          </a:p>
+        </p:txBody>
+      </p:sp>
+      <p:sp>
+        <p:nvSpPr>
+          <p:cNvPr id="415" name=""/>
+          <p:cNvSpPr>
+            <a:spLocks noGrp="1"/>
+          </p:cNvSpPr>
+          <p:nvPr/>
+        </p:nvSpPr>
+        <p:spPr>
+          <a:xfrm>
+            <a:off x="719138" y="4677115"/>
+            <a:ext cx="91440" cy="91440"/>
+          </a:xfrm>
+          <a:prstGeom prst="rect">
+            <a:avLst/>
+          </a:prstGeom>
+          <a:solidFill>
+            <a:srgbClr val="C9783E"/>
+          </a:solidFill>
+          <a:ln w="0">
+            <a:noFill/>
+            <a:prstDash val="solid"/>
+          </a:ln>
+        </p:spPr>
+      </p:sp>
+      <p:sp>
+        <p:nvSpPr>
+          <p:cNvPr id="416" name=""/>
+          <p:cNvSpPr>
+            <a:spLocks noGrp="1"/>
+          </p:cNvSpPr>
+          <p:nvPr/>
+        </p:nvSpPr>
+        <p:spPr>
+          <a:xfrm>
+            <a:off x="947738" y="4618115"/>
+            <a:ext cx="4671400" cy="520000"/>
+          </a:xfrm>
+          <a:prstGeom prst="rect">
+            <a:avLst/>
+          </a:prstGeom>
+          <a:noFill/>
+          <a:ln w="0">
+            <a:noFill/>
+            <a:prstDash val="solid"/>
+          </a:ln>
+        </p:spPr>
+        <p:txBody>
+          <a:bodyPr wrap="square" lIns="0" tIns="0" rIns="0" bIns="0" anchor="t">
+            <a:normAutofit fontScale="100000"/>
+          </a:bodyPr>
+          <a:lstStyle/>
+          <a:p>
+            <a:pPr algn="l">
+              <a:lnSpc>
+                <a:spcPct val="104000"/>
+              </a:lnSpc>
+              <a:buNone/>
+            </a:pPr>
+            <a:r>
+              <a:rPr sz="1050" b="0" i="0">
+                <a:solidFill>
+                  <a:srgbClr val="6A6F73"/>
+                </a:solidFill>
+                <a:latin typeface="Arial"/>
+                <a:ea typeface="Arial"/>
+                <a:cs typeface="Arial"/>
+              </a:rPr>
+              <a:t>Capacity allocation and commodity (Cu/Al) exposure hedging support</a:t>
+            </a:r>
+          </a:p>
+        </p:txBody>
+      </p:sp>
+      <p:sp>
+        <p:nvSpPr>
+          <p:cNvPr id="417" name=""/>
+          <p:cNvSpPr>
+            <a:spLocks noGrp="1"/>
+          </p:cNvSpPr>
+          <p:nvPr/>
+        </p:nvSpPr>
+        <p:spPr>
+          <a:xfrm>
+            <a:off x="719138" y="5271475"/>
+            <a:ext cx="91440" cy="91440"/>
+          </a:xfrm>
+          <a:prstGeom prst="rect">
+            <a:avLst/>
+          </a:prstGeom>
+          <a:solidFill>
+            <a:srgbClr val="C9783E"/>
+          </a:solidFill>
+          <a:ln w="0">
+            <a:noFill/>
+            <a:prstDash val="solid"/>
+          </a:ln>
+        </p:spPr>
+      </p:sp>
+      <p:sp>
+        <p:nvSpPr>
+          <p:cNvPr id="418" name=""/>
+          <p:cNvSpPr>
+            <a:spLocks noGrp="1"/>
+          </p:cNvSpPr>
+          <p:nvPr/>
+        </p:nvSpPr>
+        <p:spPr>
+          <a:xfrm>
+            <a:off x="947738" y="5212475"/>
+            <a:ext cx="4671400" cy="520000"/>
+          </a:xfrm>
+          <a:prstGeom prst="rect">
+            <a:avLst/>
+          </a:prstGeom>
+          <a:noFill/>
+          <a:ln w="0">
+            <a:noFill/>
+            <a:prstDash val="solid"/>
+          </a:ln>
+        </p:spPr>
+        <p:txBody>
+          <a:bodyPr wrap="square" lIns="0" tIns="0" rIns="0" bIns="0" anchor="t">
+            <a:normAutofit fontScale="100000"/>
+          </a:bodyPr>
+          <a:lstStyle/>
+          <a:p>
+            <a:pPr algn="l">
+              <a:lnSpc>
+                <a:spcPct val="104000"/>
+              </a:lnSpc>
+              <a:buNone/>
+            </a:pPr>
+            <a:r>
+              <a:rPr sz="1050" b="0" i="0">
+                <a:solidFill>
+                  <a:srgbClr val="6A6F73"/>
+                </a:solidFill>
+                <a:latin typeface="Arial"/>
+                <a:ea typeface="Arial"/>
+                <a:cs typeface="Arial"/>
+              </a:rPr>
+              <a:t>Domestic supply strategy — U.S.-made resilience for TEF and local-content goals</a:t>
+            </a:r>
+          </a:p>
+        </p:txBody>
+      </p:sp>
+      <p:sp>
+        <p:nvSpPr>
+          <p:cNvPr id="419" name=""/>
+          <p:cNvSpPr>
+            <a:spLocks noGrp="1"/>
+          </p:cNvSpPr>
+          <p:nvPr/>
+        </p:nvSpPr>
+        <p:spPr>
+          <a:xfrm>
+            <a:off x="6120130" y="2515235"/>
+            <a:ext cx="5352732" cy="228600"/>
+          </a:xfrm>
+          <a:prstGeom prst="rect">
+            <a:avLst/>
+          </a:prstGeom>
+          <a:noFill/>
+          <a:ln w="0">
+            <a:noFill/>
+            <a:prstDash val="solid"/>
+          </a:ln>
+        </p:spPr>
+        <p:txBody>
+          <a:bodyPr wrap="square" lIns="0" tIns="0" rIns="0" bIns="0" anchor="t">
+            <a:normAutofit fontScale="100000"/>
+          </a:bodyPr>
+          <a:lstStyle/>
+          <a:p>
+            <a:pPr algn="l">
+              <a:lnSpc>
+                <a:spcPct val="100000"/>
+              </a:lnSpc>
+              <a:buNone/>
+            </a:pPr>
+            <a:r>
+              <a:rPr sz="975" b="1" i="0">
+                <a:solidFill>
+                  <a:srgbClr val="9D4E24"/>
+                </a:solidFill>
+                <a:latin typeface="Arial Narrow"/>
+                <a:ea typeface="Arial Narrow"/>
+                <a:cs typeface="Arial Narrow"/>
+              </a:rPr>
+              <a:t>DOCUMENTATION FOR FINANCE + ESG</a:t>
+            </a:r>
+          </a:p>
+        </p:txBody>
+      </p:sp>
+      <p:sp>
+        <p:nvSpPr>
+          <p:cNvPr id="420" name=""/>
+          <p:cNvSpPr>
+            <a:spLocks noGrp="1"/>
+          </p:cNvSpPr>
+          <p:nvPr/>
+        </p:nvSpPr>
+        <p:spPr>
+          <a:xfrm>
+            <a:off x="6120130" y="2894035"/>
+            <a:ext cx="91440" cy="91440"/>
+          </a:xfrm>
+          <a:prstGeom prst="rect">
+            <a:avLst/>
+          </a:prstGeom>
+          <a:solidFill>
+            <a:srgbClr val="C9783E"/>
+          </a:solidFill>
+          <a:ln w="0">
+            <a:noFill/>
+            <a:prstDash val="solid"/>
+          </a:ln>
+        </p:spPr>
+      </p:sp>
+      <p:sp>
+        <p:nvSpPr>
+          <p:cNvPr id="421" name=""/>
+          <p:cNvSpPr>
+            <a:spLocks noGrp="1"/>
+          </p:cNvSpPr>
+          <p:nvPr/>
+        </p:nvSpPr>
+        <p:spPr>
+          <a:xfrm>
+            <a:off x="6348730" y="2835035"/>
+            <a:ext cx="5124132" cy="520000"/>
+          </a:xfrm>
+          <a:prstGeom prst="rect">
+            <a:avLst/>
+          </a:prstGeom>
+          <a:noFill/>
+          <a:ln w="0">
+            <a:noFill/>
+            <a:prstDash val="solid"/>
+          </a:ln>
+        </p:spPr>
+        <p:txBody>
+          <a:bodyPr wrap="square" lIns="0" tIns="0" rIns="0" bIns="0" anchor="t">
+            <a:normAutofit fontScale="100000"/>
+          </a:bodyPr>
+          <a:lstStyle/>
+          <a:p>
+            <a:pPr algn="l">
+              <a:lnSpc>
+                <a:spcPct val="104000"/>
+              </a:lnSpc>
+              <a:buNone/>
+            </a:pPr>
+            <a:r>
+              <a:rPr sz="1050" b="0" i="0">
+                <a:solidFill>
+                  <a:srgbClr val="6A6F73"/>
+                </a:solidFill>
+                <a:latin typeface="Arial"/>
+                <a:ea typeface="Arial"/>
+                <a:cs typeface="Arial"/>
+              </a:rPr>
+              <a:t>Transparent BOMs and cost-allocation records supporting asset classification and depreciation — tax treatment confirmed per project</a:t>
+            </a:r>
+          </a:p>
+        </p:txBody>
+      </p:sp>
+      <p:sp>
+        <p:nvSpPr>
+          <p:cNvPr id="422" name=""/>
+          <p:cNvSpPr>
+            <a:spLocks noGrp="1"/>
+          </p:cNvSpPr>
+          <p:nvPr/>
+        </p:nvSpPr>
+        <p:spPr>
+          <a:xfrm>
+            <a:off x="6120130" y="3488395"/>
+            <a:ext cx="91440" cy="91440"/>
+          </a:xfrm>
+          <a:prstGeom prst="rect">
+            <a:avLst/>
+          </a:prstGeom>
+          <a:solidFill>
+            <a:srgbClr val="C9783E"/>
+          </a:solidFill>
+          <a:ln w="0">
+            <a:noFill/>
+            <a:prstDash val="solid"/>
+          </a:ln>
+        </p:spPr>
+      </p:sp>
+      <p:sp>
+        <p:nvSpPr>
+          <p:cNvPr id="423" name=""/>
+          <p:cNvSpPr>
+            <a:spLocks noGrp="1"/>
+          </p:cNvSpPr>
+          <p:nvPr/>
+        </p:nvSpPr>
+        <p:spPr>
+          <a:xfrm>
+            <a:off x="6348730" y="3429395"/>
+            <a:ext cx="5124132" cy="520000"/>
+          </a:xfrm>
+          <a:prstGeom prst="rect">
+            <a:avLst/>
+          </a:prstGeom>
+          <a:noFill/>
+          <a:ln w="0">
+            <a:noFill/>
+            <a:prstDash val="solid"/>
+          </a:ln>
+        </p:spPr>
+        <p:txBody>
+          <a:bodyPr wrap="square" lIns="0" tIns="0" rIns="0" bIns="0" anchor="t">
+            <a:normAutofit fontScale="100000"/>
+          </a:bodyPr>
+          <a:lstStyle/>
+          <a:p>
+            <a:pPr algn="l">
+              <a:lnSpc>
+                <a:spcPct val="104000"/>
+              </a:lnSpc>
+              <a:buNone/>
+            </a:pPr>
+            <a:r>
+              <a:rPr sz="1050" b="0" i="0">
+                <a:solidFill>
+                  <a:srgbClr val="6A6F73"/>
+                </a:solidFill>
+                <a:latin typeface="Arial"/>
+                <a:ea typeface="Arial"/>
+                <a:cs typeface="Arial"/>
+              </a:rPr>
+              <a:t>Verified EPDs for low-embodied-carbon procurement</a:t>
+            </a:r>
+          </a:p>
+        </p:txBody>
+      </p:sp>
+      <p:sp>
+        <p:nvSpPr>
+          <p:cNvPr id="424" name=""/>
+          <p:cNvSpPr>
+            <a:spLocks noGrp="1"/>
+          </p:cNvSpPr>
+          <p:nvPr/>
+        </p:nvSpPr>
+        <p:spPr>
+          <a:xfrm>
+            <a:off x="6120130" y="4082755"/>
+            <a:ext cx="91440" cy="91440"/>
+          </a:xfrm>
+          <a:prstGeom prst="rect">
+            <a:avLst/>
+          </a:prstGeom>
+          <a:solidFill>
+            <a:srgbClr val="C9783E"/>
+          </a:solidFill>
+          <a:ln w="0">
+            <a:noFill/>
+            <a:prstDash val="solid"/>
+          </a:ln>
+        </p:spPr>
+      </p:sp>
+      <p:sp>
+        <p:nvSpPr>
+          <p:cNvPr id="425" name=""/>
+          <p:cNvSpPr>
+            <a:spLocks noGrp="1"/>
+          </p:cNvSpPr>
+          <p:nvPr/>
+        </p:nvSpPr>
+        <p:spPr>
+          <a:xfrm>
+            <a:off x="6348730" y="4023755"/>
+            <a:ext cx="5124132" cy="520000"/>
+          </a:xfrm>
+          <a:prstGeom prst="rect">
+            <a:avLst/>
+          </a:prstGeom>
+          <a:noFill/>
+          <a:ln w="0">
+            <a:noFill/>
+            <a:prstDash val="solid"/>
+          </a:ln>
+        </p:spPr>
+        <p:txBody>
+          <a:bodyPr wrap="square" lIns="0" tIns="0" rIns="0" bIns="0" anchor="t">
+            <a:normAutofit fontScale="100000"/>
+          </a:bodyPr>
+          <a:lstStyle/>
+          <a:p>
+            <a:pPr algn="l">
+              <a:lnSpc>
+                <a:spcPct val="104000"/>
+              </a:lnSpc>
+              <a:buNone/>
+            </a:pPr>
+            <a:r>
+              <a:rPr sz="1050" b="0" i="0">
+                <a:solidFill>
+                  <a:srgbClr val="6A6F73"/>
+                </a:solidFill>
+                <a:latin typeface="Arial"/>
+                <a:ea typeface="Arial"/>
+                <a:cs typeface="Arial"/>
+              </a:rPr>
+              <a:t>Scope 3 cradle-to-gate carbon data for ESG-linked financing and hyperscaler offtaker requirements</a:t>
+            </a:r>
+          </a:p>
+        </p:txBody>
+      </p:sp>
+      <p:sp>
+        <p:nvSpPr>
+          <p:cNvPr id="426" name=""/>
+          <p:cNvSpPr>
+            <a:spLocks noGrp="1"/>
+          </p:cNvSpPr>
+          <p:nvPr/>
+        </p:nvSpPr>
+        <p:spPr>
+          <a:xfrm>
+            <a:off x="6120130" y="4677115"/>
+            <a:ext cx="91440" cy="91440"/>
+          </a:xfrm>
+          <a:prstGeom prst="rect">
+            <a:avLst/>
+          </a:prstGeom>
+          <a:solidFill>
+            <a:srgbClr val="C9783E"/>
+          </a:solidFill>
+          <a:ln w="0">
+            <a:noFill/>
+            <a:prstDash val="solid"/>
+          </a:ln>
+        </p:spPr>
+      </p:sp>
+      <p:sp>
+        <p:nvSpPr>
+          <p:cNvPr id="427" name=""/>
+          <p:cNvSpPr>
+            <a:spLocks noGrp="1"/>
+          </p:cNvSpPr>
+          <p:nvPr/>
+        </p:nvSpPr>
+        <p:spPr>
+          <a:xfrm>
+            <a:off x="6348730" y="4618115"/>
+            <a:ext cx="5124132" cy="520000"/>
+          </a:xfrm>
+          <a:prstGeom prst="rect">
+            <a:avLst/>
+          </a:prstGeom>
+          <a:noFill/>
+          <a:ln w="0">
+            <a:noFill/>
+            <a:prstDash val="solid"/>
+          </a:ln>
+        </p:spPr>
+        <p:txBody>
+          <a:bodyPr wrap="square" lIns="0" tIns="0" rIns="0" bIns="0" anchor="t">
+            <a:normAutofit fontScale="100000"/>
+          </a:bodyPr>
+          <a:lstStyle/>
+          <a:p>
+            <a:pPr algn="l">
+              <a:lnSpc>
+                <a:spcPct val="104000"/>
+              </a:lnSpc>
+              <a:buNone/>
+            </a:pPr>
+            <a:r>
+              <a:rPr sz="1050" b="0" i="0">
+                <a:solidFill>
+                  <a:srgbClr val="6A6F73"/>
+                </a:solidFill>
+                <a:latin typeface="Arial"/>
+                <a:ea typeface="Arial"/>
+                <a:cs typeface="Arial"/>
+              </a:rPr>
+              <a:t>Recycled-content integration and optimized logistics (circular economy)</a:t>
+            </a:r>
+          </a:p>
+        </p:txBody>
+      </p:sp>
+      <p:sp>
+        <p:nvSpPr>
+          <p:cNvPr id="428" name=""/>
+          <p:cNvSpPr>
+            <a:spLocks noGrp="1"/>
+          </p:cNvSpPr>
+          <p:nvPr/>
+        </p:nvSpPr>
+        <p:spPr>
+          <a:xfrm>
+            <a:off x="6120130" y="5271475"/>
+            <a:ext cx="91440" cy="91440"/>
+          </a:xfrm>
+          <a:prstGeom prst="rect">
+            <a:avLst/>
+          </a:prstGeom>
+          <a:solidFill>
+            <a:srgbClr val="C9783E"/>
+          </a:solidFill>
+          <a:ln w="0">
+            <a:noFill/>
+            <a:prstDash val="solid"/>
+          </a:ln>
+        </p:spPr>
+      </p:sp>
+      <p:sp>
+        <p:nvSpPr>
+          <p:cNvPr id="429" name=""/>
+          <p:cNvSpPr>
+            <a:spLocks noGrp="1"/>
+          </p:cNvSpPr>
+          <p:nvPr/>
+        </p:nvSpPr>
+        <p:spPr>
+          <a:xfrm>
+            <a:off x="6348730" y="5212475"/>
+            <a:ext cx="5124132" cy="520000"/>
+          </a:xfrm>
+          <a:prstGeom prst="rect">
+            <a:avLst/>
+          </a:prstGeom>
+          <a:noFill/>
+          <a:ln w="0">
+            <a:noFill/>
+            <a:prstDash val="solid"/>
+          </a:ln>
+        </p:spPr>
+        <p:txBody>
+          <a:bodyPr wrap="square" lIns="0" tIns="0" rIns="0" bIns="0" anchor="t">
+            <a:normAutofit fontScale="100000"/>
+          </a:bodyPr>
+          <a:lstStyle/>
+          <a:p>
+            <a:pPr algn="l">
+              <a:lnSpc>
+                <a:spcPct val="104000"/>
+              </a:lnSpc>
+              <a:buNone/>
+            </a:pPr>
+            <a:r>
+              <a:rPr sz="1050" b="0" i="0">
+                <a:solidFill>
+                  <a:srgbClr val="6A6F73"/>
+                </a:solidFill>
+                <a:latin typeface="Arial"/>
+                <a:ea typeface="Arial"/>
+                <a:cs typeface="Arial"/>
+              </a:rPr>
+              <a:t>Auditable domestic-content documentation for TEF and investor reporting</a:t>
+            </a:r>
+          </a:p>
+        </p:txBody>
+      </p:sp>
+      <p:sp>
+        <p:nvSpPr>
+          <p:cNvPr id="430" name=""/>
+          <p:cNvSpPr>
+            <a:spLocks noGrp="1"/>
+          </p:cNvSpPr>
+          <p:nvPr/>
+        </p:nvSpPr>
+        <p:spPr>
+          <a:xfrm>
+            <a:off x="719138" y="6032500"/>
+            <a:ext cx="10753724" cy="200000"/>
+          </a:xfrm>
+          <a:prstGeom prst="rect">
+            <a:avLst/>
+          </a:prstGeom>
+          <a:noFill/>
+          <a:ln w="0">
+            <a:noFill/>
+            <a:prstDash val="solid"/>
+          </a:ln>
+        </p:spPr>
+        <p:txBody>
+          <a:bodyPr wrap="square" lIns="0" tIns="0" rIns="0" bIns="0" anchor="t">
+            <a:normAutofit fontScale="100000"/>
+          </a:bodyPr>
+          <a:lstStyle/>
+          <a:p>
+            <a:pPr algn="l">
+              <a:lnSpc>
+                <a:spcPct val="100000"/>
+              </a:lnSpc>
+              <a:buNone/>
+            </a:pPr>
+            <a:r>
+              <a:rPr sz="825" b="0" i="1">
+                <a:solidFill>
+                  <a:srgbClr val="6A6F73"/>
+                </a:solidFill>
+                <a:latin typeface="Arial"/>
+                <a:ea typeface="Arial"/>
+                <a:cs typeface="Arial"/>
+              </a:rPr>
+              <a:t>Conceptual commercial positioning — offerings, documentation and tax applicability are scoped and confirmed per project.</a:t>
+            </a:r>
+          </a:p>
+        </p:txBody>
+      </p:sp>
+      <p:sp>
+        <p:nvSpPr>
+          <p:cNvPr id="431" name=""/>
+          <p:cNvSpPr>
+            <a:spLocks noGrp="1"/>
+          </p:cNvSpPr>
+          <p:nvPr/>
+        </p:nvSpPr>
+        <p:spPr>
+          <a:xfrm>
+            <a:off x="719138" y="6315000"/>
+            <a:ext cx="10753724" cy="400000"/>
+          </a:xfrm>
+          <a:prstGeom prst="rect">
+            <a:avLst/>
+          </a:prstGeom>
+          <a:solidFill>
+            <a:srgbClr val="17191C"/>
+          </a:solidFill>
+          <a:ln w="0">
+            <a:noFill/>
+            <a:prstDash val="solid"/>
+          </a:ln>
+        </p:spPr>
+      </p:sp>
+      <p:sp>
+        <p:nvSpPr>
+          <p:cNvPr id="432" name=""/>
+          <p:cNvSpPr>
+            <a:spLocks noGrp="1"/>
+          </p:cNvSpPr>
+          <p:nvPr/>
+        </p:nvSpPr>
+        <p:spPr>
+          <a:xfrm>
+            <a:off x="719138" y="6315000"/>
+            <a:ext cx="10753724" cy="400000"/>
+          </a:xfrm>
+          <a:prstGeom prst="rect">
+            <a:avLst/>
+          </a:prstGeom>
+          <a:noFill/>
+          <a:ln w="0">
+            <a:noFill/>
+            <a:prstDash val="solid"/>
+          </a:ln>
+        </p:spPr>
+        <p:txBody>
+          <a:bodyPr wrap="square" lIns="0" tIns="0" rIns="0" bIns="0" anchor="ctr">
+            <a:normAutofit fontScale="100000"/>
+          </a:bodyPr>
+          <a:lstStyle/>
+          <a:p>
+            <a:pPr algn="ctr">
+              <a:lnSpc>
+                <a:spcPct val="100000"/>
+              </a:lnSpc>
+              <a:buNone/>
+            </a:pPr>
+            <a:r>
+              <a:rPr sz="1050" b="1" i="0">
+                <a:solidFill>
+                  <a:srgbClr val="FFFFFF"/>
+                </a:solidFill>
+                <a:latin typeface="Arial Narrow"/>
+                <a:ea typeface="Arial Narrow"/>
+                <a:cs typeface="Arial Narrow"/>
+              </a:rPr>
+              <a:t>COST, SCHEDULE, SOURCING AND CARBON VISIBILITY — BEFORE THE EPC BID PRICES THE UNCERTAINTY AS CONTINGENCY.</a:t>
+            </a:r>
+          </a:p>
+        </p:txBody>
+      </p:sp>
+    </p:spTree>
+  </p:cSld>
+</p:sld>
+</file>
+
 <file path=ppt/slides/slide2.xml><?xml version="1.0" encoding="utf-8"?>
 <p:sld xmlns:p="http://schemas.openxmlformats.org/presentationml/2006/main">
   <p:cSld>

</xml_diff>

<commit_message>
Add Cable Platform (A11) and Operating Fleet (A12) appendices
A11 consolidates the IPP Cable Catalogue and Packaged Power e-Catalogue
into a product-ladder index page; A12 carries the rejuvenation/brownfield
service offering aimed at the acquired fleet. ECatalog content duplicating
A10 not re-added; NGCC financing briefing kept internal by design.

Co-Authored-By: Claude Fable 5 <noreply@anthropic.com>
Claude-Session: https://claude.ai/code/session_01DUeyPCeDvcPsyTcH6oQXEK
</commit_message>
<xml_diff>
--- a/teaser-rework/Southwire_NRG_Protecting_Time_to_Power_Rev10.pptx
+++ b/teaser-rework/Southwire_NRG_Protecting_Time_to_Power_Rev10.pptx
@@ -27,6 +27,8 @@
     <p:sldId id="272" r:id="rId3"/>
     <p:sldId id="273" r:id="rId4"/>
     <p:sldId id="274" r:id="rId5"/>
+    <p:sldId id="275" r:id="rId6"/>
+    <p:sldId id="276" r:id="rId7"/>
   </p:sldIdLst>
   <p:sldSz cx="12192000" cy="6858000"/>
   <p:notesSz cx="6858000" cy="9144000"/>
@@ -16128,6 +16130,2616 @@
 </p:sld>
 </file>
 
+<file path=ppt/slides/slide20.xml><?xml version="1.0" encoding="utf-8"?>
+<p:sld xmlns:p="http://schemas.openxmlformats.org/presentationml/2006/main" xmlns:a="http://schemas.openxmlformats.org/drawingml/2006/main" xmlns:r="http://schemas.openxmlformats.org/officeDocument/2006/relationships">
+  <p:cSld>
+    <p:bg>
+      <p:bgPr>
+        <a:solidFill>
+          <a:srgbClr val="F6F3EE"/>
+        </a:solidFill>
+      </p:bgPr>
+    </p:bg>
+    <p:spTree>
+      <p:nvGrpSpPr>
+        <p:cNvPr id="1" name=""/>
+        <p:cNvGrpSpPr/>
+        <p:nvPr/>
+      </p:nvGrpSpPr>
+      <p:grpSpPr>
+        <a:xfrm/>
+      </p:grpSpPr>
+      <p:sp>
+        <p:nvSpPr>
+          <p:cNvPr id="501" name=""/>
+          <p:cNvSpPr>
+            <a:spLocks noGrp="1"/>
+          </p:cNvSpPr>
+          <p:nvPr/>
+        </p:nvSpPr>
+        <p:spPr>
+          <a:xfrm>
+            <a:off x="0" y="0"/>
+            <a:ext cx="12192000" cy="57150"/>
+          </a:xfrm>
+          <a:prstGeom prst="rect">
+            <a:avLst/>
+          </a:prstGeom>
+          <a:solidFill>
+            <a:srgbClr val="C9783E"/>
+          </a:solidFill>
+          <a:ln w="0">
+            <a:noFill/>
+            <a:prstDash val="solid"/>
+          </a:ln>
+        </p:spPr>
+      </p:sp>
+      <p:pic>
+        <p:nvPicPr>
+          <p:cNvPr id="502" name=""/>
+          <p:cNvPicPr>
+            <a:picLocks noChangeAspect="1"/>
+          </p:cNvPicPr>
+          <p:nvPr/>
+        </p:nvPicPr>
+        <p:blipFill>
+          <a:blip r:embed="R48e2a3d3733b4264"/>
+          <a:stretch/>
+        </p:blipFill>
+        <p:spPr>
+          <a:xfrm>
+            <a:off x="719138" y="200025"/>
+            <a:ext cx="2066925" cy="590550"/>
+          </a:xfrm>
+          <a:prstGeom prst="rect">
+            <a:avLst/>
+          </a:prstGeom>
+        </p:spPr>
+      </p:pic>
+      <p:sp>
+        <p:nvSpPr>
+          <p:cNvPr id="503" name=""/>
+          <p:cNvSpPr>
+            <a:spLocks noGrp="1"/>
+          </p:cNvSpPr>
+          <p:nvPr/>
+        </p:nvSpPr>
+        <p:spPr>
+          <a:xfrm>
+            <a:off x="7325360" y="323850"/>
+            <a:ext cx="3857000" cy="228600"/>
+          </a:xfrm>
+          <a:prstGeom prst="rect">
+            <a:avLst/>
+          </a:prstGeom>
+          <a:noFill/>
+          <a:ln w="0">
+            <a:noFill/>
+            <a:prstDash val="solid"/>
+          </a:ln>
+        </p:spPr>
+        <p:txBody>
+          <a:bodyPr wrap="square" lIns="0" tIns="0" rIns="0" bIns="0" anchor="t">
+            <a:normAutofit fontScale="100000"/>
+          </a:bodyPr>
+          <a:lstStyle/>
+          <a:p>
+            <a:pPr algn="r">
+              <a:lnSpc>
+                <a:spcPct val="100000"/>
+              </a:lnSpc>
+              <a:buNone/>
+            </a:pPr>
+            <a:r>
+              <a:rPr sz="975" b="1" i="0">
+                <a:solidFill>
+                  <a:srgbClr val="9D4E24"/>
+                </a:solidFill>
+                <a:latin typeface="Arial Narrow"/>
+                <a:ea typeface="Arial Narrow"/>
+                <a:cs typeface="Arial Narrow"/>
+              </a:rPr>
+              <a:t>APPENDIX A11 · CABLE PLATFORM</a:t>
+            </a:r>
+          </a:p>
+        </p:txBody>
+      </p:sp>
+      <p:sp>
+        <p:nvSpPr>
+          <p:cNvPr id="504" name=""/>
+          <p:cNvSpPr>
+            <a:spLocks noGrp="1"/>
+          </p:cNvSpPr>
+          <p:nvPr/>
+        </p:nvSpPr>
+        <p:spPr>
+          <a:xfrm>
+            <a:off x="11334750" y="323850"/>
+            <a:ext cx="323850" cy="228600"/>
+          </a:xfrm>
+          <a:prstGeom prst="rect">
+            <a:avLst/>
+          </a:prstGeom>
+          <a:noFill/>
+          <a:ln w="0">
+            <a:noFill/>
+            <a:prstDash val="solid"/>
+          </a:ln>
+        </p:spPr>
+        <p:txBody>
+          <a:bodyPr wrap="square" lIns="0" tIns="0" rIns="0" bIns="0" anchor="t">
+            <a:normAutofit fontScale="100000"/>
+          </a:bodyPr>
+          <a:lstStyle/>
+          <a:p>
+            <a:pPr algn="r">
+              <a:lnSpc>
+                <a:spcPct val="100000"/>
+              </a:lnSpc>
+              <a:buNone/>
+            </a:pPr>
+            <a:r>
+              <a:rPr sz="975" b="1" i="0">
+                <a:solidFill>
+                  <a:srgbClr val="8B9094"/>
+                </a:solidFill>
+                <a:latin typeface="Arial Narrow"/>
+                <a:ea typeface="Arial Narrow"/>
+                <a:cs typeface="Arial Narrow"/>
+              </a:rPr>
+              <a:t>20</a:t>
+            </a:r>
+          </a:p>
+        </p:txBody>
+      </p:sp>
+      <p:sp>
+        <p:nvSpPr>
+          <p:cNvPr id="505" name=""/>
+          <p:cNvSpPr>
+            <a:spLocks noGrp="1"/>
+          </p:cNvSpPr>
+          <p:nvPr/>
+        </p:nvSpPr>
+        <p:spPr>
+          <a:xfrm>
+            <a:off x="719138" y="1005840"/>
+            <a:ext cx="9000000" cy="228600"/>
+          </a:xfrm>
+          <a:prstGeom prst="rect">
+            <a:avLst/>
+          </a:prstGeom>
+          <a:noFill/>
+          <a:ln w="0">
+            <a:noFill/>
+            <a:prstDash val="solid"/>
+          </a:ln>
+        </p:spPr>
+        <p:txBody>
+          <a:bodyPr wrap="square" lIns="0" tIns="0" rIns="0" bIns="0" anchor="t">
+            <a:normAutofit fontScale="100000"/>
+          </a:bodyPr>
+          <a:lstStyle/>
+          <a:p>
+            <a:pPr algn="l">
+              <a:lnSpc>
+                <a:spcPct val="100000"/>
+              </a:lnSpc>
+              <a:buNone/>
+            </a:pPr>
+            <a:r>
+              <a:rPr sz="1050" b="1" i="0">
+                <a:solidFill>
+                  <a:srgbClr val="C9783E"/>
+                </a:solidFill>
+                <a:latin typeface="Arial Narrow"/>
+                <a:ea typeface="Arial Narrow"/>
+                <a:cs typeface="Arial Narrow"/>
+              </a:rPr>
+              <a:t>ONE PLATFORM — PLANT SCOPE AND PACKAGED SCOPE</a:t>
+            </a:r>
+          </a:p>
+        </p:txBody>
+      </p:sp>
+      <p:sp>
+        <p:nvSpPr>
+          <p:cNvPr id="506" name=""/>
+          <p:cNvSpPr>
+            <a:spLocks noGrp="1"/>
+          </p:cNvSpPr>
+          <p:nvPr/>
+        </p:nvSpPr>
+        <p:spPr>
+          <a:xfrm>
+            <a:off x="719138" y="1280160"/>
+            <a:ext cx="10753724" cy="500000"/>
+          </a:xfrm>
+          <a:prstGeom prst="rect">
+            <a:avLst/>
+          </a:prstGeom>
+          <a:noFill/>
+          <a:ln w="0">
+            <a:noFill/>
+            <a:prstDash val="solid"/>
+          </a:ln>
+        </p:spPr>
+        <p:txBody>
+          <a:bodyPr wrap="square" lIns="0" tIns="0" rIns="0" bIns="0" anchor="t">
+            <a:normAutofit fontScale="100000"/>
+          </a:bodyPr>
+          <a:lstStyle/>
+          <a:p>
+            <a:pPr algn="l">
+              <a:lnSpc>
+                <a:spcPct val="104000"/>
+              </a:lnSpc>
+              <a:buNone/>
+            </a:pPr>
+            <a:r>
+              <a:rPr sz="2850" b="1" i="0">
+                <a:solidFill>
+                  <a:srgbClr val="17191C"/>
+                </a:solidFill>
+                <a:latin typeface="Arial"/>
+                <a:ea typeface="Arial"/>
+                <a:cs typeface="Arial"/>
+              </a:rPr>
+              <a:t>One platform from generator to grid — and inside every package.</a:t>
+            </a:r>
+          </a:p>
+        </p:txBody>
+      </p:sp>
+      <p:sp>
+        <p:nvSpPr>
+          <p:cNvPr id="507" name=""/>
+          <p:cNvSpPr>
+            <a:spLocks noGrp="1"/>
+          </p:cNvSpPr>
+          <p:nvPr/>
+        </p:nvSpPr>
+        <p:spPr>
+          <a:xfrm>
+            <a:off x="719138" y="1950720"/>
+            <a:ext cx="10753724" cy="300000"/>
+          </a:xfrm>
+          <a:prstGeom prst="rect">
+            <a:avLst/>
+          </a:prstGeom>
+          <a:noFill/>
+          <a:ln w="0">
+            <a:noFill/>
+            <a:prstDash val="solid"/>
+          </a:ln>
+        </p:spPr>
+        <p:txBody>
+          <a:bodyPr wrap="square" lIns="0" tIns="0" rIns="0" bIns="0" anchor="t">
+            <a:normAutofit fontScale="100000"/>
+          </a:bodyPr>
+          <a:lstStyle/>
+          <a:p>
+            <a:pPr algn="l">
+              <a:lnSpc>
+                <a:spcPct val="108000"/>
+              </a:lnSpc>
+              <a:buNone/>
+            </a:pPr>
+            <a:r>
+              <a:rPr sz="1050" b="0" i="0">
+                <a:solidFill>
+                  <a:srgbClr val="6A6F73"/>
+                </a:solidFill>
+                <a:latin typeface="Arial"/>
+                <a:ea typeface="Arial"/>
+                <a:cs typeface="Arial"/>
+              </a:rPr>
+              <a:t>Every run in the A3 zone map resolves to a named product family — one supplier, one spec basis, domestic manufacture.</a:t>
+            </a:r>
+          </a:p>
+        </p:txBody>
+      </p:sp>
+      <p:sp>
+        <p:nvSpPr>
+          <p:cNvPr id="508" name=""/>
+          <p:cNvSpPr>
+            <a:spLocks noGrp="1"/>
+          </p:cNvSpPr>
+          <p:nvPr/>
+        </p:nvSpPr>
+        <p:spPr>
+          <a:xfrm>
+            <a:off x="719138" y="2515235"/>
+            <a:ext cx="4900000" cy="228600"/>
+          </a:xfrm>
+          <a:prstGeom prst="rect">
+            <a:avLst/>
+          </a:prstGeom>
+          <a:noFill/>
+          <a:ln w="0">
+            <a:noFill/>
+            <a:prstDash val="solid"/>
+          </a:ln>
+        </p:spPr>
+        <p:txBody>
+          <a:bodyPr wrap="square" lIns="0" tIns="0" rIns="0" bIns="0" anchor="t">
+            <a:normAutofit fontScale="100000"/>
+          </a:bodyPr>
+          <a:lstStyle/>
+          <a:p>
+            <a:pPr algn="l">
+              <a:lnSpc>
+                <a:spcPct val="100000"/>
+              </a:lnSpc>
+              <a:buNone/>
+            </a:pPr>
+            <a:r>
+              <a:rPr sz="975" b="1" i="0">
+                <a:solidFill>
+                  <a:srgbClr val="9D4E24"/>
+                </a:solidFill>
+                <a:latin typeface="Arial Narrow"/>
+                <a:ea typeface="Arial Narrow"/>
+                <a:cs typeface="Arial Narrow"/>
+              </a:rPr>
+              <a:t>PLANT SCOPE — GENERATOR TO GRID</a:t>
+            </a:r>
+          </a:p>
+        </p:txBody>
+      </p:sp>
+      <p:sp>
+        <p:nvSpPr>
+          <p:cNvPr id="509" name=""/>
+          <p:cNvSpPr>
+            <a:spLocks noGrp="1"/>
+          </p:cNvSpPr>
+          <p:nvPr/>
+        </p:nvSpPr>
+        <p:spPr>
+          <a:xfrm>
+            <a:off x="719138" y="2835035"/>
+            <a:ext cx="4900000" cy="228600"/>
+          </a:xfrm>
+          <a:prstGeom prst="rect">
+            <a:avLst/>
+          </a:prstGeom>
+          <a:noFill/>
+          <a:ln w="0">
+            <a:noFill/>
+            <a:prstDash val="solid"/>
+          </a:ln>
+        </p:spPr>
+        <p:txBody>
+          <a:bodyPr wrap="square" lIns="0" tIns="0" rIns="0" bIns="0" anchor="t">
+            <a:normAutofit fontScale="100000"/>
+          </a:bodyPr>
+          <a:lstStyle/>
+          <a:p>
+            <a:pPr algn="l">
+              <a:lnSpc>
+                <a:spcPct val="100000"/>
+              </a:lnSpc>
+              <a:buNone/>
+            </a:pPr>
+            <a:r>
+              <a:rPr sz="1050" b="1" i="0">
+                <a:solidFill>
+                  <a:srgbClr val="9D4E24"/>
+                </a:solidFill>
+                <a:latin typeface="Arial Narrow"/>
+                <a:ea typeface="Arial Narrow"/>
+                <a:cs typeface="Arial Narrow"/>
+              </a:rPr>
+              <a:t>HVUD HIGH-VOLTAGE UNDERGROUND · 69–400 kV</a:t>
+            </a:r>
+          </a:p>
+        </p:txBody>
+      </p:sp>
+      <p:sp>
+        <p:nvSpPr>
+          <p:cNvPr id="510" name=""/>
+          <p:cNvSpPr>
+            <a:spLocks noGrp="1"/>
+          </p:cNvSpPr>
+          <p:nvPr/>
+        </p:nvSpPr>
+        <p:spPr>
+          <a:xfrm>
+            <a:off x="719138" y="3063635"/>
+            <a:ext cx="4900000" cy="430000"/>
+          </a:xfrm>
+          <a:prstGeom prst="rect">
+            <a:avLst/>
+          </a:prstGeom>
+          <a:noFill/>
+          <a:ln w="0">
+            <a:noFill/>
+            <a:prstDash val="solid"/>
+          </a:ln>
+        </p:spPr>
+        <p:txBody>
+          <a:bodyPr wrap="square" lIns="0" tIns="0" rIns="0" bIns="0" anchor="t">
+            <a:normAutofit fontScale="100000"/>
+          </a:bodyPr>
+          <a:lstStyle/>
+          <a:p>
+            <a:pPr algn="l">
+              <a:lnSpc>
+                <a:spcPct val="105000"/>
+              </a:lnSpc>
+              <a:buNone/>
+            </a:pPr>
+            <a:r>
+              <a:rPr sz="975" b="0" i="0">
+                <a:solidFill>
+                  <a:srgbClr val="6A6F73"/>
+                </a:solidFill>
+                <a:latin typeface="Arial"/>
+                <a:ea typeface="Arial"/>
+                <a:cs typeface="Arial"/>
+              </a:rPr>
+              <a:t>XLPE underground interconnect; HVUD3 (138 kV) and HVUD4 (230 kV) carry gen-tie, behind-the-meter and bulk interconnect duty.</a:t>
+            </a:r>
+          </a:p>
+        </p:txBody>
+      </p:sp>
+      <p:sp>
+        <p:nvSpPr>
+          <p:cNvPr id="511" name=""/>
+          <p:cNvSpPr>
+            <a:spLocks noGrp="1"/>
+          </p:cNvSpPr>
+          <p:nvPr/>
+        </p:nvSpPr>
+        <p:spPr>
+          <a:xfrm>
+            <a:off x="719138" y="3520835"/>
+            <a:ext cx="4900000" cy="228600"/>
+          </a:xfrm>
+          <a:prstGeom prst="rect">
+            <a:avLst/>
+          </a:prstGeom>
+          <a:noFill/>
+          <a:ln w="0">
+            <a:noFill/>
+            <a:prstDash val="solid"/>
+          </a:ln>
+        </p:spPr>
+        <p:txBody>
+          <a:bodyPr wrap="square" lIns="0" tIns="0" rIns="0" bIns="0" anchor="t">
+            <a:normAutofit fontScale="100000"/>
+          </a:bodyPr>
+          <a:lstStyle/>
+          <a:p>
+            <a:pPr algn="l">
+              <a:lnSpc>
+                <a:spcPct val="100000"/>
+              </a:lnSpc>
+              <a:buNone/>
+            </a:pPr>
+            <a:r>
+              <a:rPr sz="1050" b="1" i="0">
+                <a:solidFill>
+                  <a:srgbClr val="9D4E24"/>
+                </a:solidFill>
+                <a:latin typeface="Arial Narrow"/>
+                <a:ea typeface="Arial Narrow"/>
+                <a:cs typeface="Arial Narrow"/>
+              </a:rPr>
+              <a:t>MV-105 · NL-EPR · 5–35 kV</a:t>
+            </a:r>
+          </a:p>
+        </p:txBody>
+      </p:sp>
+      <p:sp>
+        <p:nvSpPr>
+          <p:cNvPr id="512" name=""/>
+          <p:cNvSpPr>
+            <a:spLocks noGrp="1"/>
+          </p:cNvSpPr>
+          <p:nvPr/>
+        </p:nvSpPr>
+        <p:spPr>
+          <a:xfrm>
+            <a:off x="719138" y="3749435"/>
+            <a:ext cx="4900000" cy="430000"/>
+          </a:xfrm>
+          <a:prstGeom prst="rect">
+            <a:avLst/>
+          </a:prstGeom>
+          <a:noFill/>
+          <a:ln w="0">
+            <a:noFill/>
+            <a:prstDash val="solid"/>
+          </a:ln>
+        </p:spPr>
+        <p:txBody>
+          <a:bodyPr wrap="square" lIns="0" tIns="0" rIns="0" bIns="0" anchor="t">
+            <a:normAutofit fontScale="100000"/>
+          </a:bodyPr>
+          <a:lstStyle/>
+          <a:p>
+            <a:pPr algn="l">
+              <a:lnSpc>
+                <a:spcPct val="105000"/>
+              </a:lnSpc>
+              <a:buNone/>
+            </a:pPr>
+            <a:r>
+              <a:rPr sz="975" b="0" i="0">
+                <a:solidFill>
+                  <a:srgbClr val="6A6F73"/>
+                </a:solidFill>
+                <a:latin typeface="Arial"/>
+                <a:ea typeface="Arial"/>
+                <a:cs typeface="Arial"/>
+              </a:rPr>
+              <a:t>The plant collection and auxiliary backbone — 105°C rated, low-friction jacket, tray and duct-bank installation economics.</a:t>
+            </a:r>
+          </a:p>
+        </p:txBody>
+      </p:sp>
+      <p:sp>
+        <p:nvSpPr>
+          <p:cNvPr id="513" name=""/>
+          <p:cNvSpPr>
+            <a:spLocks noGrp="1"/>
+          </p:cNvSpPr>
+          <p:nvPr/>
+        </p:nvSpPr>
+        <p:spPr>
+          <a:xfrm>
+            <a:off x="719138" y="4206635"/>
+            <a:ext cx="4900000" cy="228600"/>
+          </a:xfrm>
+          <a:prstGeom prst="rect">
+            <a:avLst/>
+          </a:prstGeom>
+          <a:noFill/>
+          <a:ln w="0">
+            <a:noFill/>
+            <a:prstDash val="solid"/>
+          </a:ln>
+        </p:spPr>
+        <p:txBody>
+          <a:bodyPr wrap="square" lIns="0" tIns="0" rIns="0" bIns="0" anchor="t">
+            <a:normAutofit fontScale="100000"/>
+          </a:bodyPr>
+          <a:lstStyle/>
+          <a:p>
+            <a:pPr algn="l">
+              <a:lnSpc>
+                <a:spcPct val="100000"/>
+              </a:lnSpc>
+              <a:buNone/>
+            </a:pPr>
+            <a:r>
+              <a:rPr sz="1050" b="1" i="0">
+                <a:solidFill>
+                  <a:srgbClr val="9D4E24"/>
+                </a:solidFill>
+                <a:latin typeface="Arial Narrow"/>
+                <a:ea typeface="Arial Narrow"/>
+                <a:cs typeface="Arial Narrow"/>
+              </a:rPr>
+              <a:t>LV 600 V POWER, CONTROL &amp; BUILDING WIRE</a:t>
+            </a:r>
+          </a:p>
+        </p:txBody>
+      </p:sp>
+      <p:sp>
+        <p:nvSpPr>
+          <p:cNvPr id="514" name=""/>
+          <p:cNvSpPr>
+            <a:spLocks noGrp="1"/>
+          </p:cNvSpPr>
+          <p:nvPr/>
+        </p:nvSpPr>
+        <p:spPr>
+          <a:xfrm>
+            <a:off x="719138" y="4435235"/>
+            <a:ext cx="4900000" cy="430000"/>
+          </a:xfrm>
+          <a:prstGeom prst="rect">
+            <a:avLst/>
+          </a:prstGeom>
+          <a:noFill/>
+          <a:ln w="0">
+            <a:noFill/>
+            <a:prstDash val="solid"/>
+          </a:ln>
+        </p:spPr>
+        <p:txBody>
+          <a:bodyPr wrap="square" lIns="0" tIns="0" rIns="0" bIns="0" anchor="t">
+            <a:normAutofit fontScale="100000"/>
+          </a:bodyPr>
+          <a:lstStyle/>
+          <a:p>
+            <a:pPr algn="l">
+              <a:lnSpc>
+                <a:spcPct val="105000"/>
+              </a:lnSpc>
+              <a:buNone/>
+            </a:pPr>
+            <a:r>
+              <a:rPr sz="975" b="0" i="0">
+                <a:solidFill>
+                  <a:srgbClr val="6A6F73"/>
+                </a:solidFill>
+                <a:latin typeface="Arial"/>
+                <a:ea typeface="Arial"/>
+                <a:cs typeface="Arial"/>
+              </a:rPr>
+              <a:t>Feeders, motor circuits and unit auxiliary distribution across the plant.</a:t>
+            </a:r>
+          </a:p>
+        </p:txBody>
+      </p:sp>
+      <p:sp>
+        <p:nvSpPr>
+          <p:cNvPr id="515" name=""/>
+          <p:cNvSpPr>
+            <a:spLocks noGrp="1"/>
+          </p:cNvSpPr>
+          <p:nvPr/>
+        </p:nvSpPr>
+        <p:spPr>
+          <a:xfrm>
+            <a:off x="719138" y="4892435"/>
+            <a:ext cx="4900000" cy="228600"/>
+          </a:xfrm>
+          <a:prstGeom prst="rect">
+            <a:avLst/>
+          </a:prstGeom>
+          <a:noFill/>
+          <a:ln w="0">
+            <a:noFill/>
+            <a:prstDash val="solid"/>
+          </a:ln>
+        </p:spPr>
+        <p:txBody>
+          <a:bodyPr wrap="square" lIns="0" tIns="0" rIns="0" bIns="0" anchor="t">
+            <a:normAutofit fontScale="100000"/>
+          </a:bodyPr>
+          <a:lstStyle/>
+          <a:p>
+            <a:pPr algn="l">
+              <a:lnSpc>
+                <a:spcPct val="100000"/>
+              </a:lnSpc>
+              <a:buNone/>
+            </a:pPr>
+            <a:r>
+              <a:rPr sz="1050" b="1" i="0">
+                <a:solidFill>
+                  <a:srgbClr val="9D4E24"/>
+                </a:solidFill>
+                <a:latin typeface="Arial Narrow"/>
+                <a:ea typeface="Arial Narrow"/>
+                <a:cs typeface="Arial Narrow"/>
+              </a:rPr>
+              <a:t>I&amp;C, COMMS &amp; TRANSMISSION CONDUCTOR</a:t>
+            </a:r>
+          </a:p>
+        </p:txBody>
+      </p:sp>
+      <p:sp>
+        <p:nvSpPr>
+          <p:cNvPr id="516" name=""/>
+          <p:cNvSpPr>
+            <a:spLocks noGrp="1"/>
+          </p:cNvSpPr>
+          <p:nvPr/>
+        </p:nvSpPr>
+        <p:spPr>
+          <a:xfrm>
+            <a:off x="719138" y="5121035"/>
+            <a:ext cx="4900000" cy="430000"/>
+          </a:xfrm>
+          <a:prstGeom prst="rect">
+            <a:avLst/>
+          </a:prstGeom>
+          <a:noFill/>
+          <a:ln w="0">
+            <a:noFill/>
+            <a:prstDash val="solid"/>
+          </a:ln>
+        </p:spPr>
+        <p:txBody>
+          <a:bodyPr wrap="square" lIns="0" tIns="0" rIns="0" bIns="0" anchor="t">
+            <a:normAutofit fontScale="100000"/>
+          </a:bodyPr>
+          <a:lstStyle/>
+          <a:p>
+            <a:pPr algn="l">
+              <a:lnSpc>
+                <a:spcPct val="105000"/>
+              </a:lnSpc>
+              <a:buNone/>
+            </a:pPr>
+            <a:r>
+              <a:rPr sz="975" b="0" i="0">
+                <a:solidFill>
+                  <a:srgbClr val="6A6F73"/>
+                </a:solidFill>
+                <a:latin typeface="Arial"/>
+                <a:ea typeface="Arial"/>
+                <a:cs typeface="Arial"/>
+              </a:rPr>
+              <a:t>DCS, protection and metering cable; industrial Ethernet and fiber; ACSR / ACSS / OPGW where overhead is the route.</a:t>
+            </a:r>
+          </a:p>
+        </p:txBody>
+      </p:sp>
+      <p:sp>
+        <p:nvSpPr>
+          <p:cNvPr id="517" name=""/>
+          <p:cNvSpPr>
+            <a:spLocks noGrp="1"/>
+          </p:cNvSpPr>
+          <p:nvPr/>
+        </p:nvSpPr>
+        <p:spPr>
+          <a:xfrm>
+            <a:off x="719138" y="5578235"/>
+            <a:ext cx="4900000" cy="228600"/>
+          </a:xfrm>
+          <a:prstGeom prst="rect">
+            <a:avLst/>
+          </a:prstGeom>
+          <a:noFill/>
+          <a:ln w="0">
+            <a:noFill/>
+            <a:prstDash val="solid"/>
+          </a:ln>
+        </p:spPr>
+        <p:txBody>
+          <a:bodyPr wrap="square" lIns="0" tIns="0" rIns="0" bIns="0" anchor="t">
+            <a:normAutofit fontScale="100000"/>
+          </a:bodyPr>
+          <a:lstStyle/>
+          <a:p>
+            <a:pPr algn="l">
+              <a:lnSpc>
+                <a:spcPct val="100000"/>
+              </a:lnSpc>
+              <a:buNone/>
+            </a:pPr>
+            <a:r>
+              <a:rPr sz="1050" b="1" i="0">
+                <a:solidFill>
+                  <a:srgbClr val="9D4E24"/>
+                </a:solidFill>
+                <a:latin typeface="Arial Narrow"/>
+                <a:ea typeface="Arial Narrow"/>
+                <a:cs typeface="Arial Narrow"/>
+              </a:rPr>
+              <a:t>GROUNDING &amp; BONDING</a:t>
+            </a:r>
+          </a:p>
+        </p:txBody>
+      </p:sp>
+      <p:sp>
+        <p:nvSpPr>
+          <p:cNvPr id="518" name=""/>
+          <p:cNvSpPr>
+            <a:spLocks noGrp="1"/>
+          </p:cNvSpPr>
+          <p:nvPr/>
+        </p:nvSpPr>
+        <p:spPr>
+          <a:xfrm>
+            <a:off x="719138" y="5806835"/>
+            <a:ext cx="4900000" cy="430000"/>
+          </a:xfrm>
+          <a:prstGeom prst="rect">
+            <a:avLst/>
+          </a:prstGeom>
+          <a:noFill/>
+          <a:ln w="0">
+            <a:noFill/>
+            <a:prstDash val="solid"/>
+          </a:ln>
+        </p:spPr>
+        <p:txBody>
+          <a:bodyPr wrap="square" lIns="0" tIns="0" rIns="0" bIns="0" anchor="t">
+            <a:normAutofit fontScale="100000"/>
+          </a:bodyPr>
+          <a:lstStyle/>
+          <a:p>
+            <a:pPr algn="l">
+              <a:lnSpc>
+                <a:spcPct val="105000"/>
+              </a:lnSpc>
+              <a:buNone/>
+            </a:pPr>
+            <a:r>
+              <a:rPr sz="975" b="0" i="0">
+                <a:solidFill>
+                  <a:srgbClr val="6A6F73"/>
+                </a:solidFill>
+                <a:latin typeface="Arial"/>
+                <a:ea typeface="Arial"/>
+                <a:cs typeface="Arial"/>
+              </a:rPr>
+              <a:t>Bare copper and bonding conductor — the grid that ties the whole electrical system to earth.</a:t>
+            </a:r>
+          </a:p>
+        </p:txBody>
+      </p:sp>
+      <p:sp>
+        <p:nvSpPr>
+          <p:cNvPr id="519" name=""/>
+          <p:cNvSpPr>
+            <a:spLocks noGrp="1"/>
+          </p:cNvSpPr>
+          <p:nvPr/>
+        </p:nvSpPr>
+        <p:spPr>
+          <a:xfrm>
+            <a:off x="6120130" y="2515235"/>
+            <a:ext cx="5352732" cy="228600"/>
+          </a:xfrm>
+          <a:prstGeom prst="rect">
+            <a:avLst/>
+          </a:prstGeom>
+          <a:noFill/>
+          <a:ln w="0">
+            <a:noFill/>
+            <a:prstDash val="solid"/>
+          </a:ln>
+        </p:spPr>
+        <p:txBody>
+          <a:bodyPr wrap="square" lIns="0" tIns="0" rIns="0" bIns="0" anchor="t">
+            <a:normAutofit fontScale="100000"/>
+          </a:bodyPr>
+          <a:lstStyle/>
+          <a:p>
+            <a:pPr algn="l">
+              <a:lnSpc>
+                <a:spcPct val="100000"/>
+              </a:lnSpc>
+              <a:buNone/>
+            </a:pPr>
+            <a:r>
+              <a:rPr sz="975" b="1" i="0">
+                <a:solidFill>
+                  <a:srgbClr val="9D4E24"/>
+                </a:solidFill>
+                <a:latin typeface="Arial Narrow"/>
+                <a:ea typeface="Arial Narrow"/>
+                <a:cs typeface="Arial Narrow"/>
+              </a:rPr>
+              <a:t>PACKAGED &amp; MODULAR SCOPE — 8 APPLICATION FAMILIES</a:t>
+            </a:r>
+          </a:p>
+        </p:txBody>
+      </p:sp>
+      <p:sp>
+        <p:nvSpPr>
+          <p:cNvPr id="520" name=""/>
+          <p:cNvSpPr>
+            <a:spLocks noGrp="1"/>
+          </p:cNvSpPr>
+          <p:nvPr/>
+        </p:nvSpPr>
+        <p:spPr>
+          <a:xfrm>
+            <a:off x="6120130" y="2835035"/>
+            <a:ext cx="5352732" cy="228600"/>
+          </a:xfrm>
+          <a:prstGeom prst="rect">
+            <a:avLst/>
+          </a:prstGeom>
+          <a:noFill/>
+          <a:ln w="0">
+            <a:noFill/>
+            <a:prstDash val="solid"/>
+          </a:ln>
+        </p:spPr>
+        <p:txBody>
+          <a:bodyPr wrap="square" lIns="0" tIns="0" rIns="0" bIns="0" anchor="t">
+            <a:normAutofit fontScale="100000"/>
+          </a:bodyPr>
+          <a:lstStyle/>
+          <a:p>
+            <a:pPr algn="l">
+              <a:lnSpc>
+                <a:spcPct val="100000"/>
+              </a:lnSpc>
+              <a:buNone/>
+            </a:pPr>
+            <a:r>
+              <a:rPr sz="1050" b="1" i="0">
+                <a:solidFill>
+                  <a:srgbClr val="9D4E24"/>
+                </a:solidFill>
+                <a:latin typeface="Arial Narrow"/>
+                <a:ea typeface="Arial Narrow"/>
+                <a:cs typeface="Arial Narrow"/>
+              </a:rPr>
+              <a:t>2.4–35 kV AND 600 V–2 kV · BUY AMERICA</a:t>
+            </a:r>
+          </a:p>
+        </p:txBody>
+      </p:sp>
+      <p:sp>
+        <p:nvSpPr>
+          <p:cNvPr id="521" name=""/>
+          <p:cNvSpPr>
+            <a:spLocks noGrp="1"/>
+          </p:cNvSpPr>
+          <p:nvPr/>
+        </p:nvSpPr>
+        <p:spPr>
+          <a:xfrm>
+            <a:off x="6120130" y="3063635"/>
+            <a:ext cx="5352732" cy="430000"/>
+          </a:xfrm>
+          <a:prstGeom prst="rect">
+            <a:avLst/>
+          </a:prstGeom>
+          <a:noFill/>
+          <a:ln w="0">
+            <a:noFill/>
+            <a:prstDash val="solid"/>
+          </a:ln>
+        </p:spPr>
+        <p:txBody>
+          <a:bodyPr wrap="square" lIns="0" tIns="0" rIns="0" bIns="0" anchor="t">
+            <a:normAutofit fontScale="100000"/>
+          </a:bodyPr>
+          <a:lstStyle/>
+          <a:p>
+            <a:pPr algn="l">
+              <a:lnSpc>
+                <a:spcPct val="105000"/>
+              </a:lnSpc>
+              <a:buNone/>
+            </a:pPr>
+            <a:r>
+              <a:rPr sz="975" b="0" i="0">
+                <a:solidFill>
+                  <a:srgbClr val="6A6F73"/>
+                </a:solidFill>
+                <a:latin typeface="Arial"/>
+                <a:ea typeface="Arial"/>
+                <a:cs typeface="Arial"/>
+              </a:rPr>
+              <a:t>Every wire and cable application that lives inside — or connects — factory-built power packages, kitted to build sequence.</a:t>
+            </a:r>
+          </a:p>
+        </p:txBody>
+      </p:sp>
+      <p:sp>
+        <p:nvSpPr>
+          <p:cNvPr id="522" name=""/>
+          <p:cNvSpPr>
+            <a:spLocks noGrp="1"/>
+          </p:cNvSpPr>
+          <p:nvPr/>
+        </p:nvSpPr>
+        <p:spPr>
+          <a:xfrm>
+            <a:off x="6120130" y="3520835"/>
+            <a:ext cx="5352732" cy="228600"/>
+          </a:xfrm>
+          <a:prstGeom prst="rect">
+            <a:avLst/>
+          </a:prstGeom>
+          <a:noFill/>
+          <a:ln w="0">
+            <a:noFill/>
+            <a:prstDash val="solid"/>
+          </a:ln>
+        </p:spPr>
+        <p:txBody>
+          <a:bodyPr wrap="square" lIns="0" tIns="0" rIns="0" bIns="0" anchor="t">
+            <a:normAutofit fontScale="100000"/>
+          </a:bodyPr>
+          <a:lstStyle/>
+          <a:p>
+            <a:pPr algn="l">
+              <a:lnSpc>
+                <a:spcPct val="100000"/>
+              </a:lnSpc>
+              <a:buNone/>
+            </a:pPr>
+            <a:r>
+              <a:rPr sz="1050" b="1" i="0">
+                <a:solidFill>
+                  <a:srgbClr val="9D4E24"/>
+                </a:solidFill>
+                <a:latin typeface="Arial Narrow"/>
+                <a:ea typeface="Arial Narrow"/>
+                <a:cs typeface="Arial Narrow"/>
+              </a:rPr>
+              <a:t>E-HOUSES · CONTAINERIZED SUBSTATIONS · SWITCHGEAR</a:t>
+            </a:r>
+          </a:p>
+        </p:txBody>
+      </p:sp>
+      <p:sp>
+        <p:nvSpPr>
+          <p:cNvPr id="523" name=""/>
+          <p:cNvSpPr>
+            <a:spLocks noGrp="1"/>
+          </p:cNvSpPr>
+          <p:nvPr/>
+        </p:nvSpPr>
+        <p:spPr>
+          <a:xfrm>
+            <a:off x="6120130" y="3749435"/>
+            <a:ext cx="5352732" cy="430000"/>
+          </a:xfrm>
+          <a:prstGeom prst="rect">
+            <a:avLst/>
+          </a:prstGeom>
+          <a:noFill/>
+          <a:ln w="0">
+            <a:noFill/>
+            <a:prstDash val="solid"/>
+          </a:ln>
+        </p:spPr>
+        <p:txBody>
+          <a:bodyPr wrap="square" lIns="0" tIns="0" rIns="0" bIns="0" anchor="t">
+            <a:normAutofit fontScale="100000"/>
+          </a:bodyPr>
+          <a:lstStyle/>
+          <a:p>
+            <a:pPr algn="l">
+              <a:lnSpc>
+                <a:spcPct val="105000"/>
+              </a:lnSpc>
+              <a:buNone/>
+            </a:pPr>
+            <a:r>
+              <a:rPr sz="975" b="0" i="0">
+                <a:solidFill>
+                  <a:srgbClr val="6A6F73"/>
+                </a:solidFill>
+                <a:latin typeface="Arial"/>
+                <a:ea typeface="Arial"/>
+                <a:cs typeface="Arial"/>
+              </a:rPr>
+              <a:t>Power control rooms, MV switchgear lineups, LV switchboard and MCC packages.</a:t>
+            </a:r>
+          </a:p>
+        </p:txBody>
+      </p:sp>
+      <p:sp>
+        <p:nvSpPr>
+          <p:cNvPr id="524" name=""/>
+          <p:cNvSpPr>
+            <a:spLocks noGrp="1"/>
+          </p:cNvSpPr>
+          <p:nvPr/>
+        </p:nvSpPr>
+        <p:spPr>
+          <a:xfrm>
+            <a:off x="6120130" y="4206635"/>
+            <a:ext cx="5352732" cy="228600"/>
+          </a:xfrm>
+          <a:prstGeom prst="rect">
+            <a:avLst/>
+          </a:prstGeom>
+          <a:noFill/>
+          <a:ln w="0">
+            <a:noFill/>
+            <a:prstDash val="solid"/>
+          </a:ln>
+        </p:spPr>
+        <p:txBody>
+          <a:bodyPr wrap="square" lIns="0" tIns="0" rIns="0" bIns="0" anchor="t">
+            <a:normAutofit fontScale="100000"/>
+          </a:bodyPr>
+          <a:lstStyle/>
+          <a:p>
+            <a:pPr algn="l">
+              <a:lnSpc>
+                <a:spcPct val="100000"/>
+              </a:lnSpc>
+              <a:buNone/>
+            </a:pPr>
+            <a:r>
+              <a:rPr sz="1050" b="1" i="0">
+                <a:solidFill>
+                  <a:srgbClr val="9D4E24"/>
+                </a:solidFill>
+                <a:latin typeface="Arial Narrow"/>
+                <a:ea typeface="Arial Narrow"/>
+                <a:cs typeface="Arial Narrow"/>
+              </a:rPr>
+              <a:t>TRANSFORMER · BESS · GENSET · PROCESS SKIDS</a:t>
+            </a:r>
+          </a:p>
+        </p:txBody>
+      </p:sp>
+      <p:sp>
+        <p:nvSpPr>
+          <p:cNvPr id="525" name=""/>
+          <p:cNvSpPr>
+            <a:spLocks noGrp="1"/>
+          </p:cNvSpPr>
+          <p:nvPr/>
+        </p:nvSpPr>
+        <p:spPr>
+          <a:xfrm>
+            <a:off x="6120130" y="4435235"/>
+            <a:ext cx="5352732" cy="430000"/>
+          </a:xfrm>
+          <a:prstGeom prst="rect">
+            <a:avLst/>
+          </a:prstGeom>
+          <a:noFill/>
+          <a:ln w="0">
+            <a:noFill/>
+            <a:prstDash val="solid"/>
+          </a:ln>
+        </p:spPr>
+        <p:txBody>
+          <a:bodyPr wrap="square" lIns="0" tIns="0" rIns="0" bIns="0" anchor="t">
+            <a:normAutofit fontScale="100000"/>
+          </a:bodyPr>
+          <a:lstStyle/>
+          <a:p>
+            <a:pPr algn="l">
+              <a:lnSpc>
+                <a:spcPct val="105000"/>
+              </a:lnSpc>
+              <a:buNone/>
+            </a:pPr>
+            <a:r>
+              <a:rPr sz="975" b="0" i="0">
+                <a:solidFill>
+                  <a:srgbClr val="6A6F73"/>
+                </a:solidFill>
+                <a:latin typeface="Arial"/>
+                <a:ea typeface="Arial"/>
+                <a:cs typeface="Arial"/>
+              </a:rPr>
+              <a:t>Transformer packages, BESS containers, generator packages and process / pump skids.</a:t>
+            </a:r>
+          </a:p>
+        </p:txBody>
+      </p:sp>
+      <p:sp>
+        <p:nvSpPr>
+          <p:cNvPr id="526" name=""/>
+          <p:cNvSpPr>
+            <a:spLocks noGrp="1"/>
+          </p:cNvSpPr>
+          <p:nvPr/>
+        </p:nvSpPr>
+        <p:spPr>
+          <a:xfrm>
+            <a:off x="6120130" y="4892435"/>
+            <a:ext cx="5352732" cy="228600"/>
+          </a:xfrm>
+          <a:prstGeom prst="rect">
+            <a:avLst/>
+          </a:prstGeom>
+          <a:noFill/>
+          <a:ln w="0">
+            <a:noFill/>
+            <a:prstDash val="solid"/>
+          </a:ln>
+        </p:spPr>
+        <p:txBody>
+          <a:bodyPr wrap="square" lIns="0" tIns="0" rIns="0" bIns="0" anchor="t">
+            <a:normAutofit fontScale="100000"/>
+          </a:bodyPr>
+          <a:lstStyle/>
+          <a:p>
+            <a:pPr algn="l">
+              <a:lnSpc>
+                <a:spcPct val="100000"/>
+              </a:lnSpc>
+              <a:buNone/>
+            </a:pPr>
+            <a:r>
+              <a:rPr sz="1050" b="1" i="0">
+                <a:solidFill>
+                  <a:srgbClr val="9D4E24"/>
+                </a:solidFill>
+                <a:latin typeface="Arial Narrow"/>
+                <a:ea typeface="Arial Narrow"/>
+                <a:cs typeface="Arial Narrow"/>
+              </a:rPr>
+              <a:t>SIMPULL, PRE-CUTS &amp; KITTING</a:t>
+            </a:r>
+          </a:p>
+        </p:txBody>
+      </p:sp>
+      <p:sp>
+        <p:nvSpPr>
+          <p:cNvPr id="527" name=""/>
+          <p:cNvSpPr>
+            <a:spLocks noGrp="1"/>
+          </p:cNvSpPr>
+          <p:nvPr/>
+        </p:nvSpPr>
+        <p:spPr>
+          <a:xfrm>
+            <a:off x="6120130" y="5121035"/>
+            <a:ext cx="5352732" cy="430000"/>
+          </a:xfrm>
+          <a:prstGeom prst="rect">
+            <a:avLst/>
+          </a:prstGeom>
+          <a:noFill/>
+          <a:ln w="0">
+            <a:noFill/>
+            <a:prstDash val="solid"/>
+          </a:ln>
+        </p:spPr>
+        <p:txBody>
+          <a:bodyPr wrap="square" lIns="0" tIns="0" rIns="0" bIns="0" anchor="t">
+            <a:normAutofit fontScale="100000"/>
+          </a:bodyPr>
+          <a:lstStyle/>
+          <a:p>
+            <a:pPr algn="l">
+              <a:lnSpc>
+                <a:spcPct val="105000"/>
+              </a:lnSpc>
+              <a:buNone/>
+            </a:pPr>
+            <a:r>
+              <a:rPr sz="975" b="0" i="0">
+                <a:solidFill>
+                  <a:srgbClr val="6A6F73"/>
+                </a:solidFill>
+                <a:latin typeface="Arial"/>
+                <a:ea typeface="Arial"/>
+                <a:cs typeface="Arial"/>
+              </a:rPr>
+              <a:t>Low-friction pulling technology, cut-to-length labeled reels and staged kits — energization-ready, less field labor.</a:t>
+            </a:r>
+          </a:p>
+        </p:txBody>
+      </p:sp>
+      <p:sp>
+        <p:nvSpPr>
+          <p:cNvPr id="528" name=""/>
+          <p:cNvSpPr>
+            <a:spLocks noGrp="1"/>
+          </p:cNvSpPr>
+          <p:nvPr/>
+        </p:nvSpPr>
+        <p:spPr>
+          <a:xfrm>
+            <a:off x="6120130" y="5578235"/>
+            <a:ext cx="5352732" cy="228600"/>
+          </a:xfrm>
+          <a:prstGeom prst="rect">
+            <a:avLst/>
+          </a:prstGeom>
+          <a:noFill/>
+          <a:ln w="0">
+            <a:noFill/>
+            <a:prstDash val="solid"/>
+          </a:ln>
+        </p:spPr>
+        <p:txBody>
+          <a:bodyPr wrap="square" lIns="0" tIns="0" rIns="0" bIns="0" anchor="t">
+            <a:normAutofit fontScale="100000"/>
+          </a:bodyPr>
+          <a:lstStyle/>
+          <a:p>
+            <a:pPr algn="l">
+              <a:lnSpc>
+                <a:spcPct val="100000"/>
+              </a:lnSpc>
+              <a:buNone/>
+            </a:pPr>
+            <a:r>
+              <a:rPr sz="1050" b="1" i="0">
+                <a:solidFill>
+                  <a:srgbClr val="9D4E24"/>
+                </a:solidFill>
+                <a:latin typeface="Arial Narrow"/>
+                <a:ea typeface="Arial Narrow"/>
+                <a:cs typeface="Arial Narrow"/>
+              </a:rPr>
+              <a:t>ONE SUPPLIER, WHOLE PACKAGE</a:t>
+            </a:r>
+          </a:p>
+        </p:txBody>
+      </p:sp>
+      <p:sp>
+        <p:nvSpPr>
+          <p:cNvPr id="529" name=""/>
+          <p:cNvSpPr>
+            <a:spLocks noGrp="1"/>
+          </p:cNvSpPr>
+          <p:nvPr/>
+        </p:nvSpPr>
+        <p:spPr>
+          <a:xfrm>
+            <a:off x="6120130" y="5806835"/>
+            <a:ext cx="5352732" cy="430000"/>
+          </a:xfrm>
+          <a:prstGeom prst="rect">
+            <a:avLst/>
+          </a:prstGeom>
+          <a:noFill/>
+          <a:ln w="0">
+            <a:noFill/>
+            <a:prstDash val="solid"/>
+          </a:ln>
+        </p:spPr>
+        <p:txBody>
+          <a:bodyPr wrap="square" lIns="0" tIns="0" rIns="0" bIns="0" anchor="t">
+            <a:normAutofit fontScale="100000"/>
+          </a:bodyPr>
+          <a:lstStyle/>
+          <a:p>
+            <a:pPr algn="l">
+              <a:lnSpc>
+                <a:spcPct val="105000"/>
+              </a:lnSpc>
+              <a:buNone/>
+            </a:pPr>
+            <a:r>
+              <a:rPr sz="975" b="0" i="0">
+                <a:solidFill>
+                  <a:srgbClr val="6A6F73"/>
+                </a:solidFill>
+                <a:latin typeface="Arial"/>
+                <a:ea typeface="Arial"/>
+                <a:cs typeface="Arial"/>
+              </a:rPr>
+              <a:t>MV, LV, control, VFD, grounding, data and DC from a single domestic source — one procurement line item per package.</a:t>
+            </a:r>
+          </a:p>
+        </p:txBody>
+      </p:sp>
+      <p:sp>
+        <p:nvSpPr>
+          <p:cNvPr id="530" name=""/>
+          <p:cNvSpPr>
+            <a:spLocks noGrp="1"/>
+          </p:cNvSpPr>
+          <p:nvPr/>
+        </p:nvSpPr>
+        <p:spPr>
+          <a:xfrm>
+            <a:off x="719138" y="6315000"/>
+            <a:ext cx="10753724" cy="400000"/>
+          </a:xfrm>
+          <a:prstGeom prst="rect">
+            <a:avLst/>
+          </a:prstGeom>
+          <a:solidFill>
+            <a:srgbClr val="17191C"/>
+          </a:solidFill>
+          <a:ln w="0">
+            <a:noFill/>
+            <a:prstDash val="solid"/>
+          </a:ln>
+        </p:spPr>
+      </p:sp>
+      <p:sp>
+        <p:nvSpPr>
+          <p:cNvPr id="531" name=""/>
+          <p:cNvSpPr>
+            <a:spLocks noGrp="1"/>
+          </p:cNvSpPr>
+          <p:nvPr/>
+        </p:nvSpPr>
+        <p:spPr>
+          <a:xfrm>
+            <a:off x="719138" y="6315000"/>
+            <a:ext cx="10753724" cy="400000"/>
+          </a:xfrm>
+          <a:prstGeom prst="rect">
+            <a:avLst/>
+          </a:prstGeom>
+          <a:noFill/>
+          <a:ln w="0">
+            <a:noFill/>
+            <a:prstDash val="solid"/>
+          </a:ln>
+        </p:spPr>
+        <p:txBody>
+          <a:bodyPr wrap="square" lIns="0" tIns="0" rIns="0" bIns="0" anchor="ctr">
+            <a:normAutofit fontScale="100000"/>
+          </a:bodyPr>
+          <a:lstStyle/>
+          <a:p>
+            <a:pPr algn="ctr">
+              <a:lnSpc>
+                <a:spcPct val="100000"/>
+              </a:lnSpc>
+              <a:buNone/>
+            </a:pPr>
+            <a:r>
+              <a:rPr sz="1050" b="1" i="0">
+                <a:solidFill>
+                  <a:srgbClr val="FFFFFF"/>
+                </a:solidFill>
+                <a:latin typeface="Arial Narrow"/>
+                <a:ea typeface="Arial Narrow"/>
+                <a:cs typeface="Arial Narrow"/>
+              </a:rPr>
+              <a:t>TWO LEAVE-BEHIND CATALOGUES ACCOMPANY THIS DECK — IPP CABLE CATALOGUE (PLANT) · PACKAGED POWER E-CATALOGUE (SKIDS).</a:t>
+            </a:r>
+          </a:p>
+        </p:txBody>
+      </p:sp>
+    </p:spTree>
+  </p:cSld>
+</p:sld>
+</file>
+
+<file path=ppt/slides/slide21.xml><?xml version="1.0" encoding="utf-8"?>
+<p:sld xmlns:p="http://schemas.openxmlformats.org/presentationml/2006/main" xmlns:a="http://schemas.openxmlformats.org/drawingml/2006/main" xmlns:r="http://schemas.openxmlformats.org/officeDocument/2006/relationships">
+  <p:cSld>
+    <p:bg>
+      <p:bgPr>
+        <a:solidFill>
+          <a:srgbClr val="F6F3EE"/>
+        </a:solidFill>
+      </p:bgPr>
+    </p:bg>
+    <p:spTree>
+      <p:nvGrpSpPr>
+        <p:cNvPr id="1" name=""/>
+        <p:cNvGrpSpPr/>
+        <p:nvPr/>
+      </p:nvGrpSpPr>
+      <p:grpSpPr>
+        <a:xfrm/>
+      </p:grpSpPr>
+      <p:sp>
+        <p:nvSpPr>
+          <p:cNvPr id="532" name=""/>
+          <p:cNvSpPr>
+            <a:spLocks noGrp="1"/>
+          </p:cNvSpPr>
+          <p:nvPr/>
+        </p:nvSpPr>
+        <p:spPr>
+          <a:xfrm>
+            <a:off x="0" y="0"/>
+            <a:ext cx="12192000" cy="57150"/>
+          </a:xfrm>
+          <a:prstGeom prst="rect">
+            <a:avLst/>
+          </a:prstGeom>
+          <a:solidFill>
+            <a:srgbClr val="C9783E"/>
+          </a:solidFill>
+          <a:ln w="0">
+            <a:noFill/>
+            <a:prstDash val="solid"/>
+          </a:ln>
+        </p:spPr>
+      </p:sp>
+      <p:pic>
+        <p:nvPicPr>
+          <p:cNvPr id="533" name=""/>
+          <p:cNvPicPr>
+            <a:picLocks noChangeAspect="1"/>
+          </p:cNvPicPr>
+          <p:nvPr/>
+        </p:nvPicPr>
+        <p:blipFill>
+          <a:blip r:embed="R48e2a3d3733b4264"/>
+          <a:stretch/>
+        </p:blipFill>
+        <p:spPr>
+          <a:xfrm>
+            <a:off x="719138" y="200025"/>
+            <a:ext cx="2066925" cy="590550"/>
+          </a:xfrm>
+          <a:prstGeom prst="rect">
+            <a:avLst/>
+          </a:prstGeom>
+        </p:spPr>
+      </p:pic>
+      <p:sp>
+        <p:nvSpPr>
+          <p:cNvPr id="534" name=""/>
+          <p:cNvSpPr>
+            <a:spLocks noGrp="1"/>
+          </p:cNvSpPr>
+          <p:nvPr/>
+        </p:nvSpPr>
+        <p:spPr>
+          <a:xfrm>
+            <a:off x="7325360" y="323850"/>
+            <a:ext cx="3857000" cy="228600"/>
+          </a:xfrm>
+          <a:prstGeom prst="rect">
+            <a:avLst/>
+          </a:prstGeom>
+          <a:noFill/>
+          <a:ln w="0">
+            <a:noFill/>
+            <a:prstDash val="solid"/>
+          </a:ln>
+        </p:spPr>
+        <p:txBody>
+          <a:bodyPr wrap="square" lIns="0" tIns="0" rIns="0" bIns="0" anchor="t">
+            <a:normAutofit fontScale="100000"/>
+          </a:bodyPr>
+          <a:lstStyle/>
+          <a:p>
+            <a:pPr algn="r">
+              <a:lnSpc>
+                <a:spcPct val="100000"/>
+              </a:lnSpc>
+              <a:buNone/>
+            </a:pPr>
+            <a:r>
+              <a:rPr sz="975" b="1" i="0">
+                <a:solidFill>
+                  <a:srgbClr val="9D4E24"/>
+                </a:solidFill>
+                <a:latin typeface="Arial Narrow"/>
+                <a:ea typeface="Arial Narrow"/>
+                <a:cs typeface="Arial Narrow"/>
+              </a:rPr>
+              <a:t>APPENDIX A12 · OPERATING FLEET</a:t>
+            </a:r>
+          </a:p>
+        </p:txBody>
+      </p:sp>
+      <p:sp>
+        <p:nvSpPr>
+          <p:cNvPr id="535" name=""/>
+          <p:cNvSpPr>
+            <a:spLocks noGrp="1"/>
+          </p:cNvSpPr>
+          <p:nvPr/>
+        </p:nvSpPr>
+        <p:spPr>
+          <a:xfrm>
+            <a:off x="11334750" y="323850"/>
+            <a:ext cx="323850" cy="228600"/>
+          </a:xfrm>
+          <a:prstGeom prst="rect">
+            <a:avLst/>
+          </a:prstGeom>
+          <a:noFill/>
+          <a:ln w="0">
+            <a:noFill/>
+            <a:prstDash val="solid"/>
+          </a:ln>
+        </p:spPr>
+        <p:txBody>
+          <a:bodyPr wrap="square" lIns="0" tIns="0" rIns="0" bIns="0" anchor="t">
+            <a:normAutofit fontScale="100000"/>
+          </a:bodyPr>
+          <a:lstStyle/>
+          <a:p>
+            <a:pPr algn="r">
+              <a:lnSpc>
+                <a:spcPct val="100000"/>
+              </a:lnSpc>
+              <a:buNone/>
+            </a:pPr>
+            <a:r>
+              <a:rPr sz="975" b="1" i="0">
+                <a:solidFill>
+                  <a:srgbClr val="8B9094"/>
+                </a:solidFill>
+                <a:latin typeface="Arial Narrow"/>
+                <a:ea typeface="Arial Narrow"/>
+                <a:cs typeface="Arial Narrow"/>
+              </a:rPr>
+              <a:t>21</a:t>
+            </a:r>
+          </a:p>
+        </p:txBody>
+      </p:sp>
+      <p:sp>
+        <p:nvSpPr>
+          <p:cNvPr id="536" name=""/>
+          <p:cNvSpPr>
+            <a:spLocks noGrp="1"/>
+          </p:cNvSpPr>
+          <p:nvPr/>
+        </p:nvSpPr>
+        <p:spPr>
+          <a:xfrm>
+            <a:off x="719138" y="1005840"/>
+            <a:ext cx="9000000" cy="228600"/>
+          </a:xfrm>
+          <a:prstGeom prst="rect">
+            <a:avLst/>
+          </a:prstGeom>
+          <a:noFill/>
+          <a:ln w="0">
+            <a:noFill/>
+            <a:prstDash val="solid"/>
+          </a:ln>
+        </p:spPr>
+        <p:txBody>
+          <a:bodyPr wrap="square" lIns="0" tIns="0" rIns="0" bIns="0" anchor="t">
+            <a:normAutofit fontScale="100000"/>
+          </a:bodyPr>
+          <a:lstStyle/>
+          <a:p>
+            <a:pPr algn="l">
+              <a:lnSpc>
+                <a:spcPct val="100000"/>
+              </a:lnSpc>
+              <a:buNone/>
+            </a:pPr>
+            <a:r>
+              <a:rPr sz="1050" b="1" i="0">
+                <a:solidFill>
+                  <a:srgbClr val="C9783E"/>
+                </a:solidFill>
+                <a:latin typeface="Arial Narrow"/>
+                <a:ea typeface="Arial Narrow"/>
+                <a:cs typeface="Arial Narrow"/>
+              </a:rPr>
+              <a:t>REJUVENATION, BROWNFIELD &amp; SERVICE — FOR THE 25.8 GW FLEET</a:t>
+            </a:r>
+          </a:p>
+        </p:txBody>
+      </p:sp>
+      <p:sp>
+        <p:nvSpPr>
+          <p:cNvPr id="537" name=""/>
+          <p:cNvSpPr>
+            <a:spLocks noGrp="1"/>
+          </p:cNvSpPr>
+          <p:nvPr/>
+        </p:nvSpPr>
+        <p:spPr>
+          <a:xfrm>
+            <a:off x="719138" y="1280160"/>
+            <a:ext cx="10753724" cy="500000"/>
+          </a:xfrm>
+          <a:prstGeom prst="rect">
+            <a:avLst/>
+          </a:prstGeom>
+          <a:noFill/>
+          <a:ln w="0">
+            <a:noFill/>
+            <a:prstDash val="solid"/>
+          </a:ln>
+        </p:spPr>
+        <p:txBody>
+          <a:bodyPr wrap="square" lIns="0" tIns="0" rIns="0" bIns="0" anchor="t">
+            <a:normAutofit fontScale="100000"/>
+          </a:bodyPr>
+          <a:lstStyle/>
+          <a:p>
+            <a:pPr algn="l">
+              <a:lnSpc>
+                <a:spcPct val="104000"/>
+              </a:lnSpc>
+              <a:buNone/>
+            </a:pPr>
+            <a:r>
+              <a:rPr sz="2850" b="1" i="0">
+                <a:solidFill>
+                  <a:srgbClr val="17191C"/>
+                </a:solidFill>
+                <a:latin typeface="Arial"/>
+                <a:ea typeface="Arial"/>
+                <a:cs typeface="Arial"/>
+              </a:rPr>
+              <a:t>Extend asset life without a greenfield rebuild.</a:t>
+            </a:r>
+          </a:p>
+        </p:txBody>
+      </p:sp>
+      <p:sp>
+        <p:nvSpPr>
+          <p:cNvPr id="538" name=""/>
+          <p:cNvSpPr>
+            <a:spLocks noGrp="1"/>
+          </p:cNvSpPr>
+          <p:nvPr/>
+        </p:nvSpPr>
+        <p:spPr>
+          <a:xfrm>
+            <a:off x="719138" y="1950720"/>
+            <a:ext cx="10753724" cy="300000"/>
+          </a:xfrm>
+          <a:prstGeom prst="rect">
+            <a:avLst/>
+          </a:prstGeom>
+          <a:noFill/>
+          <a:ln w="0">
+            <a:noFill/>
+            <a:prstDash val="solid"/>
+          </a:ln>
+        </p:spPr>
+        <p:txBody>
+          <a:bodyPr wrap="square" lIns="0" tIns="0" rIns="0" bIns="0" anchor="t">
+            <a:normAutofit fontScale="100000"/>
+          </a:bodyPr>
+          <a:lstStyle/>
+          <a:p>
+            <a:pPr algn="l">
+              <a:lnSpc>
+                <a:spcPct val="108000"/>
+              </a:lnSpc>
+              <a:buNone/>
+            </a:pPr>
+            <a:r>
+              <a:rPr sz="1050" b="0" i="0">
+                <a:solidFill>
+                  <a:srgbClr val="6A6F73"/>
+                </a:solidFill>
+                <a:latin typeface="Arial"/>
+                <a:ea typeface="Arial"/>
+                <a:cs typeface="Arial"/>
+              </a:rPr>
+              <a:t>Aging cable systems, upgrades and modular additions across an operating fleet — planned around outage schedules, while the plant stays available.</a:t>
+            </a:r>
+          </a:p>
+        </p:txBody>
+      </p:sp>
+      <p:sp>
+        <p:nvSpPr>
+          <p:cNvPr id="539" name=""/>
+          <p:cNvSpPr>
+            <a:spLocks noGrp="1"/>
+          </p:cNvSpPr>
+          <p:nvPr/>
+        </p:nvSpPr>
+        <p:spPr>
+          <a:xfrm>
+            <a:off x="719138" y="2560320"/>
+            <a:ext cx="5237862" cy="1005840"/>
+          </a:xfrm>
+          <a:prstGeom prst="rect">
+            <a:avLst/>
+          </a:prstGeom>
+          <a:solidFill>
+            <a:srgbClr val="FFFFFF"/>
+          </a:solidFill>
+          <a:ln w="9525">
+            <a:solidFill>
+              <a:srgbClr val="D8D1C8"/>
+            </a:solidFill>
+            <a:prstDash val="solid"/>
+          </a:ln>
+        </p:spPr>
+      </p:sp>
+      <p:sp>
+        <p:nvSpPr>
+          <p:cNvPr id="540" name=""/>
+          <p:cNvSpPr>
+            <a:spLocks noGrp="1"/>
+          </p:cNvSpPr>
+          <p:nvPr/>
+        </p:nvSpPr>
+        <p:spPr>
+          <a:xfrm>
+            <a:off x="947738" y="2674620"/>
+            <a:ext cx="4780662" cy="228600"/>
+          </a:xfrm>
+          <a:prstGeom prst="rect">
+            <a:avLst/>
+          </a:prstGeom>
+          <a:noFill/>
+          <a:ln w="0">
+            <a:noFill/>
+            <a:prstDash val="solid"/>
+          </a:ln>
+        </p:spPr>
+        <p:txBody>
+          <a:bodyPr wrap="square" lIns="0" tIns="0" rIns="0" bIns="0" anchor="t">
+            <a:normAutofit fontScale="100000"/>
+          </a:bodyPr>
+          <a:lstStyle/>
+          <a:p>
+            <a:pPr algn="l">
+              <a:lnSpc>
+                <a:spcPct val="100000"/>
+              </a:lnSpc>
+              <a:buNone/>
+            </a:pPr>
+            <a:r>
+              <a:rPr sz="1050" b="1" i="0">
+                <a:solidFill>
+                  <a:srgbClr val="9D4E24"/>
+                </a:solidFill>
+                <a:latin typeface="Arial Narrow"/>
+                <a:ea typeface="Arial Narrow"/>
+                <a:cs typeface="Arial Narrow"/>
+              </a:rPr>
+              <a:t>ELECTRICAL SPINE REJUVENATION</a:t>
+            </a:r>
+          </a:p>
+        </p:txBody>
+      </p:sp>
+      <p:sp>
+        <p:nvSpPr>
+          <p:cNvPr id="541" name=""/>
+          <p:cNvSpPr>
+            <a:spLocks noGrp="1"/>
+          </p:cNvSpPr>
+          <p:nvPr/>
+        </p:nvSpPr>
+        <p:spPr>
+          <a:xfrm>
+            <a:off x="947738" y="2948940"/>
+            <a:ext cx="4780662" cy="540000"/>
+          </a:xfrm>
+          <a:prstGeom prst="rect">
+            <a:avLst/>
+          </a:prstGeom>
+          <a:noFill/>
+          <a:ln w="0">
+            <a:noFill/>
+            <a:prstDash val="solid"/>
+          </a:ln>
+        </p:spPr>
+        <p:txBody>
+          <a:bodyPr wrap="square" lIns="0" tIns="0" rIns="0" bIns="0" anchor="t">
+            <a:normAutofit fontScale="100000"/>
+          </a:bodyPr>
+          <a:lstStyle/>
+          <a:p>
+            <a:pPr algn="l">
+              <a:lnSpc>
+                <a:spcPct val="106000"/>
+              </a:lnSpc>
+              <a:buNone/>
+            </a:pPr>
+            <a:r>
+              <a:rPr sz="975" b="0" i="0">
+                <a:solidFill>
+                  <a:srgbClr val="6A6F73"/>
+                </a:solidFill>
+                <a:latin typeface="Arial"/>
+                <a:ea typeface="Arial"/>
+                <a:cs typeface="Arial"/>
+              </a:rPr>
+              <a:t>Assessment, planning and phased replacement of aging MV / LV cable, grounding, tray and fiber — while the plant remains operational.</a:t>
+            </a:r>
+          </a:p>
+        </p:txBody>
+      </p:sp>
+      <p:sp>
+        <p:nvSpPr>
+          <p:cNvPr id="542" name=""/>
+          <p:cNvSpPr>
+            <a:spLocks noGrp="1"/>
+          </p:cNvSpPr>
+          <p:nvPr/>
+        </p:nvSpPr>
+        <p:spPr>
+          <a:xfrm>
+            <a:off x="6235130" y="2560320"/>
+            <a:ext cx="5237862" cy="1005840"/>
+          </a:xfrm>
+          <a:prstGeom prst="rect">
+            <a:avLst/>
+          </a:prstGeom>
+          <a:solidFill>
+            <a:srgbClr val="FFFFFF"/>
+          </a:solidFill>
+          <a:ln w="9525">
+            <a:solidFill>
+              <a:srgbClr val="D8D1C8"/>
+            </a:solidFill>
+            <a:prstDash val="solid"/>
+          </a:ln>
+        </p:spPr>
+      </p:sp>
+      <p:sp>
+        <p:nvSpPr>
+          <p:cNvPr id="543" name=""/>
+          <p:cNvSpPr>
+            <a:spLocks noGrp="1"/>
+          </p:cNvSpPr>
+          <p:nvPr/>
+        </p:nvSpPr>
+        <p:spPr>
+          <a:xfrm>
+            <a:off x="6463730" y="2674620"/>
+            <a:ext cx="4780662" cy="228600"/>
+          </a:xfrm>
+          <a:prstGeom prst="rect">
+            <a:avLst/>
+          </a:prstGeom>
+          <a:noFill/>
+          <a:ln w="0">
+            <a:noFill/>
+            <a:prstDash val="solid"/>
+          </a:ln>
+        </p:spPr>
+        <p:txBody>
+          <a:bodyPr wrap="square" lIns="0" tIns="0" rIns="0" bIns="0" anchor="t">
+            <a:normAutofit fontScale="100000"/>
+          </a:bodyPr>
+          <a:lstStyle/>
+          <a:p>
+            <a:pPr algn="l">
+              <a:lnSpc>
+                <a:spcPct val="100000"/>
+              </a:lnSpc>
+              <a:buNone/>
+            </a:pPr>
+            <a:r>
+              <a:rPr sz="1050" b="1" i="0">
+                <a:solidFill>
+                  <a:srgbClr val="9D4E24"/>
+                </a:solidFill>
+                <a:latin typeface="Arial Narrow"/>
+                <a:ea typeface="Arial Narrow"/>
+                <a:cs typeface="Arial Narrow"/>
+              </a:rPr>
+              <a:t>CABLE REPLACEMENT PROGRAMS</a:t>
+            </a:r>
+          </a:p>
+        </p:txBody>
+      </p:sp>
+      <p:sp>
+        <p:nvSpPr>
+          <p:cNvPr id="544" name=""/>
+          <p:cNvSpPr>
+            <a:spLocks noGrp="1"/>
+          </p:cNvSpPr>
+          <p:nvPr/>
+        </p:nvSpPr>
+        <p:spPr>
+          <a:xfrm>
+            <a:off x="6463730" y="2948940"/>
+            <a:ext cx="4780662" cy="540000"/>
+          </a:xfrm>
+          <a:prstGeom prst="rect">
+            <a:avLst/>
+          </a:prstGeom>
+          <a:noFill/>
+          <a:ln w="0">
+            <a:noFill/>
+            <a:prstDash val="solid"/>
+          </a:ln>
+        </p:spPr>
+        <p:txBody>
+          <a:bodyPr wrap="square" lIns="0" tIns="0" rIns="0" bIns="0" anchor="t">
+            <a:normAutofit fontScale="100000"/>
+          </a:bodyPr>
+          <a:lstStyle/>
+          <a:p>
+            <a:pPr algn="l">
+              <a:lnSpc>
+                <a:spcPct val="106000"/>
+              </a:lnSpc>
+              <a:buNone/>
+            </a:pPr>
+            <a:r>
+              <a:rPr sz="975" b="0" i="0">
+                <a:solidFill>
+                  <a:srgbClr val="6A6F73"/>
+                </a:solidFill>
+                <a:latin typeface="Arial"/>
+                <a:ea typeface="Arial"/>
+                <a:cs typeface="Arial"/>
+              </a:rPr>
+              <a:t>Fast-track domestic supply of power, control and instrumentation cable for planned outages or emergency replacement.</a:t>
+            </a:r>
+          </a:p>
+        </p:txBody>
+      </p:sp>
+      <p:sp>
+        <p:nvSpPr>
+          <p:cNvPr id="545" name=""/>
+          <p:cNvSpPr>
+            <a:spLocks noGrp="1"/>
+          </p:cNvSpPr>
+          <p:nvPr/>
+        </p:nvSpPr>
+        <p:spPr>
+          <a:xfrm>
+            <a:off x="719138" y="3739896"/>
+            <a:ext cx="5237862" cy="1005840"/>
+          </a:xfrm>
+          <a:prstGeom prst="rect">
+            <a:avLst/>
+          </a:prstGeom>
+          <a:solidFill>
+            <a:srgbClr val="FFFFFF"/>
+          </a:solidFill>
+          <a:ln w="9525">
+            <a:solidFill>
+              <a:srgbClr val="D8D1C8"/>
+            </a:solidFill>
+            <a:prstDash val="solid"/>
+          </a:ln>
+        </p:spPr>
+      </p:sp>
+      <p:sp>
+        <p:nvSpPr>
+          <p:cNvPr id="546" name=""/>
+          <p:cNvSpPr>
+            <a:spLocks noGrp="1"/>
+          </p:cNvSpPr>
+          <p:nvPr/>
+        </p:nvSpPr>
+        <p:spPr>
+          <a:xfrm>
+            <a:off x="947738" y="3854196"/>
+            <a:ext cx="4780662" cy="228600"/>
+          </a:xfrm>
+          <a:prstGeom prst="rect">
+            <a:avLst/>
+          </a:prstGeom>
+          <a:noFill/>
+          <a:ln w="0">
+            <a:noFill/>
+            <a:prstDash val="solid"/>
+          </a:ln>
+        </p:spPr>
+        <p:txBody>
+          <a:bodyPr wrap="square" lIns="0" tIns="0" rIns="0" bIns="0" anchor="t">
+            <a:normAutofit fontScale="100000"/>
+          </a:bodyPr>
+          <a:lstStyle/>
+          <a:p>
+            <a:pPr algn="l">
+              <a:lnSpc>
+                <a:spcPct val="100000"/>
+              </a:lnSpc>
+              <a:buNone/>
+            </a:pPr>
+            <a:r>
+              <a:rPr sz="1050" b="1" i="0">
+                <a:solidFill>
+                  <a:srgbClr val="9D4E24"/>
+                </a:solidFill>
+                <a:latin typeface="Arial Narrow"/>
+                <a:ea typeface="Arial Narrow"/>
+                <a:cs typeface="Arial Narrow"/>
+              </a:rPr>
+              <a:t>BROWNFIELD UPGRADES &amp; REPOWER</a:t>
+            </a:r>
+          </a:p>
+        </p:txBody>
+      </p:sp>
+      <p:sp>
+        <p:nvSpPr>
+          <p:cNvPr id="547" name=""/>
+          <p:cNvSpPr>
+            <a:spLocks noGrp="1"/>
+          </p:cNvSpPr>
+          <p:nvPr/>
+        </p:nvSpPr>
+        <p:spPr>
+          <a:xfrm>
+            <a:off x="947738" y="4128516"/>
+            <a:ext cx="4780662" cy="540000"/>
+          </a:xfrm>
+          <a:prstGeom prst="rect">
+            <a:avLst/>
+          </a:prstGeom>
+          <a:noFill/>
+          <a:ln w="0">
+            <a:noFill/>
+            <a:prstDash val="solid"/>
+          </a:ln>
+        </p:spPr>
+        <p:txBody>
+          <a:bodyPr wrap="square" lIns="0" tIns="0" rIns="0" bIns="0" anchor="t">
+            <a:normAutofit fontScale="100000"/>
+          </a:bodyPr>
+          <a:lstStyle/>
+          <a:p>
+            <a:pPr algn="l">
+              <a:lnSpc>
+                <a:spcPct val="106000"/>
+              </a:lnSpc>
+              <a:buNone/>
+            </a:pPr>
+            <a:r>
+              <a:rPr sz="975" b="0" i="0">
+                <a:solidFill>
+                  <a:srgbClr val="6A6F73"/>
+                </a:solidFill>
+                <a:latin typeface="Arial"/>
+                <a:ea typeface="Arial"/>
+                <a:cs typeface="Arial"/>
+              </a:rPr>
+              <a:t>Electrical scope for turbine upgrades, generator replacements, emissions retrofits and balance-of-plant modernization.</a:t>
+            </a:r>
+          </a:p>
+        </p:txBody>
+      </p:sp>
+      <p:sp>
+        <p:nvSpPr>
+          <p:cNvPr id="548" name=""/>
+          <p:cNvSpPr>
+            <a:spLocks noGrp="1"/>
+          </p:cNvSpPr>
+          <p:nvPr/>
+        </p:nvSpPr>
+        <p:spPr>
+          <a:xfrm>
+            <a:off x="6235130" y="3739896"/>
+            <a:ext cx="5237862" cy="1005840"/>
+          </a:xfrm>
+          <a:prstGeom prst="rect">
+            <a:avLst/>
+          </a:prstGeom>
+          <a:solidFill>
+            <a:srgbClr val="FFFFFF"/>
+          </a:solidFill>
+          <a:ln w="9525">
+            <a:solidFill>
+              <a:srgbClr val="D8D1C8"/>
+            </a:solidFill>
+            <a:prstDash val="solid"/>
+          </a:ln>
+        </p:spPr>
+      </p:sp>
+      <p:sp>
+        <p:nvSpPr>
+          <p:cNvPr id="549" name=""/>
+          <p:cNvSpPr>
+            <a:spLocks noGrp="1"/>
+          </p:cNvSpPr>
+          <p:nvPr/>
+        </p:nvSpPr>
+        <p:spPr>
+          <a:xfrm>
+            <a:off x="6463730" y="3854196"/>
+            <a:ext cx="4780662" cy="228600"/>
+          </a:xfrm>
+          <a:prstGeom prst="rect">
+            <a:avLst/>
+          </a:prstGeom>
+          <a:noFill/>
+          <a:ln w="0">
+            <a:noFill/>
+            <a:prstDash val="solid"/>
+          </a:ln>
+        </p:spPr>
+        <p:txBody>
+          <a:bodyPr wrap="square" lIns="0" tIns="0" rIns="0" bIns="0" anchor="t">
+            <a:normAutofit fontScale="100000"/>
+          </a:bodyPr>
+          <a:lstStyle/>
+          <a:p>
+            <a:pPr algn="l">
+              <a:lnSpc>
+                <a:spcPct val="100000"/>
+              </a:lnSpc>
+              <a:buNone/>
+            </a:pPr>
+            <a:r>
+              <a:rPr sz="1050" b="1" i="0">
+                <a:solidFill>
+                  <a:srgbClr val="9D4E24"/>
+                </a:solidFill>
+                <a:latin typeface="Arial Narrow"/>
+                <a:ea typeface="Arial Narrow"/>
+                <a:cs typeface="Arial Narrow"/>
+              </a:rPr>
+              <a:t>MODULAR POWER ADDITIONS</a:t>
+            </a:r>
+          </a:p>
+        </p:txBody>
+      </p:sp>
+      <p:sp>
+        <p:nvSpPr>
+          <p:cNvPr id="550" name=""/>
+          <p:cNvSpPr>
+            <a:spLocks noGrp="1"/>
+          </p:cNvSpPr>
+          <p:nvPr/>
+        </p:nvSpPr>
+        <p:spPr>
+          <a:xfrm>
+            <a:off x="6463730" y="4128516"/>
+            <a:ext cx="4780662" cy="540000"/>
+          </a:xfrm>
+          <a:prstGeom prst="rect">
+            <a:avLst/>
+          </a:prstGeom>
+          <a:noFill/>
+          <a:ln w="0">
+            <a:noFill/>
+            <a:prstDash val="solid"/>
+          </a:ln>
+        </p:spPr>
+        <p:txBody>
+          <a:bodyPr wrap="square" lIns="0" tIns="0" rIns="0" bIns="0" anchor="t">
+            <a:normAutofit fontScale="100000"/>
+          </a:bodyPr>
+          <a:lstStyle/>
+          <a:p>
+            <a:pPr algn="l">
+              <a:lnSpc>
+                <a:spcPct val="106000"/>
+              </a:lnSpc>
+              <a:buNone/>
+            </a:pPr>
+            <a:r>
+              <a:rPr sz="975" b="0" i="0">
+                <a:solidFill>
+                  <a:srgbClr val="6A6F73"/>
+                </a:solidFill>
+                <a:latin typeface="Arial"/>
+                <a:ea typeface="Arial"/>
+                <a:cs typeface="Arial"/>
+              </a:rPr>
+              <a:t>E-houses, skids, switchgear, UPS and black-start capability — auxiliary loads or new behind-the-meter offtakers.</a:t>
+            </a:r>
+          </a:p>
+        </p:txBody>
+      </p:sp>
+      <p:sp>
+        <p:nvSpPr>
+          <p:cNvPr id="551" name=""/>
+          <p:cNvSpPr>
+            <a:spLocks noGrp="1"/>
+          </p:cNvSpPr>
+          <p:nvPr/>
+        </p:nvSpPr>
+        <p:spPr>
+          <a:xfrm>
+            <a:off x="719138" y="4919472"/>
+            <a:ext cx="5237862" cy="1005840"/>
+          </a:xfrm>
+          <a:prstGeom prst="rect">
+            <a:avLst/>
+          </a:prstGeom>
+          <a:solidFill>
+            <a:srgbClr val="FFFFFF"/>
+          </a:solidFill>
+          <a:ln w="9525">
+            <a:solidFill>
+              <a:srgbClr val="D8D1C8"/>
+            </a:solidFill>
+            <a:prstDash val="solid"/>
+          </a:ln>
+        </p:spPr>
+      </p:sp>
+      <p:sp>
+        <p:nvSpPr>
+          <p:cNvPr id="552" name=""/>
+          <p:cNvSpPr>
+            <a:spLocks noGrp="1"/>
+          </p:cNvSpPr>
+          <p:nvPr/>
+        </p:nvSpPr>
+        <p:spPr>
+          <a:xfrm>
+            <a:off x="947738" y="5033772"/>
+            <a:ext cx="4780662" cy="228600"/>
+          </a:xfrm>
+          <a:prstGeom prst="rect">
+            <a:avLst/>
+          </a:prstGeom>
+          <a:noFill/>
+          <a:ln w="0">
+            <a:noFill/>
+            <a:prstDash val="solid"/>
+          </a:ln>
+        </p:spPr>
+        <p:txBody>
+          <a:bodyPr wrap="square" lIns="0" tIns="0" rIns="0" bIns="0" anchor="t">
+            <a:normAutofit fontScale="100000"/>
+          </a:bodyPr>
+          <a:lstStyle/>
+          <a:p>
+            <a:pPr algn="l">
+              <a:lnSpc>
+                <a:spcPct val="100000"/>
+              </a:lnSpc>
+              <a:buNone/>
+            </a:pPr>
+            <a:r>
+              <a:rPr sz="1050" b="1" i="0">
+                <a:solidFill>
+                  <a:srgbClr val="9D4E24"/>
+                </a:solidFill>
+                <a:latin typeface="Arial Narrow"/>
+                <a:ea typeface="Arial Narrow"/>
+                <a:cs typeface="Arial Narrow"/>
+              </a:rPr>
+              <a:t>RELIABILITY &amp; CONDITION SUPPORT</a:t>
+            </a:r>
+          </a:p>
+        </p:txBody>
+      </p:sp>
+      <p:sp>
+        <p:nvSpPr>
+          <p:cNvPr id="553" name=""/>
+          <p:cNvSpPr>
+            <a:spLocks noGrp="1"/>
+          </p:cNvSpPr>
+          <p:nvPr/>
+        </p:nvSpPr>
+        <p:spPr>
+          <a:xfrm>
+            <a:off x="947738" y="5308092"/>
+            <a:ext cx="4780662" cy="540000"/>
+          </a:xfrm>
+          <a:prstGeom prst="rect">
+            <a:avLst/>
+          </a:prstGeom>
+          <a:noFill/>
+          <a:ln w="0">
+            <a:noFill/>
+            <a:prstDash val="solid"/>
+          </a:ln>
+        </p:spPr>
+        <p:txBody>
+          <a:bodyPr wrap="square" lIns="0" tIns="0" rIns="0" bIns="0" anchor="t">
+            <a:normAutofit fontScale="100000"/>
+          </a:bodyPr>
+          <a:lstStyle/>
+          <a:p>
+            <a:pPr algn="l">
+              <a:lnSpc>
+                <a:spcPct val="106000"/>
+              </a:lnSpc>
+              <a:buNone/>
+            </a:pPr>
+            <a:r>
+              <a:rPr sz="975" b="0" i="0">
+                <a:solidFill>
+                  <a:srgbClr val="6A6F73"/>
+                </a:solidFill>
+                <a:latin typeface="Arial"/>
+                <a:ea typeface="Arial"/>
+                <a:cs typeface="Arial"/>
+              </a:rPr>
+              <a:t>System assessments, thermal-imaging coordination, failure analysis and prioritized replacement planning.</a:t>
+            </a:r>
+          </a:p>
+        </p:txBody>
+      </p:sp>
+      <p:sp>
+        <p:nvSpPr>
+          <p:cNvPr id="554" name=""/>
+          <p:cNvSpPr>
+            <a:spLocks noGrp="1"/>
+          </p:cNvSpPr>
+          <p:nvPr/>
+        </p:nvSpPr>
+        <p:spPr>
+          <a:xfrm>
+            <a:off x="6235130" y="4919472"/>
+            <a:ext cx="5237862" cy="1005840"/>
+          </a:xfrm>
+          <a:prstGeom prst="rect">
+            <a:avLst/>
+          </a:prstGeom>
+          <a:solidFill>
+            <a:srgbClr val="FFFFFF"/>
+          </a:solidFill>
+          <a:ln w="9525">
+            <a:solidFill>
+              <a:srgbClr val="D8D1C8"/>
+            </a:solidFill>
+            <a:prstDash val="solid"/>
+          </a:ln>
+        </p:spPr>
+      </p:sp>
+      <p:sp>
+        <p:nvSpPr>
+          <p:cNvPr id="555" name=""/>
+          <p:cNvSpPr>
+            <a:spLocks noGrp="1"/>
+          </p:cNvSpPr>
+          <p:nvPr/>
+        </p:nvSpPr>
+        <p:spPr>
+          <a:xfrm>
+            <a:off x="6463730" y="5033772"/>
+            <a:ext cx="4780662" cy="228600"/>
+          </a:xfrm>
+          <a:prstGeom prst="rect">
+            <a:avLst/>
+          </a:prstGeom>
+          <a:noFill/>
+          <a:ln w="0">
+            <a:noFill/>
+            <a:prstDash val="solid"/>
+          </a:ln>
+        </p:spPr>
+        <p:txBody>
+          <a:bodyPr wrap="square" lIns="0" tIns="0" rIns="0" bIns="0" anchor="t">
+            <a:normAutofit fontScale="100000"/>
+          </a:bodyPr>
+          <a:lstStyle/>
+          <a:p>
+            <a:pPr algn="l">
+              <a:lnSpc>
+                <a:spcPct val="100000"/>
+              </a:lnSpc>
+              <a:buNone/>
+            </a:pPr>
+            <a:r>
+              <a:rPr sz="1050" b="1" i="0">
+                <a:solidFill>
+                  <a:srgbClr val="9D4E24"/>
+                </a:solidFill>
+                <a:latin typeface="Arial Narrow"/>
+                <a:ea typeface="Arial Narrow"/>
+                <a:cs typeface="Arial Narrow"/>
+              </a:rPr>
+              <a:t>SERVICE &amp; LONG-TERM AGREEMENTS</a:t>
+            </a:r>
+          </a:p>
+        </p:txBody>
+      </p:sp>
+      <p:sp>
+        <p:nvSpPr>
+          <p:cNvPr id="556" name=""/>
+          <p:cNvSpPr>
+            <a:spLocks noGrp="1"/>
+          </p:cNvSpPr>
+          <p:nvPr/>
+        </p:nvSpPr>
+        <p:spPr>
+          <a:xfrm>
+            <a:off x="6463730" y="5308092"/>
+            <a:ext cx="4780662" cy="540000"/>
+          </a:xfrm>
+          <a:prstGeom prst="rect">
+            <a:avLst/>
+          </a:prstGeom>
+          <a:noFill/>
+          <a:ln w="0">
+            <a:noFill/>
+            <a:prstDash val="solid"/>
+          </a:ln>
+        </p:spPr>
+        <p:txBody>
+          <a:bodyPr wrap="square" lIns="0" tIns="0" rIns="0" bIns="0" anchor="t">
+            <a:normAutofit fontScale="100000"/>
+          </a:bodyPr>
+          <a:lstStyle/>
+          <a:p>
+            <a:pPr algn="l">
+              <a:lnSpc>
+                <a:spcPct val="106000"/>
+              </a:lnSpc>
+              <a:buNone/>
+            </a:pPr>
+            <a:r>
+              <a:rPr sz="975" b="0" i="0">
+                <a:solidFill>
+                  <a:srgbClr val="6A6F73"/>
+                </a:solidFill>
+                <a:latin typeface="Arial"/>
+                <a:ea typeface="Arial"/>
+                <a:cs typeface="Arial"/>
+              </a:rPr>
+              <a:t>Support contracts, inventory programs and rapid-response replacement capability for operating fleets.</a:t>
+            </a:r>
+          </a:p>
+        </p:txBody>
+      </p:sp>
+      <p:sp>
+        <p:nvSpPr>
+          <p:cNvPr id="557" name=""/>
+          <p:cNvSpPr>
+            <a:spLocks noGrp="1"/>
+          </p:cNvSpPr>
+          <p:nvPr/>
+        </p:nvSpPr>
+        <p:spPr>
+          <a:xfrm>
+            <a:off x="719138" y="6032500"/>
+            <a:ext cx="10753724" cy="200000"/>
+          </a:xfrm>
+          <a:prstGeom prst="rect">
+            <a:avLst/>
+          </a:prstGeom>
+          <a:noFill/>
+          <a:ln w="0">
+            <a:noFill/>
+            <a:prstDash val="solid"/>
+          </a:ln>
+        </p:spPr>
+        <p:txBody>
+          <a:bodyPr wrap="square" lIns="0" tIns="0" rIns="0" bIns="0" anchor="t">
+            <a:normAutofit fontScale="100000"/>
+          </a:bodyPr>
+          <a:lstStyle/>
+          <a:p>
+            <a:pPr algn="l">
+              <a:lnSpc>
+                <a:spcPct val="100000"/>
+              </a:lnSpc>
+              <a:buNone/>
+            </a:pPr>
+            <a:r>
+              <a:rPr sz="825" b="0" i="1">
+                <a:solidFill>
+                  <a:srgbClr val="6A6F73"/>
+                </a:solidFill>
+                <a:latin typeface="Arial"/>
+                <a:ea typeface="Arial"/>
+                <a:cs typeface="Arial"/>
+              </a:rPr>
+              <a:t>Engagements begin with one focused 60–90 minute session across the fleet, then tailored proposals per plant — phased to outage schedules.</a:t>
+            </a:r>
+          </a:p>
+        </p:txBody>
+      </p:sp>
+      <p:sp>
+        <p:nvSpPr>
+          <p:cNvPr id="558" name=""/>
+          <p:cNvSpPr>
+            <a:spLocks noGrp="1"/>
+          </p:cNvSpPr>
+          <p:nvPr/>
+        </p:nvSpPr>
+        <p:spPr>
+          <a:xfrm>
+            <a:off x="719138" y="6315000"/>
+            <a:ext cx="10753724" cy="400000"/>
+          </a:xfrm>
+          <a:prstGeom prst="rect">
+            <a:avLst/>
+          </a:prstGeom>
+          <a:solidFill>
+            <a:srgbClr val="17191C"/>
+          </a:solidFill>
+          <a:ln w="0">
+            <a:noFill/>
+            <a:prstDash val="solid"/>
+          </a:ln>
+        </p:spPr>
+      </p:sp>
+      <p:sp>
+        <p:nvSpPr>
+          <p:cNvPr id="559" name=""/>
+          <p:cNvSpPr>
+            <a:spLocks noGrp="1"/>
+          </p:cNvSpPr>
+          <p:nvPr/>
+        </p:nvSpPr>
+        <p:spPr>
+          <a:xfrm>
+            <a:off x="719138" y="6315000"/>
+            <a:ext cx="10753724" cy="400000"/>
+          </a:xfrm>
+          <a:prstGeom prst="rect">
+            <a:avLst/>
+          </a:prstGeom>
+          <a:noFill/>
+          <a:ln w="0">
+            <a:noFill/>
+            <a:prstDash val="solid"/>
+          </a:ln>
+        </p:spPr>
+        <p:txBody>
+          <a:bodyPr wrap="square" lIns="0" tIns="0" rIns="0" bIns="0" anchor="ctr">
+            <a:normAutofit fontScale="100000"/>
+          </a:bodyPr>
+          <a:lstStyle/>
+          <a:p>
+            <a:pPr algn="ctr">
+              <a:lnSpc>
+                <a:spcPct val="100000"/>
+              </a:lnSpc>
+              <a:buNone/>
+            </a:pPr>
+            <a:r>
+              <a:rPr sz="1050" b="1" i="0">
+                <a:solidFill>
+                  <a:srgbClr val="FFFFFF"/>
+                </a:solidFill>
+                <a:latin typeface="Arial Narrow"/>
+                <a:ea typeface="Arial Narrow"/>
+                <a:cs typeface="Arial Narrow"/>
+              </a:rPr>
+              <a:t>MINIMIZED DOWNTIME · EXTENDED ASSET LIFE · LOWER TOTAL COST THAN FULL REPLACEMENT — PHASED TO OUTAGE SCHEDULES.</a:t>
+            </a:r>
+          </a:p>
+        </p:txBody>
+      </p:sp>
+    </p:spTree>
+  </p:cSld>
+</p:sld>
+</file>
+
 <file path=ppt/slides/slide3.xml><?xml version="1.0" encoding="utf-8"?>
 <p:sld xmlns:p="http://schemas.openxmlformats.org/presentationml/2006/main">
   <p:cSld>

</xml_diff>

<commit_message>
Add Benchmark Math appendix (A13) with anonymized source
Dollar template behind the 4,400 -> 880 hour benchmark: $418K vs $83.6K
field labor per spine, ~$334K gross delta, repeat-scale figures. Framed
as gross-not-net with pointer to the A5 release gate; counterparty and
site anonymized pending external-use permission.

Co-Authored-By: Claude Opus 5 <noreply@anthropic.com>
Claude-Session: https://claude.ai/code/session_01DUeyPCeDvcPsyTcH6oQXEK
</commit_message>
<xml_diff>
--- a/teaser-rework/Southwire_NRG_Protecting_Time_to_Power_Rev10.pptx
+++ b/teaser-rework/Southwire_NRG_Protecting_Time_to_Power_Rev10.pptx
@@ -29,6 +29,7 @@
     <p:sldId id="274" r:id="rId5"/>
     <p:sldId id="275" r:id="rId6"/>
     <p:sldId id="276" r:id="rId7"/>
+    <p:sldId id="277" r:id="rId8"/>
   </p:sldIdLst>
   <p:sldSz cx="12192000" cy="6858000"/>
   <p:notesSz cx="6858000" cy="9144000"/>
@@ -18740,6 +18741,1477 @@
 </p:sld>
 </file>
 
+<file path=ppt/slides/slide22.xml><?xml version="1.0" encoding="utf-8"?>
+<p:sld xmlns:p="http://schemas.openxmlformats.org/presentationml/2006/main" xmlns:a="http://schemas.openxmlformats.org/drawingml/2006/main" xmlns:r="http://schemas.openxmlformats.org/officeDocument/2006/relationships">
+  <p:cSld>
+    <p:bg>
+      <p:bgPr>
+        <a:solidFill>
+          <a:srgbClr val="F6F3EE"/>
+        </a:solidFill>
+      </p:bgPr>
+    </p:bg>
+    <p:spTree>
+      <p:nvGrpSpPr>
+        <p:cNvPr id="1" name=""/>
+        <p:cNvGrpSpPr/>
+        <p:nvPr/>
+      </p:nvGrpSpPr>
+      <p:grpSpPr>
+        <a:xfrm/>
+      </p:grpSpPr>
+      <p:sp>
+        <p:nvSpPr>
+          <p:cNvPr id="701" name=""/>
+          <p:cNvSpPr>
+            <a:spLocks noGrp="1"/>
+          </p:cNvSpPr>
+          <p:nvPr/>
+        </p:nvSpPr>
+        <p:spPr>
+          <a:xfrm>
+            <a:off x="0" y="0"/>
+            <a:ext cx="12192000" cy="57150"/>
+          </a:xfrm>
+          <a:prstGeom prst="rect">
+            <a:avLst/>
+          </a:prstGeom>
+          <a:solidFill>
+            <a:srgbClr val="C9783E"/>
+          </a:solidFill>
+          <a:ln w="0">
+            <a:noFill/>
+            <a:prstDash val="solid"/>
+          </a:ln>
+        </p:spPr>
+      </p:sp>
+      <p:pic>
+        <p:nvPicPr>
+          <p:cNvPr id="702" name=""/>
+          <p:cNvPicPr>
+            <a:picLocks noChangeAspect="1"/>
+          </p:cNvPicPr>
+          <p:nvPr/>
+        </p:nvPicPr>
+        <p:blipFill>
+          <a:blip r:embed="R48e2a3d3733b4264"/>
+          <a:stretch/>
+        </p:blipFill>
+        <p:spPr>
+          <a:xfrm>
+            <a:off x="719138" y="200025"/>
+            <a:ext cx="2066925" cy="590550"/>
+          </a:xfrm>
+          <a:prstGeom prst="rect">
+            <a:avLst/>
+          </a:prstGeom>
+        </p:spPr>
+      </p:pic>
+      <p:sp>
+        <p:nvSpPr>
+          <p:cNvPr id="703" name=""/>
+          <p:cNvSpPr>
+            <a:spLocks noGrp="1"/>
+          </p:cNvSpPr>
+          <p:nvPr/>
+        </p:nvSpPr>
+        <p:spPr>
+          <a:xfrm>
+            <a:off x="7325360" y="323850"/>
+            <a:ext cx="3857000" cy="228600"/>
+          </a:xfrm>
+          <a:prstGeom prst="rect">
+            <a:avLst/>
+          </a:prstGeom>
+          <a:noFill/>
+          <a:ln w="0">
+            <a:noFill/>
+            <a:prstDash val="solid"/>
+          </a:ln>
+        </p:spPr>
+        <p:txBody>
+          <a:bodyPr wrap="square" lIns="0" tIns="0" rIns="0" bIns="0" anchor="t">
+            <a:normAutofit fontScale="100000"/>
+          </a:bodyPr>
+          <a:lstStyle/>
+          <a:p>
+            <a:pPr algn="r">
+              <a:lnSpc>
+                <a:spcPct val="100000"/>
+              </a:lnSpc>
+              <a:buNone/>
+            </a:pPr>
+            <a:r>
+              <a:rPr sz="975" b="1" i="0">
+                <a:solidFill>
+                  <a:srgbClr val="9D4E24"/>
+                </a:solidFill>
+                <a:latin typeface="Arial Narrow"/>
+                <a:ea typeface="Arial Narrow"/>
+                <a:cs typeface="Arial Narrow"/>
+              </a:rPr>
+              <a:t>APPENDIX A13 · BENCHMARK MATH</a:t>
+            </a:r>
+          </a:p>
+        </p:txBody>
+      </p:sp>
+      <p:sp>
+        <p:nvSpPr>
+          <p:cNvPr id="704" name=""/>
+          <p:cNvSpPr>
+            <a:spLocks noGrp="1"/>
+          </p:cNvSpPr>
+          <p:nvPr/>
+        </p:nvSpPr>
+        <p:spPr>
+          <a:xfrm>
+            <a:off x="11334750" y="323850"/>
+            <a:ext cx="323850" cy="228600"/>
+          </a:xfrm>
+          <a:prstGeom prst="rect">
+            <a:avLst/>
+          </a:prstGeom>
+          <a:noFill/>
+          <a:ln w="0">
+            <a:noFill/>
+            <a:prstDash val="solid"/>
+          </a:ln>
+        </p:spPr>
+        <p:txBody>
+          <a:bodyPr wrap="square" lIns="0" tIns="0" rIns="0" bIns="0" anchor="t">
+            <a:normAutofit fontScale="100000"/>
+          </a:bodyPr>
+          <a:lstStyle/>
+          <a:p>
+            <a:pPr algn="r">
+              <a:lnSpc>
+                <a:spcPct val="100000"/>
+              </a:lnSpc>
+              <a:buNone/>
+            </a:pPr>
+            <a:r>
+              <a:rPr sz="975" b="1" i="0">
+                <a:solidFill>
+                  <a:srgbClr val="8B9094"/>
+                </a:solidFill>
+                <a:latin typeface="Arial Narrow"/>
+                <a:ea typeface="Arial Narrow"/>
+                <a:cs typeface="Arial Narrow"/>
+              </a:rPr>
+              <a:t>22</a:t>
+            </a:r>
+          </a:p>
+        </p:txBody>
+      </p:sp>
+      <p:sp>
+        <p:nvSpPr>
+          <p:cNvPr id="705" name=""/>
+          <p:cNvSpPr>
+            <a:spLocks noGrp="1"/>
+          </p:cNvSpPr>
+          <p:nvPr/>
+        </p:nvSpPr>
+        <p:spPr>
+          <a:xfrm>
+            <a:off x="719138" y="1005840"/>
+            <a:ext cx="9000000" cy="228600"/>
+          </a:xfrm>
+          <a:prstGeom prst="rect">
+            <a:avLst/>
+          </a:prstGeom>
+          <a:noFill/>
+          <a:ln w="0">
+            <a:noFill/>
+            <a:prstDash val="solid"/>
+          </a:ln>
+        </p:spPr>
+        <p:txBody>
+          <a:bodyPr wrap="square" lIns="0" tIns="0" rIns="0" bIns="0" anchor="t">
+            <a:normAutofit fontScale="100000"/>
+          </a:bodyPr>
+          <a:lstStyle/>
+          <a:p>
+            <a:pPr algn="l">
+              <a:lnSpc>
+                <a:spcPct val="100000"/>
+              </a:lnSpc>
+              <a:buNone/>
+            </a:pPr>
+            <a:r>
+              <a:rPr sz="1050" b="1" i="0">
+                <a:solidFill>
+                  <a:srgbClr val="C9783E"/>
+                </a:solidFill>
+                <a:latin typeface="Arial Narrow"/>
+                <a:ea typeface="Arial Narrow"/>
+                <a:cs typeface="Arial Narrow"/>
+              </a:rPr>
+              <a:t>GROSS FIELD-LABOR MATH — PER CENTRAL SPINE</a:t>
+            </a:r>
+          </a:p>
+        </p:txBody>
+      </p:sp>
+      <p:sp>
+        <p:nvSpPr>
+          <p:cNvPr id="706" name=""/>
+          <p:cNvSpPr>
+            <a:spLocks noGrp="1"/>
+          </p:cNvSpPr>
+          <p:nvPr/>
+        </p:nvSpPr>
+        <p:spPr>
+          <a:xfrm>
+            <a:off x="719138" y="1280160"/>
+            <a:ext cx="10753724" cy="500000"/>
+          </a:xfrm>
+          <a:prstGeom prst="rect">
+            <a:avLst/>
+          </a:prstGeom>
+          <a:noFill/>
+          <a:ln w="0">
+            <a:noFill/>
+            <a:prstDash val="solid"/>
+          </a:ln>
+        </p:spPr>
+        <p:txBody>
+          <a:bodyPr wrap="square" lIns="0" tIns="0" rIns="0" bIns="0" anchor="t">
+            <a:normAutofit fontScale="100000"/>
+          </a:bodyPr>
+          <a:lstStyle/>
+          <a:p>
+            <a:pPr algn="l">
+              <a:lnSpc>
+                <a:spcPct val="104000"/>
+              </a:lnSpc>
+              <a:buNone/>
+            </a:pPr>
+            <a:r>
+              <a:rPr sz="2850" b="1" i="0">
+                <a:solidFill>
+                  <a:srgbClr val="17191C"/>
+                </a:solidFill>
+                <a:latin typeface="Arial"/>
+                <a:ea typeface="Arial"/>
+                <a:cs typeface="Arial"/>
+              </a:rPr>
+              <a:t>What the 4,400 → 880 hours are worth, before net.</a:t>
+            </a:r>
+          </a:p>
+        </p:txBody>
+      </p:sp>
+      <p:sp>
+        <p:nvSpPr>
+          <p:cNvPr id="707" name=""/>
+          <p:cNvSpPr>
+            <a:spLocks noGrp="1"/>
+          </p:cNvSpPr>
+          <p:nvPr/>
+        </p:nvSpPr>
+        <p:spPr>
+          <a:xfrm>
+            <a:off x="719138" y="1950720"/>
+            <a:ext cx="10753724" cy="300000"/>
+          </a:xfrm>
+          <a:prstGeom prst="rect">
+            <a:avLst/>
+          </a:prstGeom>
+          <a:noFill/>
+          <a:ln w="0">
+            <a:noFill/>
+            <a:prstDash val="solid"/>
+          </a:ln>
+        </p:spPr>
+        <p:txBody>
+          <a:bodyPr wrap="square" lIns="0" tIns="0" rIns="0" bIns="0" anchor="t">
+            <a:normAutofit fontScale="100000"/>
+          </a:bodyPr>
+          <a:lstStyle/>
+          <a:p>
+            <a:pPr algn="l">
+              <a:lnSpc>
+                <a:spcPct val="108000"/>
+              </a:lnSpc>
+              <a:buNone/>
+            </a:pPr>
+            <a:r>
+              <a:rPr sz="1050" b="0" i="0">
+                <a:solidFill>
+                  <a:srgbClr val="6A6F73"/>
+                </a:solidFill>
+                <a:latin typeface="Arial"/>
+                <a:ea typeface="Arial"/>
+                <a:cs typeface="Arial"/>
+              </a:rPr>
+              <a:t>The arithmetic behind slide 7, at a $95/hr fully burdened field-labor rate. This is the template A5 requires to be rebuilt with NRG inputs — not a result.</a:t>
+            </a:r>
+          </a:p>
+        </p:txBody>
+      </p:sp>
+      <p:sp>
+        <p:nvSpPr>
+          <p:cNvPr id="708" name=""/>
+          <p:cNvSpPr>
+            <a:spLocks noGrp="1"/>
+          </p:cNvSpPr>
+          <p:nvPr/>
+        </p:nvSpPr>
+        <p:spPr>
+          <a:xfrm>
+            <a:off x="719138" y="2560320"/>
+            <a:ext cx="3378908" cy="2606040"/>
+          </a:xfrm>
+          <a:prstGeom prst="rect">
+            <a:avLst/>
+          </a:prstGeom>
+          <a:solidFill>
+            <a:srgbClr val="FFFFFF"/>
+          </a:solidFill>
+          <a:ln w="9525">
+            <a:solidFill>
+              <a:srgbClr val="D8D1C8"/>
+            </a:solidFill>
+            <a:prstDash val="solid"/>
+          </a:ln>
+        </p:spPr>
+      </p:sp>
+      <p:sp>
+        <p:nvSpPr>
+          <p:cNvPr id="709" name=""/>
+          <p:cNvSpPr>
+            <a:spLocks noGrp="1"/>
+          </p:cNvSpPr>
+          <p:nvPr/>
+        </p:nvSpPr>
+        <p:spPr>
+          <a:xfrm>
+            <a:off x="947738" y="2788920"/>
+            <a:ext cx="2921708" cy="228600"/>
+          </a:xfrm>
+          <a:prstGeom prst="rect">
+            <a:avLst/>
+          </a:prstGeom>
+          <a:noFill/>
+          <a:ln w="0">
+            <a:noFill/>
+            <a:prstDash val="solid"/>
+          </a:ln>
+        </p:spPr>
+        <p:txBody>
+          <a:bodyPr wrap="square" lIns="0" tIns="0" rIns="0" bIns="0" anchor="t">
+            <a:normAutofit fontScale="100000"/>
+          </a:bodyPr>
+          <a:lstStyle/>
+          <a:p>
+            <a:pPr algn="l">
+              <a:lnSpc>
+                <a:spcPct val="100000"/>
+              </a:lnSpc>
+              <a:buNone/>
+            </a:pPr>
+            <a:r>
+              <a:rPr sz="975" b="1" i="0">
+                <a:solidFill>
+                  <a:srgbClr val="9D4E24"/>
+                </a:solidFill>
+                <a:latin typeface="Arial Narrow"/>
+                <a:ea typeface="Arial Narrow"/>
+                <a:cs typeface="Arial Narrow"/>
+              </a:rPr>
+              <a:t>TODAY · FIELD-BUILT</a:t>
+            </a:r>
+          </a:p>
+        </p:txBody>
+      </p:sp>
+      <p:sp>
+        <p:nvSpPr>
+          <p:cNvPr id="710" name=""/>
+          <p:cNvSpPr>
+            <a:spLocks noGrp="1"/>
+          </p:cNvSpPr>
+          <p:nvPr/>
+        </p:nvSpPr>
+        <p:spPr>
+          <a:xfrm>
+            <a:off x="947738" y="3108960"/>
+            <a:ext cx="2921708" cy="640080"/>
+          </a:xfrm>
+          <a:prstGeom prst="rect">
+            <a:avLst/>
+          </a:prstGeom>
+          <a:noFill/>
+          <a:ln w="0">
+            <a:noFill/>
+            <a:prstDash val="solid"/>
+          </a:ln>
+        </p:spPr>
+        <p:txBody>
+          <a:bodyPr wrap="square" lIns="0" tIns="0" rIns="0" bIns="0" anchor="t">
+            <a:normAutofit fontScale="100000"/>
+          </a:bodyPr>
+          <a:lstStyle/>
+          <a:p>
+            <a:pPr algn="l">
+              <a:lnSpc>
+                <a:spcPct val="100000"/>
+              </a:lnSpc>
+              <a:buNone/>
+            </a:pPr>
+            <a:r>
+              <a:rPr sz="3400" b="1" i="0">
+                <a:solidFill>
+                  <a:srgbClr val="17191C"/>
+                </a:solidFill>
+                <a:latin typeface="Arial"/>
+                <a:ea typeface="Arial"/>
+                <a:cs typeface="Arial"/>
+              </a:rPr>
+              <a:t>$418,000</a:t>
+            </a:r>
+          </a:p>
+        </p:txBody>
+      </p:sp>
+      <p:sp>
+        <p:nvSpPr>
+          <p:cNvPr id="711" name=""/>
+          <p:cNvSpPr>
+            <a:spLocks noGrp="1"/>
+          </p:cNvSpPr>
+          <p:nvPr/>
+        </p:nvSpPr>
+        <p:spPr>
+          <a:xfrm>
+            <a:off x="947738" y="3749040"/>
+            <a:ext cx="2921708" cy="228600"/>
+          </a:xfrm>
+          <a:prstGeom prst="rect">
+            <a:avLst/>
+          </a:prstGeom>
+          <a:noFill/>
+          <a:ln w="0">
+            <a:noFill/>
+            <a:prstDash val="solid"/>
+          </a:ln>
+        </p:spPr>
+        <p:txBody>
+          <a:bodyPr wrap="square" lIns="0" tIns="0" rIns="0" bIns="0" anchor="t">
+            <a:normAutofit fontScale="100000"/>
+          </a:bodyPr>
+          <a:lstStyle/>
+          <a:p>
+            <a:pPr algn="l">
+              <a:lnSpc>
+                <a:spcPct val="100000"/>
+              </a:lnSpc>
+              <a:buNone/>
+            </a:pPr>
+            <a:r>
+              <a:rPr sz="975" b="0" i="0">
+                <a:solidFill>
+                  <a:srgbClr val="6A6F73"/>
+                </a:solidFill>
+                <a:latin typeface="Arial"/>
+                <a:ea typeface="Arial"/>
+                <a:cs typeface="Arial"/>
+              </a:rPr>
+              <a:t>field labor per spine</a:t>
+            </a:r>
+          </a:p>
+        </p:txBody>
+      </p:sp>
+      <p:sp>
+        <p:nvSpPr>
+          <p:cNvPr id="712" name=""/>
+          <p:cNvSpPr>
+            <a:spLocks noGrp="1"/>
+          </p:cNvSpPr>
+          <p:nvPr/>
+        </p:nvSpPr>
+        <p:spPr>
+          <a:xfrm>
+            <a:off x="947738" y="4160520"/>
+            <a:ext cx="2921708" cy="274320"/>
+          </a:xfrm>
+          <a:prstGeom prst="rect">
+            <a:avLst/>
+          </a:prstGeom>
+          <a:noFill/>
+          <a:ln w="0">
+            <a:noFill/>
+            <a:prstDash val="solid"/>
+          </a:ln>
+        </p:spPr>
+        <p:txBody>
+          <a:bodyPr wrap="square" lIns="0" tIns="0" rIns="0" bIns="0" anchor="t">
+            <a:normAutofit fontScale="100000"/>
+          </a:bodyPr>
+          <a:lstStyle/>
+          <a:p>
+            <a:pPr algn="l">
+              <a:lnSpc>
+                <a:spcPct val="100000"/>
+              </a:lnSpc>
+              <a:buNone/>
+            </a:pPr>
+            <a:r>
+              <a:rPr sz="1050" b="0" i="0">
+                <a:solidFill>
+                  <a:srgbClr val="17191C"/>
+                </a:solidFill>
+                <a:latin typeface="Arial"/>
+                <a:ea typeface="Arial"/>
+                <a:cs typeface="Arial"/>
+              </a:rPr>
+              <a:t>4,400 man-hours × $95/hr</a:t>
+            </a:r>
+          </a:p>
+        </p:txBody>
+      </p:sp>
+      <p:sp>
+        <p:nvSpPr>
+          <p:cNvPr id="713" name=""/>
+          <p:cNvSpPr>
+            <a:spLocks noGrp="1"/>
+          </p:cNvSpPr>
+          <p:nvPr/>
+        </p:nvSpPr>
+        <p:spPr>
+          <a:xfrm>
+            <a:off x="947738" y="4434840"/>
+            <a:ext cx="2921708" cy="274320"/>
+          </a:xfrm>
+          <a:prstGeom prst="rect">
+            <a:avLst/>
+          </a:prstGeom>
+          <a:noFill/>
+          <a:ln w="0">
+            <a:noFill/>
+            <a:prstDash val="solid"/>
+          </a:ln>
+        </p:spPr>
+        <p:txBody>
+          <a:bodyPr wrap="square" lIns="0" tIns="0" rIns="0" bIns="0" anchor="t">
+            <a:normAutofit fontScale="100000"/>
+          </a:bodyPr>
+          <a:lstStyle/>
+          <a:p>
+            <a:pPr algn="l">
+              <a:lnSpc>
+                <a:spcPct val="100000"/>
+              </a:lnSpc>
+              <a:buNone/>
+            </a:pPr>
+            <a:r>
+              <a:rPr sz="1050" b="0" i="0">
+                <a:solidFill>
+                  <a:srgbClr val="17191C"/>
+                </a:solidFill>
+                <a:latin typeface="Arial"/>
+                <a:ea typeface="Arial"/>
+                <a:cs typeface="Arial"/>
+              </a:rPr>
+              <a:t>27 installers × 2 shifts × 2 weeks</a:t>
+            </a:r>
+          </a:p>
+        </p:txBody>
+      </p:sp>
+      <p:sp>
+        <p:nvSpPr>
+          <p:cNvPr id="714" name=""/>
+          <p:cNvSpPr>
+            <a:spLocks noGrp="1"/>
+          </p:cNvSpPr>
+          <p:nvPr/>
+        </p:nvSpPr>
+        <p:spPr>
+          <a:xfrm>
+            <a:off x="947738" y="4709160"/>
+            <a:ext cx="2921708" cy="274320"/>
+          </a:xfrm>
+          <a:prstGeom prst="rect">
+            <a:avLst/>
+          </a:prstGeom>
+          <a:noFill/>
+          <a:ln w="0">
+            <a:noFill/>
+            <a:prstDash val="solid"/>
+          </a:ln>
+        </p:spPr>
+        <p:txBody>
+          <a:bodyPr wrap="square" lIns="0" tIns="0" rIns="0" bIns="0" anchor="t">
+            <a:normAutofit fontScale="100000"/>
+          </a:bodyPr>
+          <a:lstStyle/>
+          <a:p>
+            <a:pPr algn="l">
+              <a:lnSpc>
+                <a:spcPct val="100000"/>
+              </a:lnSpc>
+              <a:buNone/>
+            </a:pPr>
+            <a:r>
+              <a:rPr sz="1050" b="1" i="0">
+                <a:solidFill>
+                  <a:srgbClr val="6A6F73"/>
+                </a:solidFill>
+                <a:latin typeface="Arial"/>
+                <a:ea typeface="Arial"/>
+                <a:cs typeface="Arial"/>
+              </a:rPr>
+              <a:t>High variability, rework risk</a:t>
+            </a:r>
+          </a:p>
+        </p:txBody>
+      </p:sp>
+      <p:sp>
+        <p:nvSpPr>
+          <p:cNvPr id="715" name=""/>
+          <p:cNvSpPr>
+            <a:spLocks noGrp="1"/>
+          </p:cNvSpPr>
+          <p:nvPr/>
+        </p:nvSpPr>
+        <p:spPr>
+          <a:xfrm>
+            <a:off x="4406546" y="2560320"/>
+            <a:ext cx="3378908" cy="2606040"/>
+          </a:xfrm>
+          <a:prstGeom prst="rect">
+            <a:avLst/>
+          </a:prstGeom>
+          <a:solidFill>
+            <a:srgbClr val="FFFFFF"/>
+          </a:solidFill>
+          <a:ln w="9525">
+            <a:solidFill>
+              <a:srgbClr val="D8D1C8"/>
+            </a:solidFill>
+            <a:prstDash val="solid"/>
+          </a:ln>
+        </p:spPr>
+      </p:sp>
+      <p:sp>
+        <p:nvSpPr>
+          <p:cNvPr id="716" name=""/>
+          <p:cNvSpPr>
+            <a:spLocks noGrp="1"/>
+          </p:cNvSpPr>
+          <p:nvPr/>
+        </p:nvSpPr>
+        <p:spPr>
+          <a:xfrm>
+            <a:off x="4635146" y="2788920"/>
+            <a:ext cx="2921708" cy="228600"/>
+          </a:xfrm>
+          <a:prstGeom prst="rect">
+            <a:avLst/>
+          </a:prstGeom>
+          <a:noFill/>
+          <a:ln w="0">
+            <a:noFill/>
+            <a:prstDash val="solid"/>
+          </a:ln>
+        </p:spPr>
+        <p:txBody>
+          <a:bodyPr wrap="square" lIns="0" tIns="0" rIns="0" bIns="0" anchor="t">
+            <a:normAutofit fontScale="100000"/>
+          </a:bodyPr>
+          <a:lstStyle/>
+          <a:p>
+            <a:pPr algn="l">
+              <a:lnSpc>
+                <a:spcPct val="100000"/>
+              </a:lnSpc>
+              <a:buNone/>
+            </a:pPr>
+            <a:r>
+              <a:rPr sz="975" b="1" i="0">
+                <a:solidFill>
+                  <a:srgbClr val="9D4E24"/>
+                </a:solidFill>
+                <a:latin typeface="Arial Narrow"/>
+                <a:ea typeface="Arial Narrow"/>
+                <a:cs typeface="Arial Narrow"/>
+              </a:rPr>
+              <a:t>WITH CONNECTORIZED ASSEMBLY</a:t>
+            </a:r>
+          </a:p>
+        </p:txBody>
+      </p:sp>
+      <p:sp>
+        <p:nvSpPr>
+          <p:cNvPr id="717" name=""/>
+          <p:cNvSpPr>
+            <a:spLocks noGrp="1"/>
+          </p:cNvSpPr>
+          <p:nvPr/>
+        </p:nvSpPr>
+        <p:spPr>
+          <a:xfrm>
+            <a:off x="4635146" y="3108960"/>
+            <a:ext cx="2921708" cy="640080"/>
+          </a:xfrm>
+          <a:prstGeom prst="rect">
+            <a:avLst/>
+          </a:prstGeom>
+          <a:noFill/>
+          <a:ln w="0">
+            <a:noFill/>
+            <a:prstDash val="solid"/>
+          </a:ln>
+        </p:spPr>
+        <p:txBody>
+          <a:bodyPr wrap="square" lIns="0" tIns="0" rIns="0" bIns="0" anchor="t">
+            <a:normAutofit fontScale="100000"/>
+          </a:bodyPr>
+          <a:lstStyle/>
+          <a:p>
+            <a:pPr algn="l">
+              <a:lnSpc>
+                <a:spcPct val="100000"/>
+              </a:lnSpc>
+              <a:buNone/>
+            </a:pPr>
+            <a:r>
+              <a:rPr sz="3400" b="1" i="0">
+                <a:solidFill>
+                  <a:srgbClr val="9D4E24"/>
+                </a:solidFill>
+                <a:latin typeface="Arial"/>
+                <a:ea typeface="Arial"/>
+                <a:cs typeface="Arial"/>
+              </a:rPr>
+              <a:t>$83,600</a:t>
+            </a:r>
+          </a:p>
+        </p:txBody>
+      </p:sp>
+      <p:sp>
+        <p:nvSpPr>
+          <p:cNvPr id="718" name=""/>
+          <p:cNvSpPr>
+            <a:spLocks noGrp="1"/>
+          </p:cNvSpPr>
+          <p:nvPr/>
+        </p:nvSpPr>
+        <p:spPr>
+          <a:xfrm>
+            <a:off x="4635146" y="3749040"/>
+            <a:ext cx="2921708" cy="228600"/>
+          </a:xfrm>
+          <a:prstGeom prst="rect">
+            <a:avLst/>
+          </a:prstGeom>
+          <a:noFill/>
+          <a:ln w="0">
+            <a:noFill/>
+            <a:prstDash val="solid"/>
+          </a:ln>
+        </p:spPr>
+        <p:txBody>
+          <a:bodyPr wrap="square" lIns="0" tIns="0" rIns="0" bIns="0" anchor="t">
+            <a:normAutofit fontScale="100000"/>
+          </a:bodyPr>
+          <a:lstStyle/>
+          <a:p>
+            <a:pPr algn="l">
+              <a:lnSpc>
+                <a:spcPct val="100000"/>
+              </a:lnSpc>
+              <a:buNone/>
+            </a:pPr>
+            <a:r>
+              <a:rPr sz="975" b="0" i="0">
+                <a:solidFill>
+                  <a:srgbClr val="6A6F73"/>
+                </a:solidFill>
+                <a:latin typeface="Arial"/>
+                <a:ea typeface="Arial"/>
+                <a:cs typeface="Arial"/>
+              </a:rPr>
+              <a:t>field labor per spine</a:t>
+            </a:r>
+          </a:p>
+        </p:txBody>
+      </p:sp>
+      <p:sp>
+        <p:nvSpPr>
+          <p:cNvPr id="719" name=""/>
+          <p:cNvSpPr>
+            <a:spLocks noGrp="1"/>
+          </p:cNvSpPr>
+          <p:nvPr/>
+        </p:nvSpPr>
+        <p:spPr>
+          <a:xfrm>
+            <a:off x="4635146" y="4160520"/>
+            <a:ext cx="2921708" cy="274320"/>
+          </a:xfrm>
+          <a:prstGeom prst="rect">
+            <a:avLst/>
+          </a:prstGeom>
+          <a:noFill/>
+          <a:ln w="0">
+            <a:noFill/>
+            <a:prstDash val="solid"/>
+          </a:ln>
+        </p:spPr>
+        <p:txBody>
+          <a:bodyPr wrap="square" lIns="0" tIns="0" rIns="0" bIns="0" anchor="t">
+            <a:normAutofit fontScale="100000"/>
+          </a:bodyPr>
+          <a:lstStyle/>
+          <a:p>
+            <a:pPr algn="l">
+              <a:lnSpc>
+                <a:spcPct val="100000"/>
+              </a:lnSpc>
+              <a:buNone/>
+            </a:pPr>
+            <a:r>
+              <a:rPr sz="1050" b="0" i="0">
+                <a:solidFill>
+                  <a:srgbClr val="17191C"/>
+                </a:solidFill>
+                <a:latin typeface="Arial"/>
+                <a:ea typeface="Arial"/>
+                <a:cs typeface="Arial"/>
+              </a:rPr>
+              <a:t>~880 man-hours × $95/hr</a:t>
+            </a:r>
+          </a:p>
+        </p:txBody>
+      </p:sp>
+      <p:sp>
+        <p:nvSpPr>
+          <p:cNvPr id="720" name=""/>
+          <p:cNvSpPr>
+            <a:spLocks noGrp="1"/>
+          </p:cNvSpPr>
+          <p:nvPr/>
+        </p:nvSpPr>
+        <p:spPr>
+          <a:xfrm>
+            <a:off x="4635146" y="4434840"/>
+            <a:ext cx="2921708" cy="274320"/>
+          </a:xfrm>
+          <a:prstGeom prst="rect">
+            <a:avLst/>
+          </a:prstGeom>
+          <a:noFill/>
+          <a:ln w="0">
+            <a:noFill/>
+            <a:prstDash val="solid"/>
+          </a:ln>
+        </p:spPr>
+        <p:txBody>
+          <a:bodyPr wrap="square" lIns="0" tIns="0" rIns="0" bIns="0" anchor="t">
+            <a:normAutofit fontScale="100000"/>
+          </a:bodyPr>
+          <a:lstStyle/>
+          <a:p>
+            <a:pPr algn="l">
+              <a:lnSpc>
+                <a:spcPct val="100000"/>
+              </a:lnSpc>
+              <a:buNone/>
+            </a:pPr>
+            <a:r>
+              <a:rPr sz="1050" b="0" i="0">
+                <a:solidFill>
+                  <a:srgbClr val="17191C"/>
+                </a:solidFill>
+                <a:latin typeface="Arial"/>
+                <a:ea typeface="Arial"/>
+                <a:cs typeface="Arial"/>
+              </a:rPr>
+              <a:t>~6 installers × 1 shift × ~3 days</a:t>
+            </a:r>
+          </a:p>
+        </p:txBody>
+      </p:sp>
+      <p:sp>
+        <p:nvSpPr>
+          <p:cNvPr id="721" name=""/>
+          <p:cNvSpPr>
+            <a:spLocks noGrp="1"/>
+          </p:cNvSpPr>
+          <p:nvPr/>
+        </p:nvSpPr>
+        <p:spPr>
+          <a:xfrm>
+            <a:off x="4635146" y="4709160"/>
+            <a:ext cx="2921708" cy="274320"/>
+          </a:xfrm>
+          <a:prstGeom prst="rect">
+            <a:avLst/>
+          </a:prstGeom>
+          <a:noFill/>
+          <a:ln w="0">
+            <a:noFill/>
+            <a:prstDash val="solid"/>
+          </a:ln>
+        </p:spPr>
+        <p:txBody>
+          <a:bodyPr wrap="square" lIns="0" tIns="0" rIns="0" bIns="0" anchor="t">
+            <a:normAutofit fontScale="100000"/>
+          </a:bodyPr>
+          <a:lstStyle/>
+          <a:p>
+            <a:pPr algn="l">
+              <a:lnSpc>
+                <a:spcPct val="100000"/>
+              </a:lnSpc>
+              <a:buNone/>
+            </a:pPr>
+            <a:r>
+              <a:rPr sz="1050" b="1" i="0">
+                <a:solidFill>
+                  <a:srgbClr val="6A6F73"/>
+                </a:solidFill>
+                <a:latin typeface="Arial"/>
+                <a:ea typeface="Arial"/>
+                <a:cs typeface="Arial"/>
+              </a:rPr>
+              <a:t>Factory-validated, plug-and-play</a:t>
+            </a:r>
+          </a:p>
+        </p:txBody>
+      </p:sp>
+      <p:sp>
+        <p:nvSpPr>
+          <p:cNvPr id="722" name=""/>
+          <p:cNvSpPr>
+            <a:spLocks noGrp="1"/>
+          </p:cNvSpPr>
+          <p:nvPr/>
+        </p:nvSpPr>
+        <p:spPr>
+          <a:xfrm>
+            <a:off x="8093954" y="2560320"/>
+            <a:ext cx="3378908" cy="2606040"/>
+          </a:xfrm>
+          <a:prstGeom prst="rect">
+            <a:avLst/>
+          </a:prstGeom>
+          <a:solidFill>
+            <a:srgbClr val="C9783E"/>
+          </a:solidFill>
+          <a:ln w="0">
+            <a:noFill/>
+            <a:prstDash val="solid"/>
+          </a:ln>
+        </p:spPr>
+      </p:sp>
+      <p:sp>
+        <p:nvSpPr>
+          <p:cNvPr id="723" name=""/>
+          <p:cNvSpPr>
+            <a:spLocks noGrp="1"/>
+          </p:cNvSpPr>
+          <p:nvPr/>
+        </p:nvSpPr>
+        <p:spPr>
+          <a:xfrm>
+            <a:off x="8322554" y="2788920"/>
+            <a:ext cx="2921708" cy="228600"/>
+          </a:xfrm>
+          <a:prstGeom prst="rect">
+            <a:avLst/>
+          </a:prstGeom>
+          <a:noFill/>
+          <a:ln w="0">
+            <a:noFill/>
+            <a:prstDash val="solid"/>
+          </a:ln>
+        </p:spPr>
+        <p:txBody>
+          <a:bodyPr wrap="square" lIns="0" tIns="0" rIns="0" bIns="0" anchor="t">
+            <a:normAutofit fontScale="100000"/>
+          </a:bodyPr>
+          <a:lstStyle/>
+          <a:p>
+            <a:pPr algn="l">
+              <a:lnSpc>
+                <a:spcPct val="100000"/>
+              </a:lnSpc>
+              <a:buNone/>
+            </a:pPr>
+            <a:r>
+              <a:rPr sz="975" b="1" i="0">
+                <a:solidFill>
+                  <a:srgbClr val="FFFFFF"/>
+                </a:solidFill>
+                <a:latin typeface="Arial Narrow"/>
+                <a:ea typeface="Arial Narrow"/>
+                <a:cs typeface="Arial Narrow"/>
+              </a:rPr>
+              <a:t>GROSS DELTA PER SPINE</a:t>
+            </a:r>
+          </a:p>
+        </p:txBody>
+      </p:sp>
+      <p:sp>
+        <p:nvSpPr>
+          <p:cNvPr id="724" name=""/>
+          <p:cNvSpPr>
+            <a:spLocks noGrp="1"/>
+          </p:cNvSpPr>
+          <p:nvPr/>
+        </p:nvSpPr>
+        <p:spPr>
+          <a:xfrm>
+            <a:off x="8322554" y="3108960"/>
+            <a:ext cx="2921708" cy="640080"/>
+          </a:xfrm>
+          <a:prstGeom prst="rect">
+            <a:avLst/>
+          </a:prstGeom>
+          <a:noFill/>
+          <a:ln w="0">
+            <a:noFill/>
+            <a:prstDash val="solid"/>
+          </a:ln>
+        </p:spPr>
+        <p:txBody>
+          <a:bodyPr wrap="square" lIns="0" tIns="0" rIns="0" bIns="0" anchor="t">
+            <a:normAutofit fontScale="100000"/>
+          </a:bodyPr>
+          <a:lstStyle/>
+          <a:p>
+            <a:pPr algn="l">
+              <a:lnSpc>
+                <a:spcPct val="100000"/>
+              </a:lnSpc>
+              <a:buNone/>
+            </a:pPr>
+            <a:r>
+              <a:rPr sz="3400" b="1" i="0">
+                <a:solidFill>
+                  <a:srgbClr val="FFFFFF"/>
+                </a:solidFill>
+                <a:latin typeface="Arial"/>
+                <a:ea typeface="Arial"/>
+                <a:cs typeface="Arial"/>
+              </a:rPr>
+              <a:t>$334K</a:t>
+            </a:r>
+          </a:p>
+        </p:txBody>
+      </p:sp>
+      <p:sp>
+        <p:nvSpPr>
+          <p:cNvPr id="725" name=""/>
+          <p:cNvSpPr>
+            <a:spLocks noGrp="1"/>
+          </p:cNvSpPr>
+          <p:nvPr/>
+        </p:nvSpPr>
+        <p:spPr>
+          <a:xfrm>
+            <a:off x="8322554" y="3749040"/>
+            <a:ext cx="2921708" cy="228600"/>
+          </a:xfrm>
+          <a:prstGeom prst="rect">
+            <a:avLst/>
+          </a:prstGeom>
+          <a:noFill/>
+          <a:ln w="0">
+            <a:noFill/>
+            <a:prstDash val="solid"/>
+          </a:ln>
+        </p:spPr>
+        <p:txBody>
+          <a:bodyPr wrap="square" lIns="0" tIns="0" rIns="0" bIns="0" anchor="t">
+            <a:normAutofit fontScale="100000"/>
+          </a:bodyPr>
+          <a:lstStyle/>
+          <a:p>
+            <a:pPr algn="l">
+              <a:lnSpc>
+                <a:spcPct val="100000"/>
+              </a:lnSpc>
+              <a:buNone/>
+            </a:pPr>
+            <a:r>
+              <a:rPr sz="975" b="0" i="0">
+                <a:solidFill>
+                  <a:srgbClr val="FFFFFF"/>
+                </a:solidFill>
+                <a:latin typeface="Arial"/>
+                <a:ea typeface="Arial"/>
+                <a:cs typeface="Arial"/>
+              </a:rPr>
+              <a:t>~80% of field-labor cost</a:t>
+            </a:r>
+          </a:p>
+        </p:txBody>
+      </p:sp>
+      <p:sp>
+        <p:nvSpPr>
+          <p:cNvPr id="726" name=""/>
+          <p:cNvSpPr>
+            <a:spLocks noGrp="1"/>
+          </p:cNvSpPr>
+          <p:nvPr/>
+        </p:nvSpPr>
+        <p:spPr>
+          <a:xfrm>
+            <a:off x="8322554" y="4114800"/>
+            <a:ext cx="2921708" cy="228600"/>
+          </a:xfrm>
+          <a:prstGeom prst="rect">
+            <a:avLst/>
+          </a:prstGeom>
+          <a:noFill/>
+          <a:ln w="0">
+            <a:noFill/>
+            <a:prstDash val="solid"/>
+          </a:ln>
+        </p:spPr>
+        <p:txBody>
+          <a:bodyPr wrap="square" lIns="0" tIns="0" rIns="0" bIns="0" anchor="t">
+            <a:normAutofit fontScale="100000"/>
+          </a:bodyPr>
+          <a:lstStyle/>
+          <a:p>
+            <a:pPr algn="l">
+              <a:lnSpc>
+                <a:spcPct val="100000"/>
+              </a:lnSpc>
+              <a:buNone/>
+            </a:pPr>
+            <a:r>
+              <a:rPr sz="900" b="1" i="0">
+                <a:solidFill>
+                  <a:srgbClr val="FFFFFF"/>
+                </a:solidFill>
+                <a:latin typeface="Arial Narrow"/>
+                <a:ea typeface="Arial Narrow"/>
+                <a:cs typeface="Arial Narrow"/>
+              </a:rPr>
+              <a:t>IF IT REPEATS (GROSS, ILLUSTRATIVE)</a:t>
+            </a:r>
+          </a:p>
+        </p:txBody>
+      </p:sp>
+      <p:sp>
+        <p:nvSpPr>
+          <p:cNvPr id="727" name=""/>
+          <p:cNvSpPr>
+            <a:spLocks noGrp="1"/>
+          </p:cNvSpPr>
+          <p:nvPr/>
+        </p:nvSpPr>
+        <p:spPr>
+          <a:xfrm>
+            <a:off x="8322554" y="4389120"/>
+            <a:ext cx="2921708" cy="228600"/>
+          </a:xfrm>
+          <a:prstGeom prst="rect">
+            <a:avLst/>
+          </a:prstGeom>
+          <a:noFill/>
+          <a:ln w="0">
+            <a:noFill/>
+            <a:prstDash val="solid"/>
+          </a:ln>
+        </p:spPr>
+        <p:txBody>
+          <a:bodyPr wrap="square" lIns="0" tIns="0" rIns="0" bIns="0" anchor="t">
+            <a:normAutofit fontScale="100000"/>
+          </a:bodyPr>
+          <a:lstStyle/>
+          <a:p>
+            <a:pPr algn="l">
+              <a:lnSpc>
+                <a:spcPct val="100000"/>
+              </a:lnSpc>
+              <a:buNone/>
+            </a:pPr>
+            <a:r>
+              <a:rPr sz="1050" b="1" i="0">
+                <a:solidFill>
+                  <a:srgbClr val="FFFFFF"/>
+                </a:solidFill>
+                <a:latin typeface="Arial"/>
+                <a:ea typeface="Arial"/>
+                <a:cs typeface="Arial"/>
+              </a:rPr>
+              <a:t>10 spines  →  $3.3M</a:t>
+            </a:r>
+          </a:p>
+        </p:txBody>
+      </p:sp>
+      <p:sp>
+        <p:nvSpPr>
+          <p:cNvPr id="728" name=""/>
+          <p:cNvSpPr>
+            <a:spLocks noGrp="1"/>
+          </p:cNvSpPr>
+          <p:nvPr/>
+        </p:nvSpPr>
+        <p:spPr>
+          <a:xfrm>
+            <a:off x="8322554" y="4617720"/>
+            <a:ext cx="2921708" cy="228600"/>
+          </a:xfrm>
+          <a:prstGeom prst="rect">
+            <a:avLst/>
+          </a:prstGeom>
+          <a:noFill/>
+          <a:ln w="0">
+            <a:noFill/>
+            <a:prstDash val="solid"/>
+          </a:ln>
+        </p:spPr>
+        <p:txBody>
+          <a:bodyPr wrap="square" lIns="0" tIns="0" rIns="0" bIns="0" anchor="t">
+            <a:normAutofit fontScale="100000"/>
+          </a:bodyPr>
+          <a:lstStyle/>
+          <a:p>
+            <a:pPr algn="l">
+              <a:lnSpc>
+                <a:spcPct val="100000"/>
+              </a:lnSpc>
+              <a:buNone/>
+            </a:pPr>
+            <a:r>
+              <a:rPr sz="1050" b="1" i="0">
+                <a:solidFill>
+                  <a:srgbClr val="FFFFFF"/>
+                </a:solidFill>
+                <a:latin typeface="Arial"/>
+                <a:ea typeface="Arial"/>
+                <a:cs typeface="Arial"/>
+              </a:rPr>
+              <a:t>50 spines  →  $16.7M</a:t>
+            </a:r>
+          </a:p>
+        </p:txBody>
+      </p:sp>
+      <p:sp>
+        <p:nvSpPr>
+          <p:cNvPr id="729" name=""/>
+          <p:cNvSpPr>
+            <a:spLocks noGrp="1"/>
+          </p:cNvSpPr>
+          <p:nvPr/>
+        </p:nvSpPr>
+        <p:spPr>
+          <a:xfrm>
+            <a:off x="8322554" y="4846320"/>
+            <a:ext cx="2921708" cy="228600"/>
+          </a:xfrm>
+          <a:prstGeom prst="rect">
+            <a:avLst/>
+          </a:prstGeom>
+          <a:noFill/>
+          <a:ln w="0">
+            <a:noFill/>
+            <a:prstDash val="solid"/>
+          </a:ln>
+        </p:spPr>
+        <p:txBody>
+          <a:bodyPr wrap="square" lIns="0" tIns="0" rIns="0" bIns="0" anchor="t">
+            <a:normAutofit fontScale="100000"/>
+          </a:bodyPr>
+          <a:lstStyle/>
+          <a:p>
+            <a:pPr algn="l">
+              <a:lnSpc>
+                <a:spcPct val="100000"/>
+              </a:lnSpc>
+              <a:buNone/>
+            </a:pPr>
+            <a:r>
+              <a:rPr sz="1050" b="1" i="0">
+                <a:solidFill>
+                  <a:srgbClr val="FFFFFF"/>
+                </a:solidFill>
+                <a:latin typeface="Arial"/>
+                <a:ea typeface="Arial"/>
+                <a:cs typeface="Arial"/>
+              </a:rPr>
+              <a:t>100 spines  →  $33.4M</a:t>
+            </a:r>
+          </a:p>
+        </p:txBody>
+      </p:sp>
+      <p:sp>
+        <p:nvSpPr>
+          <p:cNvPr id="730" name=""/>
+          <p:cNvSpPr>
+            <a:spLocks noGrp="1"/>
+          </p:cNvSpPr>
+          <p:nvPr/>
+        </p:nvSpPr>
+        <p:spPr>
+          <a:xfrm>
+            <a:off x="719138" y="5349240"/>
+            <a:ext cx="10753724" cy="300000"/>
+          </a:xfrm>
+          <a:prstGeom prst="rect">
+            <a:avLst/>
+          </a:prstGeom>
+          <a:noFill/>
+          <a:ln w="0">
+            <a:noFill/>
+            <a:prstDash val="solid"/>
+          </a:ln>
+        </p:spPr>
+        <p:txBody>
+          <a:bodyPr wrap="square" lIns="0" tIns="0" rIns="0" bIns="0" anchor="t">
+            <a:normAutofit fontScale="100000"/>
+          </a:bodyPr>
+          <a:lstStyle/>
+          <a:p>
+            <a:pPr algn="l">
+              <a:lnSpc>
+                <a:spcPct val="106000"/>
+              </a:lnSpc>
+              <a:buNone/>
+            </a:pPr>
+            <a:r>
+              <a:rPr sz="900" b="0" i="1">
+                <a:solidFill>
+                  <a:srgbClr val="6A6F73"/>
+                </a:solidFill>
+                <a:latin typeface="Arial"/>
+                <a:ea typeface="Arial"/>
+                <a:cs typeface="Arial"/>
+              </a:rPr>
+              <a:t>ASSUMPTIONS  ·  $95/hr fully burdened (wage + benefits + overtime + supervision)  ·  4,400 hours observed on one site-built spine in an adjacent market, May 2026  ·  ~80% field-labor reduction typical for prefabricated interconnect  ·  one spine = one central electrical spine serving repeated generation modules.</a:t>
+            </a:r>
+          </a:p>
+        </p:txBody>
+      </p:sp>
+      <p:sp>
+        <p:nvSpPr>
+          <p:cNvPr id="731" name=""/>
+          <p:cNvSpPr>
+            <a:spLocks noGrp="1"/>
+          </p:cNvSpPr>
+          <p:nvPr/>
+        </p:nvSpPr>
+        <p:spPr>
+          <a:xfrm>
+            <a:off x="719138" y="5852160"/>
+            <a:ext cx="10753724" cy="300000"/>
+          </a:xfrm>
+          <a:prstGeom prst="rect">
+            <a:avLst/>
+          </a:prstGeom>
+          <a:noFill/>
+          <a:ln w="0">
+            <a:noFill/>
+            <a:prstDash val="solid"/>
+          </a:ln>
+        </p:spPr>
+        <p:txBody>
+          <a:bodyPr wrap="square" lIns="0" tIns="0" rIns="0" bIns="0" anchor="t">
+            <a:normAutofit fontScale="100000"/>
+          </a:bodyPr>
+          <a:lstStyle/>
+          <a:p>
+            <a:pPr algn="l">
+              <a:lnSpc>
+                <a:spcPct val="106000"/>
+              </a:lnSpc>
+              <a:buNone/>
+            </a:pPr>
+            <a:r>
+              <a:rPr sz="975" b="1" i="0">
+                <a:solidFill>
+                  <a:srgbClr val="17191C"/>
+                </a:solidFill>
+                <a:latin typeface="Arial"/>
+                <a:ea typeface="Arial"/>
+                <a:cs typeface="Arial"/>
+              </a:rPr>
+              <a:t>NOT NET.  Subtract the assembly premium, engineering, factory labor, freight, factory acceptance and commissioning — and prefabrication does not automatically remove an activity from the critical path.</a:t>
+            </a:r>
+          </a:p>
+        </p:txBody>
+      </p:sp>
+      <p:sp>
+        <p:nvSpPr>
+          <p:cNvPr id="732" name=""/>
+          <p:cNvSpPr>
+            <a:spLocks noGrp="1"/>
+          </p:cNvSpPr>
+          <p:nvPr/>
+        </p:nvSpPr>
+        <p:spPr>
+          <a:xfrm>
+            <a:off x="719138" y="6315000"/>
+            <a:ext cx="10753724" cy="400000"/>
+          </a:xfrm>
+          <a:prstGeom prst="rect">
+            <a:avLst/>
+          </a:prstGeom>
+          <a:solidFill>
+            <a:srgbClr val="17191C"/>
+          </a:solidFill>
+          <a:ln w="0">
+            <a:noFill/>
+            <a:prstDash val="solid"/>
+          </a:ln>
+        </p:spPr>
+      </p:sp>
+      <p:sp>
+        <p:nvSpPr>
+          <p:cNvPr id="733" name=""/>
+          <p:cNvSpPr>
+            <a:spLocks noGrp="1"/>
+          </p:cNvSpPr>
+          <p:nvPr/>
+        </p:nvSpPr>
+        <p:spPr>
+          <a:xfrm>
+            <a:off x="719138" y="6315000"/>
+            <a:ext cx="10753724" cy="400000"/>
+          </a:xfrm>
+          <a:prstGeom prst="rect">
+            <a:avLst/>
+          </a:prstGeom>
+          <a:noFill/>
+          <a:ln w="0">
+            <a:noFill/>
+            <a:prstDash val="solid"/>
+          </a:ln>
+        </p:spPr>
+        <p:txBody>
+          <a:bodyPr wrap="square" lIns="0" tIns="0" rIns="0" bIns="0" anchor="ctr">
+            <a:normAutofit fontScale="100000"/>
+          </a:bodyPr>
+          <a:lstStyle/>
+          <a:p>
+            <a:pPr algn="ctr">
+              <a:lnSpc>
+                <a:spcPct val="100000"/>
+              </a:lnSpc>
+              <a:buNone/>
+            </a:pPr>
+            <a:r>
+              <a:rPr sz="1050" b="1" i="0">
+                <a:solidFill>
+                  <a:srgbClr val="FFFFFF"/>
+                </a:solidFill>
+                <a:latin typeface="Arial Narrow"/>
+                <a:ea typeface="Arial Narrow"/>
+                <a:cs typeface="Arial Narrow"/>
+              </a:rPr>
+              <a:t>GROSS TEMPLATE ONLY — REBUILD WITH NRG SCOPE, LABOR RATES AND SCHEDULE LOGIC BEFORE ANY CLAIM (SEE A5).</a:t>
+            </a:r>
+          </a:p>
+        </p:txBody>
+      </p:sp>
+    </p:spTree>
+  </p:cSld>
+</p:sld>
+</file>
+
 <file path=ppt/slides/slide3.xml><?xml version="1.0" encoding="utf-8"?>
 <p:sld xmlns:p="http://schemas.openxmlformats.org/presentationml/2006/main">
   <p:cSld>

</xml_diff>

<commit_message>
Add Modular Economics appendix (A14) as second prefab data point
50 MW skid deployment-block case supporting A13 at different scale and
market, with explicit reconciliation of the $95/hr vs $180/hr rate basis.
C7 corridor economics excluded (utility buyer, not IPP); cooling OEM case
excluded (named partner archetype).

Co-Authored-By: Claude Opus 5 <noreply@anthropic.com>
Claude-Session: https://claude.ai/code/session_01DUeyPCeDvcPsyTcH6oQXEK
</commit_message>
<xml_diff>
--- a/teaser-rework/Southwire_NRG_Protecting_Time_to_Power_Rev10.pptx
+++ b/teaser-rework/Southwire_NRG_Protecting_Time_to_Power_Rev10.pptx
@@ -30,6 +30,7 @@
     <p:sldId id="275" r:id="rId6"/>
     <p:sldId id="276" r:id="rId7"/>
     <p:sldId id="277" r:id="rId8"/>
+    <p:sldId id="278" r:id="rId9"/>
   </p:sldIdLst>
   <p:sldSz cx="12192000" cy="6858000"/>
   <p:notesSz cx="6858000" cy="9144000"/>
@@ -20212,6 +20213,1477 @@
 </p:sld>
 </file>
 
+<file path=ppt/slides/slide23.xml><?xml version="1.0" encoding="utf-8"?>
+<p:sld xmlns:p="http://schemas.openxmlformats.org/presentationml/2006/main" xmlns:a="http://schemas.openxmlformats.org/drawingml/2006/main" xmlns:r="http://schemas.openxmlformats.org/officeDocument/2006/relationships">
+  <p:cSld>
+    <p:bg>
+      <p:bgPr>
+        <a:solidFill>
+          <a:srgbClr val="F6F3EE"/>
+        </a:solidFill>
+      </p:bgPr>
+    </p:bg>
+    <p:spTree>
+      <p:nvGrpSpPr>
+        <p:cNvPr id="1" name=""/>
+        <p:cNvGrpSpPr/>
+        <p:nvPr/>
+      </p:nvGrpSpPr>
+      <p:grpSpPr>
+        <a:xfrm/>
+      </p:grpSpPr>
+      <p:sp>
+        <p:nvSpPr>
+          <p:cNvPr id="901" name=""/>
+          <p:cNvSpPr>
+            <a:spLocks noGrp="1"/>
+          </p:cNvSpPr>
+          <p:nvPr/>
+        </p:nvSpPr>
+        <p:spPr>
+          <a:xfrm>
+            <a:off x="0" y="0"/>
+            <a:ext cx="12192000" cy="57150"/>
+          </a:xfrm>
+          <a:prstGeom prst="rect">
+            <a:avLst/>
+          </a:prstGeom>
+          <a:solidFill>
+            <a:srgbClr val="C9783E"/>
+          </a:solidFill>
+          <a:ln w="0">
+            <a:noFill/>
+            <a:prstDash val="solid"/>
+          </a:ln>
+        </p:spPr>
+      </p:sp>
+      <p:pic>
+        <p:nvPicPr>
+          <p:cNvPr id="902" name=""/>
+          <p:cNvPicPr>
+            <a:picLocks noChangeAspect="1"/>
+          </p:cNvPicPr>
+          <p:nvPr/>
+        </p:nvPicPr>
+        <p:blipFill>
+          <a:blip r:embed="R48e2a3d3733b4264"/>
+          <a:stretch/>
+        </p:blipFill>
+        <p:spPr>
+          <a:xfrm>
+            <a:off x="719138" y="200025"/>
+            <a:ext cx="2066925" cy="590550"/>
+          </a:xfrm>
+          <a:prstGeom prst="rect">
+            <a:avLst/>
+          </a:prstGeom>
+        </p:spPr>
+      </p:pic>
+      <p:sp>
+        <p:nvSpPr>
+          <p:cNvPr id="903" name=""/>
+          <p:cNvSpPr>
+            <a:spLocks noGrp="1"/>
+          </p:cNvSpPr>
+          <p:nvPr/>
+        </p:nvSpPr>
+        <p:spPr>
+          <a:xfrm>
+            <a:off x="7325360" y="323850"/>
+            <a:ext cx="3857000" cy="228600"/>
+          </a:xfrm>
+          <a:prstGeom prst="rect">
+            <a:avLst/>
+          </a:prstGeom>
+          <a:noFill/>
+          <a:ln w="0">
+            <a:noFill/>
+            <a:prstDash val="solid"/>
+          </a:ln>
+        </p:spPr>
+        <p:txBody>
+          <a:bodyPr wrap="square" lIns="0" tIns="0" rIns="0" bIns="0" anchor="t">
+            <a:normAutofit fontScale="100000"/>
+          </a:bodyPr>
+          <a:lstStyle/>
+          <a:p>
+            <a:pPr algn="r">
+              <a:lnSpc>
+                <a:spcPct val="100000"/>
+              </a:lnSpc>
+              <a:buNone/>
+            </a:pPr>
+            <a:r>
+              <a:rPr sz="975" b="1" i="0">
+                <a:solidFill>
+                  <a:srgbClr val="9D4E24"/>
+                </a:solidFill>
+                <a:latin typeface="Arial Narrow"/>
+                <a:ea typeface="Arial Narrow"/>
+                <a:cs typeface="Arial Narrow"/>
+              </a:rPr>
+              <a:t>APPENDIX A14 · MODULAR ECONOMICS</a:t>
+            </a:r>
+          </a:p>
+        </p:txBody>
+      </p:sp>
+      <p:sp>
+        <p:nvSpPr>
+          <p:cNvPr id="904" name=""/>
+          <p:cNvSpPr>
+            <a:spLocks noGrp="1"/>
+          </p:cNvSpPr>
+          <p:nvPr/>
+        </p:nvSpPr>
+        <p:spPr>
+          <a:xfrm>
+            <a:off x="11334750" y="323850"/>
+            <a:ext cx="323850" cy="228600"/>
+          </a:xfrm>
+          <a:prstGeom prst="rect">
+            <a:avLst/>
+          </a:prstGeom>
+          <a:noFill/>
+          <a:ln w="0">
+            <a:noFill/>
+            <a:prstDash val="solid"/>
+          </a:ln>
+        </p:spPr>
+        <p:txBody>
+          <a:bodyPr wrap="square" lIns="0" tIns="0" rIns="0" bIns="0" anchor="t">
+            <a:normAutofit fontScale="100000"/>
+          </a:bodyPr>
+          <a:lstStyle/>
+          <a:p>
+            <a:pPr algn="r">
+              <a:lnSpc>
+                <a:spcPct val="100000"/>
+              </a:lnSpc>
+              <a:buNone/>
+            </a:pPr>
+            <a:r>
+              <a:rPr sz="975" b="1" i="0">
+                <a:solidFill>
+                  <a:srgbClr val="8B9094"/>
+                </a:solidFill>
+                <a:latin typeface="Arial Narrow"/>
+                <a:ea typeface="Arial Narrow"/>
+                <a:cs typeface="Arial Narrow"/>
+              </a:rPr>
+              <a:t>23</a:t>
+            </a:r>
+          </a:p>
+        </p:txBody>
+      </p:sp>
+      <p:sp>
+        <p:nvSpPr>
+          <p:cNvPr id="905" name=""/>
+          <p:cNvSpPr>
+            <a:spLocks noGrp="1"/>
+          </p:cNvSpPr>
+          <p:nvPr/>
+        </p:nvSpPr>
+        <p:spPr>
+          <a:xfrm>
+            <a:off x="719138" y="1005840"/>
+            <a:ext cx="9000000" cy="228600"/>
+          </a:xfrm>
+          <a:prstGeom prst="rect">
+            <a:avLst/>
+          </a:prstGeom>
+          <a:noFill/>
+          <a:ln w="0">
+            <a:noFill/>
+            <a:prstDash val="solid"/>
+          </a:ln>
+        </p:spPr>
+        <p:txBody>
+          <a:bodyPr wrap="square" lIns="0" tIns="0" rIns="0" bIns="0" anchor="t">
+            <a:normAutofit fontScale="100000"/>
+          </a:bodyPr>
+          <a:lstStyle/>
+          <a:p>
+            <a:pPr algn="l">
+              <a:lnSpc>
+                <a:spcPct val="100000"/>
+              </a:lnSpc>
+              <a:buNone/>
+            </a:pPr>
+            <a:r>
+              <a:rPr sz="1050" b="1" i="0">
+                <a:solidFill>
+                  <a:srgbClr val="C9783E"/>
+                </a:solidFill>
+                <a:latin typeface="Arial Narrow"/>
+                <a:ea typeface="Arial Narrow"/>
+                <a:cs typeface="Arial Narrow"/>
+              </a:rPr>
+              <a:t>SECOND CASE — DEPLOYMENT-BLOCK SCALE</a:t>
+            </a:r>
+          </a:p>
+        </p:txBody>
+      </p:sp>
+      <p:sp>
+        <p:nvSpPr>
+          <p:cNvPr id="906" name=""/>
+          <p:cNvSpPr>
+            <a:spLocks noGrp="1"/>
+          </p:cNvSpPr>
+          <p:nvPr/>
+        </p:nvSpPr>
+        <p:spPr>
+          <a:xfrm>
+            <a:off x="719138" y="1280160"/>
+            <a:ext cx="10753724" cy="500000"/>
+          </a:xfrm>
+          <a:prstGeom prst="rect">
+            <a:avLst/>
+          </a:prstGeom>
+          <a:noFill/>
+          <a:ln w="0">
+            <a:noFill/>
+            <a:prstDash val="solid"/>
+          </a:ln>
+        </p:spPr>
+        <p:txBody>
+          <a:bodyPr wrap="square" lIns="0" tIns="0" rIns="0" bIns="0" anchor="t">
+            <a:normAutofit fontScale="100000"/>
+          </a:bodyPr>
+          <a:lstStyle/>
+          <a:p>
+            <a:pPr algn="l">
+              <a:lnSpc>
+                <a:spcPct val="104000"/>
+              </a:lnSpc>
+              <a:buNone/>
+            </a:pPr>
+            <a:r>
+              <a:rPr sz="2850" b="1" i="0">
+                <a:solidFill>
+                  <a:srgbClr val="17191C"/>
+                </a:solidFill>
+                <a:latin typeface="Arial"/>
+                <a:ea typeface="Arial"/>
+                <a:cs typeface="Arial"/>
+              </a:rPr>
+              <a:t>The same mechanism at package scale, from a different market.</a:t>
+            </a:r>
+          </a:p>
+        </p:txBody>
+      </p:sp>
+      <p:sp>
+        <p:nvSpPr>
+          <p:cNvPr id="907" name=""/>
+          <p:cNvSpPr>
+            <a:spLocks noGrp="1"/>
+          </p:cNvSpPr>
+          <p:nvPr/>
+        </p:nvSpPr>
+        <p:spPr>
+          <a:xfrm>
+            <a:off x="719138" y="1950720"/>
+            <a:ext cx="10753724" cy="300000"/>
+          </a:xfrm>
+          <a:prstGeom prst="rect">
+            <a:avLst/>
+          </a:prstGeom>
+          <a:noFill/>
+          <a:ln w="0">
+            <a:noFill/>
+            <a:prstDash val="solid"/>
+          </a:ln>
+        </p:spPr>
+        <p:txBody>
+          <a:bodyPr wrap="square" lIns="0" tIns="0" rIns="0" bIns="0" anchor="t">
+            <a:normAutofit fontScale="100000"/>
+          </a:bodyPr>
+          <a:lstStyle/>
+          <a:p>
+            <a:pPr algn="l">
+              <a:lnSpc>
+                <a:spcPct val="108000"/>
+              </a:lnSpc>
+              <a:buNone/>
+            </a:pPr>
+            <a:r>
+              <a:rPr sz="1050" b="0" i="0">
+                <a:solidFill>
+                  <a:srgbClr val="6A6F73"/>
+                </a:solidFill>
+                <a:latin typeface="Arial"/>
+                <a:ea typeface="Arial"/>
+                <a:cs typeface="Arial"/>
+              </a:rPr>
+              <a:t>An illustrative 50 MW distribution-skid deployment block, modeled independently of A13. Two cases, two markets, one mechanism: onsite hours moved into the factory.</a:t>
+            </a:r>
+          </a:p>
+        </p:txBody>
+      </p:sp>
+      <p:sp>
+        <p:nvSpPr>
+          <p:cNvPr id="908" name=""/>
+          <p:cNvSpPr>
+            <a:spLocks noGrp="1"/>
+          </p:cNvSpPr>
+          <p:nvPr/>
+        </p:nvSpPr>
+        <p:spPr>
+          <a:xfrm>
+            <a:off x="719138" y="2377440"/>
+            <a:ext cx="3378908" cy="2469540"/>
+          </a:xfrm>
+          <a:prstGeom prst="rect">
+            <a:avLst/>
+          </a:prstGeom>
+          <a:solidFill>
+            <a:srgbClr val="FFFFFF"/>
+          </a:solidFill>
+          <a:ln w="9525">
+            <a:solidFill>
+              <a:srgbClr val="D8D1C8"/>
+            </a:solidFill>
+            <a:prstDash val="solid"/>
+          </a:ln>
+        </p:spPr>
+      </p:sp>
+      <p:sp>
+        <p:nvSpPr>
+          <p:cNvPr id="909" name=""/>
+          <p:cNvSpPr>
+            <a:spLocks noGrp="1"/>
+          </p:cNvSpPr>
+          <p:nvPr/>
+        </p:nvSpPr>
+        <p:spPr>
+          <a:xfrm>
+            <a:off x="947738" y="2606040"/>
+            <a:ext cx="2921708" cy="228600"/>
+          </a:xfrm>
+          <a:prstGeom prst="rect">
+            <a:avLst/>
+          </a:prstGeom>
+          <a:noFill/>
+          <a:ln w="0">
+            <a:noFill/>
+            <a:prstDash val="solid"/>
+          </a:ln>
+        </p:spPr>
+        <p:txBody>
+          <a:bodyPr wrap="square" lIns="0" tIns="0" rIns="0" bIns="0" anchor="t">
+            <a:normAutofit fontScale="100000"/>
+          </a:bodyPr>
+          <a:lstStyle/>
+          <a:p>
+            <a:pPr algn="l">
+              <a:lnSpc>
+                <a:spcPct val="100000"/>
+              </a:lnSpc>
+              <a:buNone/>
+            </a:pPr>
+            <a:r>
+              <a:rPr sz="975" b="1" i="0">
+                <a:solidFill>
+                  <a:srgbClr val="9D4E24"/>
+                </a:solidFill>
+                <a:latin typeface="Arial Narrow"/>
+                <a:ea typeface="Arial Narrow"/>
+                <a:cs typeface="Arial Narrow"/>
+              </a:rPr>
+              <a:t>TRADITIONAL FIELD BUILD</a:t>
+            </a:r>
+          </a:p>
+        </p:txBody>
+      </p:sp>
+      <p:sp>
+        <p:nvSpPr>
+          <p:cNvPr id="910" name=""/>
+          <p:cNvSpPr>
+            <a:spLocks noGrp="1"/>
+          </p:cNvSpPr>
+          <p:nvPr/>
+        </p:nvSpPr>
+        <p:spPr>
+          <a:xfrm>
+            <a:off x="947738" y="2880360"/>
+            <a:ext cx="2921708" cy="594360"/>
+          </a:xfrm>
+          <a:prstGeom prst="rect">
+            <a:avLst/>
+          </a:prstGeom>
+          <a:noFill/>
+          <a:ln w="0">
+            <a:noFill/>
+            <a:prstDash val="solid"/>
+          </a:ln>
+        </p:spPr>
+        <p:txBody>
+          <a:bodyPr wrap="square" lIns="0" tIns="0" rIns="0" bIns="0" anchor="t">
+            <a:normAutofit fontScale="100000"/>
+          </a:bodyPr>
+          <a:lstStyle/>
+          <a:p>
+            <a:pPr algn="l">
+              <a:lnSpc>
+                <a:spcPct val="100000"/>
+              </a:lnSpc>
+              <a:buNone/>
+            </a:pPr>
+            <a:r>
+              <a:rPr sz="3200" b="1" i="0">
+                <a:solidFill>
+                  <a:srgbClr val="17191C"/>
+                </a:solidFill>
+                <a:latin typeface="Arial"/>
+                <a:ea typeface="Arial"/>
+                <a:cs typeface="Arial"/>
+              </a:rPr>
+              <a:t>8–12 wks</a:t>
+            </a:r>
+          </a:p>
+        </p:txBody>
+      </p:sp>
+      <p:sp>
+        <p:nvSpPr>
+          <p:cNvPr id="911" name=""/>
+          <p:cNvSpPr>
+            <a:spLocks noGrp="1"/>
+          </p:cNvSpPr>
+          <p:nvPr/>
+        </p:nvSpPr>
+        <p:spPr>
+          <a:xfrm>
+            <a:off x="947738" y="3474720"/>
+            <a:ext cx="2921708" cy="228600"/>
+          </a:xfrm>
+          <a:prstGeom prst="rect">
+            <a:avLst/>
+          </a:prstGeom>
+          <a:noFill/>
+          <a:ln w="0">
+            <a:noFill/>
+            <a:prstDash val="solid"/>
+          </a:ln>
+        </p:spPr>
+        <p:txBody>
+          <a:bodyPr wrap="square" lIns="0" tIns="0" rIns="0" bIns="0" anchor="t">
+            <a:normAutofit fontScale="100000"/>
+          </a:bodyPr>
+          <a:lstStyle/>
+          <a:p>
+            <a:pPr algn="l">
+              <a:lnSpc>
+                <a:spcPct val="100000"/>
+              </a:lnSpc>
+              <a:buNone/>
+            </a:pPr>
+            <a:r>
+              <a:rPr sz="975" b="0" i="0">
+                <a:solidFill>
+                  <a:srgbClr val="6A6F73"/>
+                </a:solidFill>
+                <a:latin typeface="Arial"/>
+                <a:ea typeface="Arial"/>
+                <a:cs typeface="Arial"/>
+              </a:rPr>
+              <a:t>install + commissioning</a:t>
+            </a:r>
+          </a:p>
+        </p:txBody>
+      </p:sp>
+      <p:sp>
+        <p:nvSpPr>
+          <p:cNvPr id="912" name=""/>
+          <p:cNvSpPr>
+            <a:spLocks noGrp="1"/>
+          </p:cNvSpPr>
+          <p:nvPr/>
+        </p:nvSpPr>
+        <p:spPr>
+          <a:xfrm>
+            <a:off x="947738" y="3794760"/>
+            <a:ext cx="2921708" cy="274320"/>
+          </a:xfrm>
+          <a:prstGeom prst="rect">
+            <a:avLst/>
+          </a:prstGeom>
+          <a:noFill/>
+          <a:ln w="0">
+            <a:noFill/>
+            <a:prstDash val="solid"/>
+          </a:ln>
+        </p:spPr>
+        <p:txBody>
+          <a:bodyPr wrap="square" lIns="0" tIns="0" rIns="0" bIns="0" anchor="t">
+            <a:normAutofit fontScale="100000"/>
+          </a:bodyPr>
+          <a:lstStyle/>
+          <a:p>
+            <a:pPr algn="l">
+              <a:lnSpc>
+                <a:spcPct val="100000"/>
+              </a:lnSpc>
+              <a:buNone/>
+            </a:pPr>
+            <a:r>
+              <a:rPr sz="1050" b="0" i="0">
+                <a:solidFill>
+                  <a:srgbClr val="17191C"/>
+                </a:solidFill>
+                <a:latin typeface="Arial"/>
+                <a:ea typeface="Arial"/>
+                <a:cs typeface="Arial"/>
+              </a:rPr>
+              <a:t>15 electricians × 10 weeks</a:t>
+            </a:r>
+          </a:p>
+        </p:txBody>
+      </p:sp>
+      <p:sp>
+        <p:nvSpPr>
+          <p:cNvPr id="913" name=""/>
+          <p:cNvSpPr>
+            <a:spLocks noGrp="1"/>
+          </p:cNvSpPr>
+          <p:nvPr/>
+        </p:nvSpPr>
+        <p:spPr>
+          <a:xfrm>
+            <a:off x="947738" y="4069080"/>
+            <a:ext cx="2921708" cy="274320"/>
+          </a:xfrm>
+          <a:prstGeom prst="rect">
+            <a:avLst/>
+          </a:prstGeom>
+          <a:noFill/>
+          <a:ln w="0">
+            <a:noFill/>
+            <a:prstDash val="solid"/>
+          </a:ln>
+        </p:spPr>
+        <p:txBody>
+          <a:bodyPr wrap="square" lIns="0" tIns="0" rIns="0" bIns="0" anchor="t">
+            <a:normAutofit fontScale="100000"/>
+          </a:bodyPr>
+          <a:lstStyle/>
+          <a:p>
+            <a:pPr algn="l">
+              <a:lnSpc>
+                <a:spcPct val="100000"/>
+              </a:lnSpc>
+              <a:buNone/>
+            </a:pPr>
+            <a:r>
+              <a:rPr sz="1050" b="0" i="0">
+                <a:solidFill>
+                  <a:srgbClr val="17191C"/>
+                </a:solidFill>
+                <a:latin typeface="Arial"/>
+                <a:ea typeface="Arial"/>
+                <a:cs typeface="Arial"/>
+              </a:rPr>
+              <a:t>~$1.1M–$1.5M field labor</a:t>
+            </a:r>
+          </a:p>
+        </p:txBody>
+      </p:sp>
+      <p:sp>
+        <p:nvSpPr>
+          <p:cNvPr id="914" name=""/>
+          <p:cNvSpPr>
+            <a:spLocks noGrp="1"/>
+          </p:cNvSpPr>
+          <p:nvPr/>
+        </p:nvSpPr>
+        <p:spPr>
+          <a:xfrm>
+            <a:off x="947738" y="4343400"/>
+            <a:ext cx="2921708" cy="274320"/>
+          </a:xfrm>
+          <a:prstGeom prst="rect">
+            <a:avLst/>
+          </a:prstGeom>
+          <a:noFill/>
+          <a:ln w="0">
+            <a:noFill/>
+            <a:prstDash val="solid"/>
+          </a:ln>
+        </p:spPr>
+        <p:txBody>
+          <a:bodyPr wrap="square" lIns="0" tIns="0" rIns="0" bIns="0" anchor="t">
+            <a:normAutofit fontScale="100000"/>
+          </a:bodyPr>
+          <a:lstStyle/>
+          <a:p>
+            <a:pPr algn="l">
+              <a:lnSpc>
+                <a:spcPct val="100000"/>
+              </a:lnSpc>
+              <a:buNone/>
+            </a:pPr>
+            <a:r>
+              <a:rPr sz="1050" b="1" i="0">
+                <a:solidFill>
+                  <a:srgbClr val="6A6F73"/>
+                </a:solidFill>
+                <a:latin typeface="Arial"/>
+                <a:ea typeface="Arial"/>
+                <a:cs typeface="Arial"/>
+              </a:rPr>
+              <a:t>Weather, rework, multi-trade risk</a:t>
+            </a:r>
+          </a:p>
+        </p:txBody>
+      </p:sp>
+      <p:sp>
+        <p:nvSpPr>
+          <p:cNvPr id="915" name=""/>
+          <p:cNvSpPr>
+            <a:spLocks noGrp="1"/>
+          </p:cNvSpPr>
+          <p:nvPr/>
+        </p:nvSpPr>
+        <p:spPr>
+          <a:xfrm>
+            <a:off x="4406546" y="2377440"/>
+            <a:ext cx="3378908" cy="2469540"/>
+          </a:xfrm>
+          <a:prstGeom prst="rect">
+            <a:avLst/>
+          </a:prstGeom>
+          <a:solidFill>
+            <a:srgbClr val="FFFFFF"/>
+          </a:solidFill>
+          <a:ln w="9525">
+            <a:solidFill>
+              <a:srgbClr val="D8D1C8"/>
+            </a:solidFill>
+            <a:prstDash val="solid"/>
+          </a:ln>
+        </p:spPr>
+      </p:sp>
+      <p:sp>
+        <p:nvSpPr>
+          <p:cNvPr id="916" name=""/>
+          <p:cNvSpPr>
+            <a:spLocks noGrp="1"/>
+          </p:cNvSpPr>
+          <p:nvPr/>
+        </p:nvSpPr>
+        <p:spPr>
+          <a:xfrm>
+            <a:off x="4635146" y="2606040"/>
+            <a:ext cx="2921708" cy="228600"/>
+          </a:xfrm>
+          <a:prstGeom prst="rect">
+            <a:avLst/>
+          </a:prstGeom>
+          <a:noFill/>
+          <a:ln w="0">
+            <a:noFill/>
+            <a:prstDash val="solid"/>
+          </a:ln>
+        </p:spPr>
+        <p:txBody>
+          <a:bodyPr wrap="square" lIns="0" tIns="0" rIns="0" bIns="0" anchor="t">
+            <a:normAutofit fontScale="100000"/>
+          </a:bodyPr>
+          <a:lstStyle/>
+          <a:p>
+            <a:pPr algn="l">
+              <a:lnSpc>
+                <a:spcPct val="100000"/>
+              </a:lnSpc>
+              <a:buNone/>
+            </a:pPr>
+            <a:r>
+              <a:rPr sz="975" b="1" i="0">
+                <a:solidFill>
+                  <a:srgbClr val="9D4E24"/>
+                </a:solidFill>
+                <a:latin typeface="Arial Narrow"/>
+                <a:ea typeface="Arial Narrow"/>
+                <a:cs typeface="Arial Narrow"/>
+              </a:rPr>
+              <a:t>WITH PREFABRICATED CABLE</a:t>
+            </a:r>
+          </a:p>
+        </p:txBody>
+      </p:sp>
+      <p:sp>
+        <p:nvSpPr>
+          <p:cNvPr id="917" name=""/>
+          <p:cNvSpPr>
+            <a:spLocks noGrp="1"/>
+          </p:cNvSpPr>
+          <p:nvPr/>
+        </p:nvSpPr>
+        <p:spPr>
+          <a:xfrm>
+            <a:off x="4635146" y="2880360"/>
+            <a:ext cx="2921708" cy="594360"/>
+          </a:xfrm>
+          <a:prstGeom prst="rect">
+            <a:avLst/>
+          </a:prstGeom>
+          <a:noFill/>
+          <a:ln w="0">
+            <a:noFill/>
+            <a:prstDash val="solid"/>
+          </a:ln>
+        </p:spPr>
+        <p:txBody>
+          <a:bodyPr wrap="square" lIns="0" tIns="0" rIns="0" bIns="0" anchor="t">
+            <a:normAutofit fontScale="100000"/>
+          </a:bodyPr>
+          <a:lstStyle/>
+          <a:p>
+            <a:pPr algn="l">
+              <a:lnSpc>
+                <a:spcPct val="100000"/>
+              </a:lnSpc>
+              <a:buNone/>
+            </a:pPr>
+            <a:r>
+              <a:rPr sz="3200" b="1" i="0">
+                <a:solidFill>
+                  <a:srgbClr val="9D4E24"/>
+                </a:solidFill>
+                <a:latin typeface="Arial"/>
+                <a:ea typeface="Arial"/>
+                <a:cs typeface="Arial"/>
+              </a:rPr>
+              <a:t>2–4 wks</a:t>
+            </a:r>
+          </a:p>
+        </p:txBody>
+      </p:sp>
+      <p:sp>
+        <p:nvSpPr>
+          <p:cNvPr id="918" name=""/>
+          <p:cNvSpPr>
+            <a:spLocks noGrp="1"/>
+          </p:cNvSpPr>
+          <p:nvPr/>
+        </p:nvSpPr>
+        <p:spPr>
+          <a:xfrm>
+            <a:off x="4635146" y="3474720"/>
+            <a:ext cx="2921708" cy="228600"/>
+          </a:xfrm>
+          <a:prstGeom prst="rect">
+            <a:avLst/>
+          </a:prstGeom>
+          <a:noFill/>
+          <a:ln w="0">
+            <a:noFill/>
+            <a:prstDash val="solid"/>
+          </a:ln>
+        </p:spPr>
+        <p:txBody>
+          <a:bodyPr wrap="square" lIns="0" tIns="0" rIns="0" bIns="0" anchor="t">
+            <a:normAutofit fontScale="100000"/>
+          </a:bodyPr>
+          <a:lstStyle/>
+          <a:p>
+            <a:pPr algn="l">
+              <a:lnSpc>
+                <a:spcPct val="100000"/>
+              </a:lnSpc>
+              <a:buNone/>
+            </a:pPr>
+            <a:r>
+              <a:rPr sz="975" b="0" i="0">
+                <a:solidFill>
+                  <a:srgbClr val="6A6F73"/>
+                </a:solidFill>
+                <a:latin typeface="Arial"/>
+                <a:ea typeface="Arial"/>
+                <a:cs typeface="Arial"/>
+              </a:rPr>
+              <a:t>install + commissioning</a:t>
+            </a:r>
+          </a:p>
+        </p:txBody>
+      </p:sp>
+      <p:sp>
+        <p:nvSpPr>
+          <p:cNvPr id="919" name=""/>
+          <p:cNvSpPr>
+            <a:spLocks noGrp="1"/>
+          </p:cNvSpPr>
+          <p:nvPr/>
+        </p:nvSpPr>
+        <p:spPr>
+          <a:xfrm>
+            <a:off x="4635146" y="3794760"/>
+            <a:ext cx="2921708" cy="274320"/>
+          </a:xfrm>
+          <a:prstGeom prst="rect">
+            <a:avLst/>
+          </a:prstGeom>
+          <a:noFill/>
+          <a:ln w="0">
+            <a:noFill/>
+            <a:prstDash val="solid"/>
+          </a:ln>
+        </p:spPr>
+        <p:txBody>
+          <a:bodyPr wrap="square" lIns="0" tIns="0" rIns="0" bIns="0" anchor="t">
+            <a:normAutofit fontScale="100000"/>
+          </a:bodyPr>
+          <a:lstStyle/>
+          <a:p>
+            <a:pPr algn="l">
+              <a:lnSpc>
+                <a:spcPct val="100000"/>
+              </a:lnSpc>
+              <a:buNone/>
+            </a:pPr>
+            <a:r>
+              <a:rPr sz="1050" b="0" i="0">
+                <a:solidFill>
+                  <a:srgbClr val="17191C"/>
+                </a:solidFill>
+                <a:latin typeface="Arial"/>
+                <a:ea typeface="Arial"/>
+                <a:cs typeface="Arial"/>
+              </a:rPr>
+              <a:t>40–60% fewer onsite labor hours</a:t>
+            </a:r>
+          </a:p>
+        </p:txBody>
+      </p:sp>
+      <p:sp>
+        <p:nvSpPr>
+          <p:cNvPr id="920" name=""/>
+          <p:cNvSpPr>
+            <a:spLocks noGrp="1"/>
+          </p:cNvSpPr>
+          <p:nvPr/>
+        </p:nvSpPr>
+        <p:spPr>
+          <a:xfrm>
+            <a:off x="4635146" y="4069080"/>
+            <a:ext cx="2921708" cy="274320"/>
+          </a:xfrm>
+          <a:prstGeom prst="rect">
+            <a:avLst/>
+          </a:prstGeom>
+          <a:noFill/>
+          <a:ln w="0">
+            <a:noFill/>
+            <a:prstDash val="solid"/>
+          </a:ln>
+        </p:spPr>
+        <p:txBody>
+          <a:bodyPr wrap="square" lIns="0" tIns="0" rIns="0" bIns="0" anchor="t">
+            <a:normAutofit fontScale="100000"/>
+          </a:bodyPr>
+          <a:lstStyle/>
+          <a:p>
+            <a:pPr algn="l">
+              <a:lnSpc>
+                <a:spcPct val="100000"/>
+              </a:lnSpc>
+              <a:buNone/>
+            </a:pPr>
+            <a:r>
+              <a:rPr sz="1050" b="0" i="0">
+                <a:solidFill>
+                  <a:srgbClr val="17191C"/>
+                </a:solidFill>
+                <a:latin typeface="Arial"/>
+                <a:ea typeface="Arial"/>
+                <a:cs typeface="Arial"/>
+              </a:rPr>
+              <a:t>Pre-tested, pre-labeled harnesses</a:t>
+            </a:r>
+          </a:p>
+        </p:txBody>
+      </p:sp>
+      <p:sp>
+        <p:nvSpPr>
+          <p:cNvPr id="921" name=""/>
+          <p:cNvSpPr>
+            <a:spLocks noGrp="1"/>
+          </p:cNvSpPr>
+          <p:nvPr/>
+        </p:nvSpPr>
+        <p:spPr>
+          <a:xfrm>
+            <a:off x="4635146" y="4343400"/>
+            <a:ext cx="2921708" cy="274320"/>
+          </a:xfrm>
+          <a:prstGeom prst="rect">
+            <a:avLst/>
+          </a:prstGeom>
+          <a:noFill/>
+          <a:ln w="0">
+            <a:noFill/>
+            <a:prstDash val="solid"/>
+          </a:ln>
+        </p:spPr>
+        <p:txBody>
+          <a:bodyPr wrap="square" lIns="0" tIns="0" rIns="0" bIns="0" anchor="t">
+            <a:normAutofit fontScale="100000"/>
+          </a:bodyPr>
+          <a:lstStyle/>
+          <a:p>
+            <a:pPr algn="l">
+              <a:lnSpc>
+                <a:spcPct val="100000"/>
+              </a:lnSpc>
+              <a:buNone/>
+            </a:pPr>
+            <a:r>
+              <a:rPr sz="1050" b="1" i="0">
+                <a:solidFill>
+                  <a:srgbClr val="6A6F73"/>
+                </a:solidFill>
+                <a:latin typeface="Arial"/>
+                <a:ea typeface="Arial"/>
+                <a:cs typeface="Arial"/>
+              </a:rPr>
+              <a:t>Plug-and-play modular connections</a:t>
+            </a:r>
+          </a:p>
+        </p:txBody>
+      </p:sp>
+      <p:sp>
+        <p:nvSpPr>
+          <p:cNvPr id="922" name=""/>
+          <p:cNvSpPr>
+            <a:spLocks noGrp="1"/>
+          </p:cNvSpPr>
+          <p:nvPr/>
+        </p:nvSpPr>
+        <p:spPr>
+          <a:xfrm>
+            <a:off x="8093954" y="2377440"/>
+            <a:ext cx="3378908" cy="2469540"/>
+          </a:xfrm>
+          <a:prstGeom prst="rect">
+            <a:avLst/>
+          </a:prstGeom>
+          <a:solidFill>
+            <a:srgbClr val="C9783E"/>
+          </a:solidFill>
+          <a:ln w="0">
+            <a:noFill/>
+            <a:prstDash val="solid"/>
+          </a:ln>
+        </p:spPr>
+      </p:sp>
+      <p:sp>
+        <p:nvSpPr>
+          <p:cNvPr id="923" name=""/>
+          <p:cNvSpPr>
+            <a:spLocks noGrp="1"/>
+          </p:cNvSpPr>
+          <p:nvPr/>
+        </p:nvSpPr>
+        <p:spPr>
+          <a:xfrm>
+            <a:off x="8322554" y="2606040"/>
+            <a:ext cx="2921708" cy="228600"/>
+          </a:xfrm>
+          <a:prstGeom prst="rect">
+            <a:avLst/>
+          </a:prstGeom>
+          <a:noFill/>
+          <a:ln w="0">
+            <a:noFill/>
+            <a:prstDash val="solid"/>
+          </a:ln>
+        </p:spPr>
+        <p:txBody>
+          <a:bodyPr wrap="square" lIns="0" tIns="0" rIns="0" bIns="0" anchor="t">
+            <a:normAutofit fontScale="100000"/>
+          </a:bodyPr>
+          <a:lstStyle/>
+          <a:p>
+            <a:pPr algn="l">
+              <a:lnSpc>
+                <a:spcPct val="100000"/>
+              </a:lnSpc>
+              <a:buNone/>
+            </a:pPr>
+            <a:r>
+              <a:rPr sz="975" b="1" i="0">
+                <a:solidFill>
+                  <a:srgbClr val="FFFFFF"/>
+                </a:solidFill>
+                <a:latin typeface="Arial Narrow"/>
+                <a:ea typeface="Arial Narrow"/>
+                <a:cs typeface="Arial Narrow"/>
+              </a:rPr>
+              <a:t>GAIN PER DEPLOYMENT BLOCK</a:t>
+            </a:r>
+          </a:p>
+        </p:txBody>
+      </p:sp>
+      <p:sp>
+        <p:nvSpPr>
+          <p:cNvPr id="924" name=""/>
+          <p:cNvSpPr>
+            <a:spLocks noGrp="1"/>
+          </p:cNvSpPr>
+          <p:nvPr/>
+        </p:nvSpPr>
+        <p:spPr>
+          <a:xfrm>
+            <a:off x="8322554" y="2880360"/>
+            <a:ext cx="2921708" cy="594360"/>
+          </a:xfrm>
+          <a:prstGeom prst="rect">
+            <a:avLst/>
+          </a:prstGeom>
+          <a:noFill/>
+          <a:ln w="0">
+            <a:noFill/>
+            <a:prstDash val="solid"/>
+          </a:ln>
+        </p:spPr>
+        <p:txBody>
+          <a:bodyPr wrap="square" lIns="0" tIns="0" rIns="0" bIns="0" anchor="t">
+            <a:normAutofit fontScale="100000"/>
+          </a:bodyPr>
+          <a:lstStyle/>
+          <a:p>
+            <a:pPr algn="l">
+              <a:lnSpc>
+                <a:spcPct val="100000"/>
+              </a:lnSpc>
+              <a:buNone/>
+            </a:pPr>
+            <a:r>
+              <a:rPr sz="3200" b="1" i="0">
+                <a:solidFill>
+                  <a:srgbClr val="FFFFFF"/>
+                </a:solidFill>
+                <a:latin typeface="Arial"/>
+                <a:ea typeface="Arial"/>
+                <a:cs typeface="Arial"/>
+              </a:rPr>
+              <a:t>6–8 wks</a:t>
+            </a:r>
+          </a:p>
+        </p:txBody>
+      </p:sp>
+      <p:sp>
+        <p:nvSpPr>
+          <p:cNvPr id="925" name=""/>
+          <p:cNvSpPr>
+            <a:spLocks noGrp="1"/>
+          </p:cNvSpPr>
+          <p:nvPr/>
+        </p:nvSpPr>
+        <p:spPr>
+          <a:xfrm>
+            <a:off x="8322554" y="3474720"/>
+            <a:ext cx="2921708" cy="228600"/>
+          </a:xfrm>
+          <a:prstGeom prst="rect">
+            <a:avLst/>
+          </a:prstGeom>
+          <a:noFill/>
+          <a:ln w="0">
+            <a:noFill/>
+            <a:prstDash val="solid"/>
+          </a:ln>
+        </p:spPr>
+        <p:txBody>
+          <a:bodyPr wrap="square" lIns="0" tIns="0" rIns="0" bIns="0" anchor="t">
+            <a:normAutofit fontScale="100000"/>
+          </a:bodyPr>
+          <a:lstStyle/>
+          <a:p>
+            <a:pPr algn="l">
+              <a:lnSpc>
+                <a:spcPct val="100000"/>
+              </a:lnSpc>
+              <a:buNone/>
+            </a:pPr>
+            <a:r>
+              <a:rPr sz="975" b="0" i="0">
+                <a:solidFill>
+                  <a:srgbClr val="FFFFFF"/>
+                </a:solidFill>
+                <a:latin typeface="Arial"/>
+                <a:ea typeface="Arial"/>
+                <a:cs typeface="Arial"/>
+              </a:rPr>
+              <a:t>faster to energization</a:t>
+            </a:r>
+          </a:p>
+        </p:txBody>
+      </p:sp>
+      <p:sp>
+        <p:nvSpPr>
+          <p:cNvPr id="926" name=""/>
+          <p:cNvSpPr>
+            <a:spLocks noGrp="1"/>
+          </p:cNvSpPr>
+          <p:nvPr/>
+        </p:nvSpPr>
+        <p:spPr>
+          <a:xfrm>
+            <a:off x="8322554" y="3794760"/>
+            <a:ext cx="2921708" cy="320040"/>
+          </a:xfrm>
+          <a:prstGeom prst="rect">
+            <a:avLst/>
+          </a:prstGeom>
+          <a:noFill/>
+          <a:ln w="0">
+            <a:noFill/>
+            <a:prstDash val="solid"/>
+          </a:ln>
+        </p:spPr>
+        <p:txBody>
+          <a:bodyPr wrap="square" lIns="0" tIns="0" rIns="0" bIns="0" anchor="t">
+            <a:normAutofit fontScale="100000"/>
+          </a:bodyPr>
+          <a:lstStyle/>
+          <a:p>
+            <a:pPr algn="l">
+              <a:lnSpc>
+                <a:spcPct val="100000"/>
+              </a:lnSpc>
+              <a:buNone/>
+            </a:pPr>
+            <a:r>
+              <a:rPr sz="1800" b="1" i="0">
+                <a:solidFill>
+                  <a:srgbClr val="FFFFFF"/>
+                </a:solidFill>
+                <a:latin typeface="Arial"/>
+                <a:ea typeface="Arial"/>
+                <a:cs typeface="Arial"/>
+              </a:rPr>
+              <a:t>$500K–$800K</a:t>
+            </a:r>
+          </a:p>
+        </p:txBody>
+      </p:sp>
+      <p:sp>
+        <p:nvSpPr>
+          <p:cNvPr id="927" name=""/>
+          <p:cNvSpPr>
+            <a:spLocks noGrp="1"/>
+          </p:cNvSpPr>
+          <p:nvPr/>
+        </p:nvSpPr>
+        <p:spPr>
+          <a:xfrm>
+            <a:off x="8322554" y="4114800"/>
+            <a:ext cx="2921708" cy="228600"/>
+          </a:xfrm>
+          <a:prstGeom prst="rect">
+            <a:avLst/>
+          </a:prstGeom>
+          <a:noFill/>
+          <a:ln w="0">
+            <a:noFill/>
+            <a:prstDash val="solid"/>
+          </a:ln>
+        </p:spPr>
+        <p:txBody>
+          <a:bodyPr wrap="square" lIns="0" tIns="0" rIns="0" bIns="0" anchor="t">
+            <a:normAutofit fontScale="100000"/>
+          </a:bodyPr>
+          <a:lstStyle/>
+          <a:p>
+            <a:pPr algn="l">
+              <a:lnSpc>
+                <a:spcPct val="100000"/>
+              </a:lnSpc>
+              <a:buNone/>
+            </a:pPr>
+            <a:r>
+              <a:rPr sz="900" b="0" i="0">
+                <a:solidFill>
+                  <a:srgbClr val="FFFFFF"/>
+                </a:solidFill>
+                <a:latin typeface="Arial"/>
+                <a:ea typeface="Arial"/>
+                <a:cs typeface="Arial"/>
+              </a:rPr>
+              <a:t>gross field-labor savings</a:t>
+            </a:r>
+          </a:p>
+        </p:txBody>
+      </p:sp>
+      <p:sp>
+        <p:nvSpPr>
+          <p:cNvPr id="928" name=""/>
+          <p:cNvSpPr>
+            <a:spLocks noGrp="1"/>
+          </p:cNvSpPr>
+          <p:nvPr/>
+        </p:nvSpPr>
+        <p:spPr>
+          <a:xfrm>
+            <a:off x="8322554" y="4343400"/>
+            <a:ext cx="2921708" cy="440000"/>
+          </a:xfrm>
+          <a:prstGeom prst="rect">
+            <a:avLst/>
+          </a:prstGeom>
+          <a:noFill/>
+          <a:ln w="0">
+            <a:noFill/>
+            <a:prstDash val="solid"/>
+          </a:ln>
+        </p:spPr>
+        <p:txBody>
+          <a:bodyPr wrap="square" lIns="0" tIns="0" rIns="0" bIns="0" anchor="t">
+            <a:normAutofit fontScale="100000"/>
+          </a:bodyPr>
+          <a:lstStyle/>
+          <a:p>
+            <a:pPr algn="l">
+              <a:lnSpc>
+                <a:spcPct val="104000"/>
+              </a:lnSpc>
+              <a:buNone/>
+            </a:pPr>
+            <a:r>
+              <a:rPr sz="900" b="0" i="0">
+                <a:solidFill>
+                  <a:srgbClr val="FFFFFF"/>
+                </a:solidFill>
+                <a:latin typeface="Arial"/>
+                <a:ea typeface="Arial"/>
+                <a:cs typeface="Arial"/>
+              </a:rPr>
+              <a:t>Plus lower rework, earlier revenue recognition and reduced LD exposure.</a:t>
+            </a:r>
+          </a:p>
+        </p:txBody>
+      </p:sp>
+      <p:sp>
+        <p:nvSpPr>
+          <p:cNvPr id="929" name=""/>
+          <p:cNvSpPr>
+            <a:spLocks noGrp="1"/>
+          </p:cNvSpPr>
+          <p:nvPr/>
+        </p:nvSpPr>
+        <p:spPr>
+          <a:xfrm>
+            <a:off x="719138" y="5029200"/>
+            <a:ext cx="10753724" cy="228600"/>
+          </a:xfrm>
+          <a:prstGeom prst="rect">
+            <a:avLst/>
+          </a:prstGeom>
+          <a:noFill/>
+          <a:ln w="0">
+            <a:noFill/>
+            <a:prstDash val="solid"/>
+          </a:ln>
+        </p:spPr>
+        <p:txBody>
+          <a:bodyPr wrap="square" lIns="0" tIns="0" rIns="0" bIns="0" anchor="t">
+            <a:normAutofit fontScale="100000"/>
+          </a:bodyPr>
+          <a:lstStyle/>
+          <a:p>
+            <a:pPr algn="l">
+              <a:lnSpc>
+                <a:spcPct val="100000"/>
+              </a:lnSpc>
+              <a:buNone/>
+            </a:pPr>
+            <a:r>
+              <a:rPr sz="975" b="1" i="0">
+                <a:solidFill>
+                  <a:srgbClr val="9D4E24"/>
+                </a:solidFill>
+                <a:latin typeface="Arial Narrow"/>
+                <a:ea typeface="Arial Narrow"/>
+                <a:cs typeface="Arial Narrow"/>
+              </a:rPr>
+              <a:t>WHERE THIS LANDS IN NRG'S PROGRAM</a:t>
+            </a:r>
+          </a:p>
+        </p:txBody>
+      </p:sp>
+      <p:sp>
+        <p:nvSpPr>
+          <p:cNvPr id="930" name=""/>
+          <p:cNvSpPr>
+            <a:spLocks noGrp="1"/>
+          </p:cNvSpPr>
+          <p:nvPr/>
+        </p:nvSpPr>
+        <p:spPr>
+          <a:xfrm>
+            <a:off x="719138" y="5303520"/>
+            <a:ext cx="10753724" cy="460000"/>
+          </a:xfrm>
+          <a:prstGeom prst="rect">
+            <a:avLst/>
+          </a:prstGeom>
+          <a:noFill/>
+          <a:ln w="0">
+            <a:noFill/>
+            <a:prstDash val="solid"/>
+          </a:ln>
+        </p:spPr>
+        <p:txBody>
+          <a:bodyPr wrap="square" lIns="0" tIns="0" rIns="0" bIns="0" anchor="t">
+            <a:normAutofit fontScale="100000"/>
+          </a:bodyPr>
+          <a:lstStyle/>
+          <a:p>
+            <a:pPr algn="l">
+              <a:lnSpc>
+                <a:spcPct val="106000"/>
+              </a:lnSpc>
+              <a:buNone/>
+            </a:pPr>
+            <a:r>
+              <a:rPr sz="1050" b="0" i="0">
+                <a:solidFill>
+                  <a:srgbClr val="6A6F73"/>
+                </a:solidFill>
+                <a:latin typeface="Arial"/>
+                <a:ea typeface="Arial"/>
+                <a:cs typeface="Arial"/>
+              </a:rPr>
+              <a:t>Modular power yard and black-start packages  ·  behind-the-meter and colocation skids  ·  e-houses, containerized substations and BESS  ·  any unit that repeats across the fleet.</a:t>
+            </a:r>
+          </a:p>
+        </p:txBody>
+      </p:sp>
+      <p:sp>
+        <p:nvSpPr>
+          <p:cNvPr id="931" name=""/>
+          <p:cNvSpPr>
+            <a:spLocks noGrp="1"/>
+          </p:cNvSpPr>
+          <p:nvPr/>
+        </p:nvSpPr>
+        <p:spPr>
+          <a:xfrm>
+            <a:off x="719138" y="5806440"/>
+            <a:ext cx="10753724" cy="440000"/>
+          </a:xfrm>
+          <a:prstGeom prst="rect">
+            <a:avLst/>
+          </a:prstGeom>
+          <a:noFill/>
+          <a:ln w="0">
+            <a:noFill/>
+            <a:prstDash val="solid"/>
+          </a:ln>
+        </p:spPr>
+        <p:txBody>
+          <a:bodyPr wrap="square" lIns="0" tIns="0" rIns="0" bIns="0" anchor="t">
+            <a:normAutofit fontScale="100000"/>
+          </a:bodyPr>
+          <a:lstStyle/>
+          <a:p>
+            <a:pPr algn="l">
+              <a:lnSpc>
+                <a:spcPct val="106000"/>
+              </a:lnSpc>
+              <a:buNone/>
+            </a:pPr>
+            <a:r>
+              <a:rPr sz="900" b="0" i="1">
+                <a:solidFill>
+                  <a:srgbClr val="17191C"/>
+                </a:solidFill>
+                <a:latin typeface="Arial"/>
+                <a:ea typeface="Arial"/>
+                <a:cs typeface="Arial"/>
+              </a:rPr>
+              <a:t>WHY THE TWO CASES USE DIFFERENT RATES:  A13 models $95/hr fully burdened for an industrial electrician on a two-shift site; this case models $180/hr loaded for multi-trade work in the data-center market. Different markets and burden bases — both are gross field labor, and both need NRG's own rates before either number is used.</a:t>
+            </a:r>
+          </a:p>
+        </p:txBody>
+      </p:sp>
+      <p:sp>
+        <p:nvSpPr>
+          <p:cNvPr id="932" name=""/>
+          <p:cNvSpPr>
+            <a:spLocks noGrp="1"/>
+          </p:cNvSpPr>
+          <p:nvPr/>
+        </p:nvSpPr>
+        <p:spPr>
+          <a:xfrm>
+            <a:off x="719138" y="6315000"/>
+            <a:ext cx="10753724" cy="400000"/>
+          </a:xfrm>
+          <a:prstGeom prst="rect">
+            <a:avLst/>
+          </a:prstGeom>
+          <a:solidFill>
+            <a:srgbClr val="17191C"/>
+          </a:solidFill>
+          <a:ln w="0">
+            <a:noFill/>
+            <a:prstDash val="solid"/>
+          </a:ln>
+        </p:spPr>
+      </p:sp>
+      <p:sp>
+        <p:nvSpPr>
+          <p:cNvPr id="933" name=""/>
+          <p:cNvSpPr>
+            <a:spLocks noGrp="1"/>
+          </p:cNvSpPr>
+          <p:nvPr/>
+        </p:nvSpPr>
+        <p:spPr>
+          <a:xfrm>
+            <a:off x="719138" y="6315000"/>
+            <a:ext cx="10753724" cy="400000"/>
+          </a:xfrm>
+          <a:prstGeom prst="rect">
+            <a:avLst/>
+          </a:prstGeom>
+          <a:noFill/>
+          <a:ln w="0">
+            <a:noFill/>
+            <a:prstDash val="solid"/>
+          </a:ln>
+        </p:spPr>
+        <p:txBody>
+          <a:bodyPr wrap="square" lIns="0" tIns="0" rIns="0" bIns="0" anchor="ctr">
+            <a:normAutofit fontScale="100000"/>
+          </a:bodyPr>
+          <a:lstStyle/>
+          <a:p>
+            <a:pPr algn="ctr">
+              <a:lnSpc>
+                <a:spcPct val="100000"/>
+              </a:lnSpc>
+              <a:buNone/>
+            </a:pPr>
+            <a:r>
+              <a:rPr sz="1050" b="1" i="0">
+                <a:solidFill>
+                  <a:srgbClr val="FFFFFF"/>
+                </a:solidFill>
+                <a:latin typeface="Arial Narrow"/>
+                <a:ea typeface="Arial Narrow"/>
+                <a:cs typeface="Arial Narrow"/>
+              </a:rPr>
+              <a:t>DIRECTIONAL FIGURES — VALIDATE AGAINST PARTNER AND NRG LABOR DATA BEFORE USE (SEE A5).</a:t>
+            </a:r>
+          </a:p>
+        </p:txBody>
+      </p:sp>
+    </p:spTree>
+  </p:cSld>
+</p:sld>
+</file>
+
 <file path=ppt/slides/slide3.xml><?xml version="1.0" encoding="utf-8"?>
 <p:sld xmlns:p="http://schemas.openxmlformats.org/presentationml/2006/main">
   <p:cSld>

</xml_diff>

<commit_message>
Add Interconnection Timing appendix (A15), reframing C7 for an IPP
Corrects the earlier call that excluded the advanced-conductor case as
utility-only. Reconductoring is a real IPP schedule lever via
generator-funded network upgrades, gen-tie ownership, uprate thermal
limits and in-service corridor headroom. Framed as time-to-COD with an
explicit note on the TO/ISO mechanism.

Co-Authored-By: Claude Opus 5 <noreply@anthropic.com>
Claude-Session: https://claude.ai/code/session_01DUeyPCeDvcPsyTcH6oQXEK
</commit_message>
<xml_diff>
--- a/teaser-rework/Southwire_NRG_Protecting_Time_to_Power_Rev10.pptx
+++ b/teaser-rework/Southwire_NRG_Protecting_Time_to_Power_Rev10.pptx
@@ -31,6 +31,7 @@
     <p:sldId id="276" r:id="rId7"/>
     <p:sldId id="277" r:id="rId8"/>
     <p:sldId id="278" r:id="rId9"/>
+    <p:sldId id="279" r:id="rId10"/>
   </p:sldIdLst>
   <p:sldSz cx="12192000" cy="6858000"/>
   <p:notesSz cx="6858000" cy="9144000"/>
@@ -21684,6 +21685,1516 @@
 </p:sld>
 </file>
 
+<file path=ppt/slides/slide24.xml><?xml version="1.0" encoding="utf-8"?>
+<p:sld xmlns:p="http://schemas.openxmlformats.org/presentationml/2006/main" xmlns:a="http://schemas.openxmlformats.org/drawingml/2006/main" xmlns:r="http://schemas.openxmlformats.org/officeDocument/2006/relationships">
+  <p:cSld>
+    <p:bg>
+      <p:bgPr>
+        <a:solidFill>
+          <a:srgbClr val="F6F3EE"/>
+        </a:solidFill>
+      </p:bgPr>
+    </p:bg>
+    <p:spTree>
+      <p:nvGrpSpPr>
+        <p:cNvPr id="1" name=""/>
+        <p:cNvGrpSpPr/>
+        <p:nvPr/>
+      </p:nvGrpSpPr>
+      <p:grpSpPr>
+        <a:xfrm/>
+      </p:grpSpPr>
+      <p:sp>
+        <p:nvSpPr>
+          <p:cNvPr id="1101" name=""/>
+          <p:cNvSpPr>
+            <a:spLocks noGrp="1"/>
+          </p:cNvSpPr>
+          <p:nvPr/>
+        </p:nvSpPr>
+        <p:spPr>
+          <a:xfrm>
+            <a:off x="0" y="0"/>
+            <a:ext cx="12192000" cy="57150"/>
+          </a:xfrm>
+          <a:prstGeom prst="rect">
+            <a:avLst/>
+          </a:prstGeom>
+          <a:solidFill>
+            <a:srgbClr val="C9783E"/>
+          </a:solidFill>
+          <a:ln w="0">
+            <a:noFill/>
+            <a:prstDash val="solid"/>
+          </a:ln>
+        </p:spPr>
+      </p:sp>
+      <p:pic>
+        <p:nvPicPr>
+          <p:cNvPr id="1102" name=""/>
+          <p:cNvPicPr>
+            <a:picLocks noChangeAspect="1"/>
+          </p:cNvPicPr>
+          <p:nvPr/>
+        </p:nvPicPr>
+        <p:blipFill>
+          <a:blip r:embed="R48e2a3d3733b4264"/>
+          <a:stretch/>
+        </p:blipFill>
+        <p:spPr>
+          <a:xfrm>
+            <a:off x="719138" y="200025"/>
+            <a:ext cx="2066925" cy="590550"/>
+          </a:xfrm>
+          <a:prstGeom prst="rect">
+            <a:avLst/>
+          </a:prstGeom>
+        </p:spPr>
+      </p:pic>
+      <p:sp>
+        <p:nvSpPr>
+          <p:cNvPr id="1103" name=""/>
+          <p:cNvSpPr>
+            <a:spLocks noGrp="1"/>
+          </p:cNvSpPr>
+          <p:nvPr/>
+        </p:nvSpPr>
+        <p:spPr>
+          <a:xfrm>
+            <a:off x="7325360" y="323850"/>
+            <a:ext cx="3857000" cy="228600"/>
+          </a:xfrm>
+          <a:prstGeom prst="rect">
+            <a:avLst/>
+          </a:prstGeom>
+          <a:noFill/>
+          <a:ln w="0">
+            <a:noFill/>
+            <a:prstDash val="solid"/>
+          </a:ln>
+        </p:spPr>
+        <p:txBody>
+          <a:bodyPr wrap="square" lIns="0" tIns="0" rIns="0" bIns="0" anchor="t">
+            <a:normAutofit fontScale="100000"/>
+          </a:bodyPr>
+          <a:lstStyle/>
+          <a:p>
+            <a:pPr algn="r">
+              <a:lnSpc>
+                <a:spcPct val="100000"/>
+              </a:lnSpc>
+              <a:buNone/>
+            </a:pPr>
+            <a:r>
+              <a:rPr sz="975" b="1" i="0">
+                <a:solidFill>
+                  <a:srgbClr val="9D4E24"/>
+                </a:solidFill>
+                <a:latin typeface="Arial Narrow"/>
+                <a:ea typeface="Arial Narrow"/>
+                <a:cs typeface="Arial Narrow"/>
+              </a:rPr>
+              <a:t>APPENDIX A15 · INTERCONNECTION TIMING</a:t>
+            </a:r>
+          </a:p>
+        </p:txBody>
+      </p:sp>
+      <p:sp>
+        <p:nvSpPr>
+          <p:cNvPr id="1104" name=""/>
+          <p:cNvSpPr>
+            <a:spLocks noGrp="1"/>
+          </p:cNvSpPr>
+          <p:nvPr/>
+        </p:nvSpPr>
+        <p:spPr>
+          <a:xfrm>
+            <a:off x="11334750" y="323850"/>
+            <a:ext cx="323850" cy="228600"/>
+          </a:xfrm>
+          <a:prstGeom prst="rect">
+            <a:avLst/>
+          </a:prstGeom>
+          <a:noFill/>
+          <a:ln w="0">
+            <a:noFill/>
+            <a:prstDash val="solid"/>
+          </a:ln>
+        </p:spPr>
+        <p:txBody>
+          <a:bodyPr wrap="square" lIns="0" tIns="0" rIns="0" bIns="0" anchor="t">
+            <a:normAutofit fontScale="100000"/>
+          </a:bodyPr>
+          <a:lstStyle/>
+          <a:p>
+            <a:pPr algn="r">
+              <a:lnSpc>
+                <a:spcPct val="100000"/>
+              </a:lnSpc>
+              <a:buNone/>
+            </a:pPr>
+            <a:r>
+              <a:rPr sz="975" b="1" i="0">
+                <a:solidFill>
+                  <a:srgbClr val="8B9094"/>
+                </a:solidFill>
+                <a:latin typeface="Arial Narrow"/>
+                <a:ea typeface="Arial Narrow"/>
+                <a:cs typeface="Arial Narrow"/>
+              </a:rPr>
+              <a:t>24</a:t>
+            </a:r>
+          </a:p>
+        </p:txBody>
+      </p:sp>
+      <p:sp>
+        <p:nvSpPr>
+          <p:cNvPr id="1105" name=""/>
+          <p:cNvSpPr>
+            <a:spLocks noGrp="1"/>
+          </p:cNvSpPr>
+          <p:nvPr/>
+        </p:nvSpPr>
+        <p:spPr>
+          <a:xfrm>
+            <a:off x="719138" y="1005840"/>
+            <a:ext cx="9000000" cy="228600"/>
+          </a:xfrm>
+          <a:prstGeom prst="rect">
+            <a:avLst/>
+          </a:prstGeom>
+          <a:noFill/>
+          <a:ln w="0">
+            <a:noFill/>
+            <a:prstDash val="solid"/>
+          </a:ln>
+        </p:spPr>
+        <p:txBody>
+          <a:bodyPr wrap="square" lIns="0" tIns="0" rIns="0" bIns="0" anchor="t">
+            <a:normAutofit fontScale="100000"/>
+          </a:bodyPr>
+          <a:lstStyle/>
+          <a:p>
+            <a:pPr algn="l">
+              <a:lnSpc>
+                <a:spcPct val="100000"/>
+              </a:lnSpc>
+              <a:buNone/>
+            </a:pPr>
+            <a:r>
+              <a:rPr sz="1050" b="1" i="0">
+                <a:solidFill>
+                  <a:srgbClr val="C9783E"/>
+                </a:solidFill>
+                <a:latin typeface="Arial Narrow"/>
+                <a:ea typeface="Arial Narrow"/>
+                <a:cs typeface="Arial Narrow"/>
+              </a:rPr>
+              <a:t>WHEN THE UPGRADE IS ON THE CRITICAL PATH</a:t>
+            </a:r>
+          </a:p>
+        </p:txBody>
+      </p:sp>
+      <p:sp>
+        <p:nvSpPr>
+          <p:cNvPr id="1106" name=""/>
+          <p:cNvSpPr>
+            <a:spLocks noGrp="1"/>
+          </p:cNvSpPr>
+          <p:nvPr/>
+        </p:nvSpPr>
+        <p:spPr>
+          <a:xfrm>
+            <a:off x="719138" y="1280160"/>
+            <a:ext cx="10753724" cy="500000"/>
+          </a:xfrm>
+          <a:prstGeom prst="rect">
+            <a:avLst/>
+          </a:prstGeom>
+          <a:noFill/>
+          <a:ln w="0">
+            <a:noFill/>
+            <a:prstDash val="solid"/>
+          </a:ln>
+        </p:spPr>
+        <p:txBody>
+          <a:bodyPr wrap="square" lIns="0" tIns="0" rIns="0" bIns="0" anchor="t">
+            <a:normAutofit fontScale="100000"/>
+          </a:bodyPr>
+          <a:lstStyle/>
+          <a:p>
+            <a:pPr algn="l">
+              <a:lnSpc>
+                <a:spcPct val="104000"/>
+              </a:lnSpc>
+              <a:buNone/>
+            </a:pPr>
+            <a:r>
+              <a:rPr sz="2850" b="1" i="0">
+                <a:solidFill>
+                  <a:srgbClr val="17191C"/>
+                </a:solidFill>
+                <a:latin typeface="Arial"/>
+                <a:ea typeface="Arial"/>
+                <a:cs typeface="Arial"/>
+              </a:rPr>
+              <a:t>Reconductor instead of a new line — and the date moves years left.</a:t>
+            </a:r>
+          </a:p>
+        </p:txBody>
+      </p:sp>
+      <p:sp>
+        <p:nvSpPr>
+          <p:cNvPr id="1107" name=""/>
+          <p:cNvSpPr>
+            <a:spLocks noGrp="1"/>
+          </p:cNvSpPr>
+          <p:nvPr/>
+        </p:nvSpPr>
+        <p:spPr>
+          <a:xfrm>
+            <a:off x="719138" y="1950720"/>
+            <a:ext cx="10753724" cy="300000"/>
+          </a:xfrm>
+          <a:prstGeom prst="rect">
+            <a:avLst/>
+          </a:prstGeom>
+          <a:noFill/>
+          <a:ln w="0">
+            <a:noFill/>
+            <a:prstDash val="solid"/>
+          </a:ln>
+        </p:spPr>
+        <p:txBody>
+          <a:bodyPr wrap="square" lIns="0" tIns="0" rIns="0" bIns="0" anchor="t">
+            <a:normAutofit fontScale="100000"/>
+          </a:bodyPr>
+          <a:lstStyle/>
+          <a:p>
+            <a:pPr algn="l">
+              <a:lnSpc>
+                <a:spcPct val="108000"/>
+              </a:lnSpc>
+              <a:buNone/>
+            </a:pPr>
+            <a:r>
+              <a:rPr sz="1050" b="0" i="0">
+                <a:solidFill>
+                  <a:srgbClr val="6A6F73"/>
+                </a:solidFill>
+                <a:latin typeface="Arial"/>
+                <a:ea typeface="Arial"/>
+                <a:cs typeface="Arial"/>
+              </a:rPr>
+              <a:t>Advanced conductor on structures and right-of-way that already exist. Illustrative 25-mile corridor, 300 MVA baseline, C7 at 2.5x capacity, versus a traditional new build.</a:t>
+            </a:r>
+          </a:p>
+        </p:txBody>
+      </p:sp>
+      <p:sp>
+        <p:nvSpPr>
+          <p:cNvPr id="1108" name=""/>
+          <p:cNvSpPr>
+            <a:spLocks noGrp="1"/>
+          </p:cNvSpPr>
+          <p:nvPr/>
+        </p:nvSpPr>
+        <p:spPr>
+          <a:xfrm>
+            <a:off x="719138" y="2377440"/>
+            <a:ext cx="3378908" cy="1188720"/>
+          </a:xfrm>
+          <a:prstGeom prst="rect">
+            <a:avLst/>
+          </a:prstGeom>
+          <a:solidFill>
+            <a:srgbClr val="FFFFFF"/>
+          </a:solidFill>
+          <a:ln w="9525">
+            <a:solidFill>
+              <a:srgbClr val="D8D1C8"/>
+            </a:solidFill>
+            <a:prstDash val="solid"/>
+          </a:ln>
+        </p:spPr>
+      </p:sp>
+      <p:sp>
+        <p:nvSpPr>
+          <p:cNvPr id="1109" name=""/>
+          <p:cNvSpPr>
+            <a:spLocks noGrp="1"/>
+          </p:cNvSpPr>
+          <p:nvPr/>
+        </p:nvSpPr>
+        <p:spPr>
+          <a:xfrm>
+            <a:off x="947738" y="2514600"/>
+            <a:ext cx="2921708" cy="594360"/>
+          </a:xfrm>
+          <a:prstGeom prst="rect">
+            <a:avLst/>
+          </a:prstGeom>
+          <a:noFill/>
+          <a:ln w="0">
+            <a:noFill/>
+            <a:prstDash val="solid"/>
+          </a:ln>
+        </p:spPr>
+        <p:txBody>
+          <a:bodyPr wrap="square" lIns="0" tIns="0" rIns="0" bIns="0" anchor="t">
+            <a:normAutofit fontScale="100000"/>
+          </a:bodyPr>
+          <a:lstStyle/>
+          <a:p>
+            <a:pPr algn="l">
+              <a:lnSpc>
+                <a:spcPct val="100000"/>
+              </a:lnSpc>
+              <a:buNone/>
+            </a:pPr>
+            <a:r>
+              <a:rPr sz="3200" b="1" i="0">
+                <a:solidFill>
+                  <a:srgbClr val="9D4E24"/>
+                </a:solidFill>
+                <a:latin typeface="Arial"/>
+                <a:ea typeface="Arial"/>
+                <a:cs typeface="Arial"/>
+              </a:rPr>
+              <a:t>6 YEARS</a:t>
+            </a:r>
+          </a:p>
+        </p:txBody>
+      </p:sp>
+      <p:sp>
+        <p:nvSpPr>
+          <p:cNvPr id="1110" name=""/>
+          <p:cNvSpPr>
+            <a:spLocks noGrp="1"/>
+          </p:cNvSpPr>
+          <p:nvPr/>
+        </p:nvSpPr>
+        <p:spPr>
+          <a:xfrm>
+            <a:off x="947738" y="3108960"/>
+            <a:ext cx="2921708" cy="228600"/>
+          </a:xfrm>
+          <a:prstGeom prst="rect">
+            <a:avLst/>
+          </a:prstGeom>
+          <a:noFill/>
+          <a:ln w="0">
+            <a:noFill/>
+            <a:prstDash val="solid"/>
+          </a:ln>
+        </p:spPr>
+        <p:txBody>
+          <a:bodyPr wrap="square" lIns="0" tIns="0" rIns="0" bIns="0" anchor="t">
+            <a:normAutofit fontScale="100000"/>
+          </a:bodyPr>
+          <a:lstStyle/>
+          <a:p>
+            <a:pPr algn="l">
+              <a:lnSpc>
+                <a:spcPct val="100000"/>
+              </a:lnSpc>
+              <a:buNone/>
+            </a:pPr>
+            <a:r>
+              <a:rPr sz="1050" b="1" i="0">
+                <a:solidFill>
+                  <a:srgbClr val="17191C"/>
+                </a:solidFill>
+                <a:latin typeface="Arial"/>
+                <a:ea typeface="Arial"/>
+                <a:cs typeface="Arial"/>
+              </a:rPr>
+              <a:t>earlier to capacity</a:t>
+            </a:r>
+          </a:p>
+        </p:txBody>
+      </p:sp>
+      <p:sp>
+        <p:nvSpPr>
+          <p:cNvPr id="1111" name=""/>
+          <p:cNvSpPr>
+            <a:spLocks noGrp="1"/>
+          </p:cNvSpPr>
+          <p:nvPr/>
+        </p:nvSpPr>
+        <p:spPr>
+          <a:xfrm>
+            <a:off x="947738" y="3337560"/>
+            <a:ext cx="2921708" cy="228600"/>
+          </a:xfrm>
+          <a:prstGeom prst="rect">
+            <a:avLst/>
+          </a:prstGeom>
+          <a:noFill/>
+          <a:ln w="0">
+            <a:noFill/>
+            <a:prstDash val="solid"/>
+          </a:ln>
+        </p:spPr>
+        <p:txBody>
+          <a:bodyPr wrap="square" lIns="0" tIns="0" rIns="0" bIns="0" anchor="t">
+            <a:normAutofit fontScale="100000"/>
+          </a:bodyPr>
+          <a:lstStyle/>
+          <a:p>
+            <a:pPr algn="l">
+              <a:lnSpc>
+                <a:spcPct val="100000"/>
+              </a:lnSpc>
+              <a:buNone/>
+            </a:pPr>
+            <a:r>
+              <a:rPr sz="900" b="0" i="0">
+                <a:solidFill>
+                  <a:srgbClr val="6A6F73"/>
+                </a:solidFill>
+                <a:latin typeface="Arial"/>
+                <a:ea typeface="Arial"/>
+                <a:cs typeface="Arial"/>
+              </a:rPr>
+              <a:t>~2 years to reconductor vs ~8 for a new build</a:t>
+            </a:r>
+          </a:p>
+        </p:txBody>
+      </p:sp>
+      <p:sp>
+        <p:nvSpPr>
+          <p:cNvPr id="1112" name=""/>
+          <p:cNvSpPr>
+            <a:spLocks noGrp="1"/>
+          </p:cNvSpPr>
+          <p:nvPr/>
+        </p:nvSpPr>
+        <p:spPr>
+          <a:xfrm>
+            <a:off x="4406546" y="2377440"/>
+            <a:ext cx="3378908" cy="1188720"/>
+          </a:xfrm>
+          <a:prstGeom prst="rect">
+            <a:avLst/>
+          </a:prstGeom>
+          <a:solidFill>
+            <a:srgbClr val="FFFFFF"/>
+          </a:solidFill>
+          <a:ln w="9525">
+            <a:solidFill>
+              <a:srgbClr val="D8D1C8"/>
+            </a:solidFill>
+            <a:prstDash val="solid"/>
+          </a:ln>
+        </p:spPr>
+      </p:sp>
+      <p:sp>
+        <p:nvSpPr>
+          <p:cNvPr id="1113" name=""/>
+          <p:cNvSpPr>
+            <a:spLocks noGrp="1"/>
+          </p:cNvSpPr>
+          <p:nvPr/>
+        </p:nvSpPr>
+        <p:spPr>
+          <a:xfrm>
+            <a:off x="4635146" y="2514600"/>
+            <a:ext cx="2921708" cy="594360"/>
+          </a:xfrm>
+          <a:prstGeom prst="rect">
+            <a:avLst/>
+          </a:prstGeom>
+          <a:noFill/>
+          <a:ln w="0">
+            <a:noFill/>
+            <a:prstDash val="solid"/>
+          </a:ln>
+        </p:spPr>
+        <p:txBody>
+          <a:bodyPr wrap="square" lIns="0" tIns="0" rIns="0" bIns="0" anchor="t">
+            <a:normAutofit fontScale="100000"/>
+          </a:bodyPr>
+          <a:lstStyle/>
+          <a:p>
+            <a:pPr algn="l">
+              <a:lnSpc>
+                <a:spcPct val="100000"/>
+              </a:lnSpc>
+              <a:buNone/>
+            </a:pPr>
+            <a:r>
+              <a:rPr sz="3200" b="1" i="0">
+                <a:solidFill>
+                  <a:srgbClr val="9D4E24"/>
+                </a:solidFill>
+                <a:latin typeface="Arial"/>
+                <a:ea typeface="Arial"/>
+                <a:cs typeface="Arial"/>
+              </a:rPr>
+              <a:t>+450 MVA</a:t>
+            </a:r>
+          </a:p>
+        </p:txBody>
+      </p:sp>
+      <p:sp>
+        <p:nvSpPr>
+          <p:cNvPr id="1114" name=""/>
+          <p:cNvSpPr>
+            <a:spLocks noGrp="1"/>
+          </p:cNvSpPr>
+          <p:nvPr/>
+        </p:nvSpPr>
+        <p:spPr>
+          <a:xfrm>
+            <a:off x="4635146" y="3108960"/>
+            <a:ext cx="2921708" cy="228600"/>
+          </a:xfrm>
+          <a:prstGeom prst="rect">
+            <a:avLst/>
+          </a:prstGeom>
+          <a:noFill/>
+          <a:ln w="0">
+            <a:noFill/>
+            <a:prstDash val="solid"/>
+          </a:ln>
+        </p:spPr>
+        <p:txBody>
+          <a:bodyPr wrap="square" lIns="0" tIns="0" rIns="0" bIns="0" anchor="t">
+            <a:normAutofit fontScale="100000"/>
+          </a:bodyPr>
+          <a:lstStyle/>
+          <a:p>
+            <a:pPr algn="l">
+              <a:lnSpc>
+                <a:spcPct val="100000"/>
+              </a:lnSpc>
+              <a:buNone/>
+            </a:pPr>
+            <a:r>
+              <a:rPr sz="1050" b="1" i="0">
+                <a:solidFill>
+                  <a:srgbClr val="17191C"/>
+                </a:solidFill>
+                <a:latin typeface="Arial"/>
+                <a:ea typeface="Arial"/>
+                <a:cs typeface="Arial"/>
+              </a:rPr>
+              <a:t>on the same corridor</a:t>
+            </a:r>
+          </a:p>
+        </p:txBody>
+      </p:sp>
+      <p:sp>
+        <p:nvSpPr>
+          <p:cNvPr id="1115" name=""/>
+          <p:cNvSpPr>
+            <a:spLocks noGrp="1"/>
+          </p:cNvSpPr>
+          <p:nvPr/>
+        </p:nvSpPr>
+        <p:spPr>
+          <a:xfrm>
+            <a:off x="4635146" y="3337560"/>
+            <a:ext cx="2921708" cy="228600"/>
+          </a:xfrm>
+          <a:prstGeom prst="rect">
+            <a:avLst/>
+          </a:prstGeom>
+          <a:noFill/>
+          <a:ln w="0">
+            <a:noFill/>
+            <a:prstDash val="solid"/>
+          </a:ln>
+        </p:spPr>
+        <p:txBody>
+          <a:bodyPr wrap="square" lIns="0" tIns="0" rIns="0" bIns="0" anchor="t">
+            <a:normAutofit fontScale="100000"/>
+          </a:bodyPr>
+          <a:lstStyle/>
+          <a:p>
+            <a:pPr algn="l">
+              <a:lnSpc>
+                <a:spcPct val="100000"/>
+              </a:lnSpc>
+              <a:buNone/>
+            </a:pPr>
+            <a:r>
+              <a:rPr sz="900" b="0" i="0">
+                <a:solidFill>
+                  <a:srgbClr val="6A6F73"/>
+                </a:solidFill>
+                <a:latin typeface="Arial"/>
+                <a:ea typeface="Arial"/>
+                <a:cs typeface="Arial"/>
+              </a:rPr>
+              <a:t>300 → 750 MVA at 2.5x conductor capacity</a:t>
+            </a:r>
+          </a:p>
+        </p:txBody>
+      </p:sp>
+      <p:sp>
+        <p:nvSpPr>
+          <p:cNvPr id="1116" name=""/>
+          <p:cNvSpPr>
+            <a:spLocks noGrp="1"/>
+          </p:cNvSpPr>
+          <p:nvPr/>
+        </p:nvSpPr>
+        <p:spPr>
+          <a:xfrm>
+            <a:off x="8093954" y="2377440"/>
+            <a:ext cx="3378908" cy="1188720"/>
+          </a:xfrm>
+          <a:prstGeom prst="rect">
+            <a:avLst/>
+          </a:prstGeom>
+          <a:solidFill>
+            <a:srgbClr val="FFFFFF"/>
+          </a:solidFill>
+          <a:ln w="9525">
+            <a:solidFill>
+              <a:srgbClr val="D8D1C8"/>
+            </a:solidFill>
+            <a:prstDash val="solid"/>
+          </a:ln>
+        </p:spPr>
+      </p:sp>
+      <p:sp>
+        <p:nvSpPr>
+          <p:cNvPr id="1117" name=""/>
+          <p:cNvSpPr>
+            <a:spLocks noGrp="1"/>
+          </p:cNvSpPr>
+          <p:nvPr/>
+        </p:nvSpPr>
+        <p:spPr>
+          <a:xfrm>
+            <a:off x="8322554" y="2514600"/>
+            <a:ext cx="2921708" cy="594360"/>
+          </a:xfrm>
+          <a:prstGeom prst="rect">
+            <a:avLst/>
+          </a:prstGeom>
+          <a:noFill/>
+          <a:ln w="0">
+            <a:noFill/>
+            <a:prstDash val="solid"/>
+          </a:ln>
+        </p:spPr>
+        <p:txBody>
+          <a:bodyPr wrap="square" lIns="0" tIns="0" rIns="0" bIns="0" anchor="t">
+            <a:normAutofit fontScale="100000"/>
+          </a:bodyPr>
+          <a:lstStyle/>
+          <a:p>
+            <a:pPr algn="l">
+              <a:lnSpc>
+                <a:spcPct val="100000"/>
+              </a:lnSpc>
+              <a:buNone/>
+            </a:pPr>
+            <a:r>
+              <a:rPr sz="3200" b="1" i="0">
+                <a:solidFill>
+                  <a:srgbClr val="9D4E24"/>
+                </a:solidFill>
+                <a:latin typeface="Arial"/>
+                <a:ea typeface="Arial"/>
+                <a:cs typeface="Arial"/>
+              </a:rPr>
+              <a:t>~$57.5M</a:t>
+            </a:r>
+          </a:p>
+        </p:txBody>
+      </p:sp>
+      <p:sp>
+        <p:nvSpPr>
+          <p:cNvPr id="1118" name=""/>
+          <p:cNvSpPr>
+            <a:spLocks noGrp="1"/>
+          </p:cNvSpPr>
+          <p:nvPr/>
+        </p:nvSpPr>
+        <p:spPr>
+          <a:xfrm>
+            <a:off x="8322554" y="3108960"/>
+            <a:ext cx="2921708" cy="228600"/>
+          </a:xfrm>
+          <a:prstGeom prst="rect">
+            <a:avLst/>
+          </a:prstGeom>
+          <a:noFill/>
+          <a:ln w="0">
+            <a:noFill/>
+            <a:prstDash val="solid"/>
+          </a:ln>
+        </p:spPr>
+        <p:txBody>
+          <a:bodyPr wrap="square" lIns="0" tIns="0" rIns="0" bIns="0" anchor="t">
+            <a:normAutofit fontScale="100000"/>
+          </a:bodyPr>
+          <a:lstStyle/>
+          <a:p>
+            <a:pPr algn="l">
+              <a:lnSpc>
+                <a:spcPct val="100000"/>
+              </a:lnSpc>
+              <a:buNone/>
+            </a:pPr>
+            <a:r>
+              <a:rPr sz="1050" b="1" i="0">
+                <a:solidFill>
+                  <a:srgbClr val="17191C"/>
+                </a:solidFill>
+                <a:latin typeface="Arial"/>
+                <a:ea typeface="Arial"/>
+                <a:cs typeface="Arial"/>
+              </a:rPr>
+              <a:t>lower upgrade cost</a:t>
+            </a:r>
+          </a:p>
+        </p:txBody>
+      </p:sp>
+      <p:sp>
+        <p:nvSpPr>
+          <p:cNvPr id="1119" name=""/>
+          <p:cNvSpPr>
+            <a:spLocks noGrp="1"/>
+          </p:cNvSpPr>
+          <p:nvPr/>
+        </p:nvSpPr>
+        <p:spPr>
+          <a:xfrm>
+            <a:off x="8322554" y="3337560"/>
+            <a:ext cx="2921708" cy="228600"/>
+          </a:xfrm>
+          <a:prstGeom prst="rect">
+            <a:avLst/>
+          </a:prstGeom>
+          <a:noFill/>
+          <a:ln w="0">
+            <a:noFill/>
+            <a:prstDash val="solid"/>
+          </a:ln>
+        </p:spPr>
+        <p:txBody>
+          <a:bodyPr wrap="square" lIns="0" tIns="0" rIns="0" bIns="0" anchor="t">
+            <a:normAutofit fontScale="100000"/>
+          </a:bodyPr>
+          <a:lstStyle/>
+          <a:p>
+            <a:pPr algn="l">
+              <a:lnSpc>
+                <a:spcPct val="100000"/>
+              </a:lnSpc>
+              <a:buNone/>
+            </a:pPr>
+            <a:r>
+              <a:rPr sz="900" b="0" i="0">
+                <a:solidFill>
+                  <a:srgbClr val="6A6F73"/>
+                </a:solidFill>
+                <a:latin typeface="Arial"/>
+                <a:ea typeface="Arial"/>
+                <a:cs typeface="Arial"/>
+              </a:rPr>
+              <a:t>$87.5M new build → $30.0M reconductor</a:t>
+            </a:r>
+          </a:p>
+        </p:txBody>
+      </p:sp>
+      <p:sp>
+        <p:nvSpPr>
+          <p:cNvPr id="1120" name=""/>
+          <p:cNvSpPr>
+            <a:spLocks noGrp="1"/>
+          </p:cNvSpPr>
+          <p:nvPr/>
+        </p:nvSpPr>
+        <p:spPr>
+          <a:xfrm>
+            <a:off x="719138" y="3794760"/>
+            <a:ext cx="5237862" cy="228600"/>
+          </a:xfrm>
+          <a:prstGeom prst="rect">
+            <a:avLst/>
+          </a:prstGeom>
+          <a:noFill/>
+          <a:ln w="0">
+            <a:noFill/>
+            <a:prstDash val="solid"/>
+          </a:ln>
+        </p:spPr>
+        <p:txBody>
+          <a:bodyPr wrap="square" lIns="0" tIns="0" rIns="0" bIns="0" anchor="t">
+            <a:normAutofit fontScale="100000"/>
+          </a:bodyPr>
+          <a:lstStyle/>
+          <a:p>
+            <a:pPr algn="l">
+              <a:lnSpc>
+                <a:spcPct val="100000"/>
+              </a:lnSpc>
+              <a:buNone/>
+            </a:pPr>
+            <a:r>
+              <a:rPr sz="975" b="1" i="0">
+                <a:solidFill>
+                  <a:srgbClr val="9D4E24"/>
+                </a:solidFill>
+                <a:latin typeface="Arial Narrow"/>
+                <a:ea typeface="Arial Narrow"/>
+                <a:cs typeface="Arial Narrow"/>
+              </a:rPr>
+              <a:t>WHERE THE $57.5M COMES FROM</a:t>
+            </a:r>
+          </a:p>
+        </p:txBody>
+      </p:sp>
+      <p:sp>
+        <p:nvSpPr>
+          <p:cNvPr id="1121" name=""/>
+          <p:cNvSpPr>
+            <a:spLocks noGrp="1"/>
+          </p:cNvSpPr>
+          <p:nvPr/>
+        </p:nvSpPr>
+        <p:spPr>
+          <a:xfrm>
+            <a:off x="719138" y="4069080"/>
+            <a:ext cx="5237862" cy="340000"/>
+          </a:xfrm>
+          <a:prstGeom prst="rect">
+            <a:avLst/>
+          </a:prstGeom>
+          <a:noFill/>
+          <a:ln w="0">
+            <a:noFill/>
+            <a:prstDash val="solid"/>
+          </a:ln>
+        </p:spPr>
+        <p:txBody>
+          <a:bodyPr wrap="square" lIns="0" tIns="0" rIns="0" bIns="0" anchor="t">
+            <a:normAutofit fontScale="100000"/>
+          </a:bodyPr>
+          <a:lstStyle/>
+          <a:p>
+            <a:pPr algn="l">
+              <a:lnSpc>
+                <a:spcPct val="104000"/>
+              </a:lnSpc>
+              <a:buNone/>
+            </a:pPr>
+            <a:r>
+              <a:rPr sz="1050" b="1" i="0">
+                <a:solidFill>
+                  <a:srgbClr val="17191C"/>
+                </a:solidFill>
+                <a:latin typeface="Arial"/>
+                <a:ea typeface="Arial"/>
+                <a:cs typeface="Arial"/>
+              </a:rPr>
+              <a:t>$30.0M</a:t>
+            </a:r>
+            <a:r>
+              <a:rPr sz="1050" b="0" i="0">
+                <a:solidFill>
+                  <a:srgbClr val="6A6F73"/>
+                </a:solidFill>
+                <a:latin typeface="Arial"/>
+                <a:ea typeface="Arial"/>
+                <a:cs typeface="Arial"/>
+              </a:rPr>
+              <a:t> structures and foundations — the existing towers are reused.</a:t>
+            </a:r>
+          </a:p>
+        </p:txBody>
+      </p:sp>
+      <p:sp>
+        <p:nvSpPr>
+          <p:cNvPr id="1122" name=""/>
+          <p:cNvSpPr>
+            <a:spLocks noGrp="1"/>
+          </p:cNvSpPr>
+          <p:nvPr/>
+        </p:nvSpPr>
+        <p:spPr>
+          <a:xfrm>
+            <a:off x="719138" y="4480560"/>
+            <a:ext cx="5237862" cy="340000"/>
+          </a:xfrm>
+          <a:prstGeom prst="rect">
+            <a:avLst/>
+          </a:prstGeom>
+          <a:noFill/>
+          <a:ln w="0">
+            <a:noFill/>
+            <a:prstDash val="solid"/>
+          </a:ln>
+        </p:spPr>
+        <p:txBody>
+          <a:bodyPr wrap="square" lIns="0" tIns="0" rIns="0" bIns="0" anchor="t">
+            <a:normAutofit fontScale="100000"/>
+          </a:bodyPr>
+          <a:lstStyle/>
+          <a:p>
+            <a:pPr algn="l">
+              <a:lnSpc>
+                <a:spcPct val="104000"/>
+              </a:lnSpc>
+              <a:buNone/>
+            </a:pPr>
+            <a:r>
+              <a:rPr sz="1050" b="1" i="0">
+                <a:solidFill>
+                  <a:srgbClr val="17191C"/>
+                </a:solidFill>
+                <a:latin typeface="Arial"/>
+                <a:ea typeface="Arial"/>
+                <a:cs typeface="Arial"/>
+              </a:rPr>
+              <a:t>$15.0M</a:t>
+            </a:r>
+            <a:r>
+              <a:rPr sz="1050" b="0" i="0">
+                <a:solidFill>
+                  <a:srgbClr val="6A6F73"/>
+                </a:solidFill>
+                <a:latin typeface="Arial"/>
+                <a:ea typeface="Arial"/>
+                <a:cs typeface="Arial"/>
+              </a:rPr>
+              <a:t> right-of-way, permitting and legal — no new corridor to acquire.</a:t>
+            </a:r>
+          </a:p>
+        </p:txBody>
+      </p:sp>
+      <p:sp>
+        <p:nvSpPr>
+          <p:cNvPr id="1123" name=""/>
+          <p:cNvSpPr>
+            <a:spLocks noGrp="1"/>
+          </p:cNvSpPr>
+          <p:nvPr/>
+        </p:nvSpPr>
+        <p:spPr>
+          <a:xfrm>
+            <a:off x="719138" y="4892040"/>
+            <a:ext cx="5237862" cy="340000"/>
+          </a:xfrm>
+          <a:prstGeom prst="rect">
+            <a:avLst/>
+          </a:prstGeom>
+          <a:noFill/>
+          <a:ln w="0">
+            <a:noFill/>
+            <a:prstDash val="solid"/>
+          </a:ln>
+        </p:spPr>
+        <p:txBody>
+          <a:bodyPr wrap="square" lIns="0" tIns="0" rIns="0" bIns="0" anchor="t">
+            <a:normAutofit fontScale="100000"/>
+          </a:bodyPr>
+          <a:lstStyle/>
+          <a:p>
+            <a:pPr algn="l">
+              <a:lnSpc>
+                <a:spcPct val="104000"/>
+              </a:lnSpc>
+              <a:buNone/>
+            </a:pPr>
+            <a:r>
+              <a:rPr sz="1050" b="1" i="0">
+                <a:solidFill>
+                  <a:srgbClr val="17191C"/>
+                </a:solidFill>
+                <a:latin typeface="Arial"/>
+                <a:ea typeface="Arial"/>
+                <a:cs typeface="Arial"/>
+              </a:rPr>
+              <a:t>$12.5M</a:t>
+            </a:r>
+            <a:r>
+              <a:rPr sz="1050" b="0" i="0">
+                <a:solidFill>
+                  <a:srgbClr val="6A6F73"/>
+                </a:solidFill>
+                <a:latin typeface="Arial"/>
+                <a:ea typeface="Arial"/>
+                <a:cs typeface="Arial"/>
+              </a:rPr>
+              <a:t> materials efficiency and construction labor — smaller crews, faster install.</a:t>
+            </a:r>
+          </a:p>
+        </p:txBody>
+      </p:sp>
+      <p:sp>
+        <p:nvSpPr>
+          <p:cNvPr id="1124" name=""/>
+          <p:cNvSpPr>
+            <a:spLocks noGrp="1"/>
+          </p:cNvSpPr>
+          <p:nvPr/>
+        </p:nvSpPr>
+        <p:spPr>
+          <a:xfrm>
+            <a:off x="6234000" y="3794760"/>
+            <a:ext cx="5238862" cy="228600"/>
+          </a:xfrm>
+          <a:prstGeom prst="rect">
+            <a:avLst/>
+          </a:prstGeom>
+          <a:noFill/>
+          <a:ln w="0">
+            <a:noFill/>
+            <a:prstDash val="solid"/>
+          </a:ln>
+        </p:spPr>
+        <p:txBody>
+          <a:bodyPr wrap="square" lIns="0" tIns="0" rIns="0" bIns="0" anchor="t">
+            <a:normAutofit fontScale="100000"/>
+          </a:bodyPr>
+          <a:lstStyle/>
+          <a:p>
+            <a:pPr algn="l">
+              <a:lnSpc>
+                <a:spcPct val="100000"/>
+              </a:lnSpc>
+              <a:buNone/>
+            </a:pPr>
+            <a:r>
+              <a:rPr sz="975" b="1" i="0">
+                <a:solidFill>
+                  <a:srgbClr val="9D4E24"/>
+                </a:solidFill>
+                <a:latin typeface="Arial Narrow"/>
+                <a:ea typeface="Arial Narrow"/>
+                <a:cs typeface="Arial Narrow"/>
+              </a:rPr>
+              <a:t>WHY THIS IS AN IPP LEVER, NOT ONLY A UTILITY ONE</a:t>
+            </a:r>
+          </a:p>
+        </p:txBody>
+      </p:sp>
+      <p:sp>
+        <p:nvSpPr>
+          <p:cNvPr id="1125" name=""/>
+          <p:cNvSpPr>
+            <a:spLocks noGrp="1"/>
+          </p:cNvSpPr>
+          <p:nvPr/>
+        </p:nvSpPr>
+        <p:spPr>
+          <a:xfrm>
+            <a:off x="6234000" y="4128080"/>
+            <a:ext cx="91440" cy="91440"/>
+          </a:xfrm>
+          <a:prstGeom prst="rect">
+            <a:avLst/>
+          </a:prstGeom>
+          <a:solidFill>
+            <a:srgbClr val="C9783E"/>
+          </a:solidFill>
+          <a:ln w="0">
+            <a:noFill/>
+            <a:prstDash val="solid"/>
+          </a:ln>
+        </p:spPr>
+      </p:sp>
+      <p:sp>
+        <p:nvSpPr>
+          <p:cNvPr id="1126" name=""/>
+          <p:cNvSpPr>
+            <a:spLocks noGrp="1"/>
+          </p:cNvSpPr>
+          <p:nvPr/>
+        </p:nvSpPr>
+        <p:spPr>
+          <a:xfrm>
+            <a:off x="6462600" y="4069080"/>
+            <a:ext cx="5010262" cy="340000"/>
+          </a:xfrm>
+          <a:prstGeom prst="rect">
+            <a:avLst/>
+          </a:prstGeom>
+          <a:noFill/>
+          <a:ln w="0">
+            <a:noFill/>
+            <a:prstDash val="solid"/>
+          </a:ln>
+        </p:spPr>
+        <p:txBody>
+          <a:bodyPr wrap="square" lIns="0" tIns="0" rIns="0" bIns="0" anchor="t">
+            <a:normAutofit fontScale="100000"/>
+          </a:bodyPr>
+          <a:lstStyle/>
+          <a:p>
+            <a:pPr algn="l">
+              <a:lnSpc>
+                <a:spcPct val="104000"/>
+              </a:lnSpc>
+              <a:buNone/>
+            </a:pPr>
+            <a:r>
+              <a:rPr sz="1050" b="0" i="0">
+                <a:solidFill>
+                  <a:srgbClr val="6A6F73"/>
+                </a:solidFill>
+                <a:latin typeface="Arial"/>
+                <a:ea typeface="Arial"/>
+                <a:cs typeface="Arial"/>
+              </a:rPr>
+              <a:t>COD moves left — and revenue that starts years earlier is the IRR lever on A6.</a:t>
+            </a:r>
+          </a:p>
+        </p:txBody>
+      </p:sp>
+      <p:sp>
+        <p:nvSpPr>
+          <p:cNvPr id="1127" name=""/>
+          <p:cNvSpPr>
+            <a:spLocks noGrp="1"/>
+          </p:cNvSpPr>
+          <p:nvPr/>
+        </p:nvSpPr>
+        <p:spPr>
+          <a:xfrm>
+            <a:off x="6234000" y="4539560"/>
+            <a:ext cx="91440" cy="91440"/>
+          </a:xfrm>
+          <a:prstGeom prst="rect">
+            <a:avLst/>
+          </a:prstGeom>
+          <a:solidFill>
+            <a:srgbClr val="C9783E"/>
+          </a:solidFill>
+          <a:ln w="0">
+            <a:noFill/>
+            <a:prstDash val="solid"/>
+          </a:ln>
+        </p:spPr>
+      </p:sp>
+      <p:sp>
+        <p:nvSpPr>
+          <p:cNvPr id="1128" name=""/>
+          <p:cNvSpPr>
+            <a:spLocks noGrp="1"/>
+          </p:cNvSpPr>
+          <p:nvPr/>
+        </p:nvSpPr>
+        <p:spPr>
+          <a:xfrm>
+            <a:off x="6462600" y="4480560"/>
+            <a:ext cx="5010262" cy="340000"/>
+          </a:xfrm>
+          <a:prstGeom prst="rect">
+            <a:avLst/>
+          </a:prstGeom>
+          <a:noFill/>
+          <a:ln w="0">
+            <a:noFill/>
+            <a:prstDash val="solid"/>
+          </a:ln>
+        </p:spPr>
+        <p:txBody>
+          <a:bodyPr wrap="square" lIns="0" tIns="0" rIns="0" bIns="0" anchor="t">
+            <a:normAutofit fontScale="100000"/>
+          </a:bodyPr>
+          <a:lstStyle/>
+          <a:p>
+            <a:pPr algn="l">
+              <a:lnSpc>
+                <a:spcPct val="104000"/>
+              </a:lnSpc>
+              <a:buNone/>
+            </a:pPr>
+            <a:r>
+              <a:rPr sz="1050" b="0" i="0">
+                <a:solidFill>
+                  <a:srgbClr val="6A6F73"/>
+                </a:solidFill>
+                <a:latin typeface="Arial"/>
+                <a:ea typeface="Arial"/>
+                <a:cs typeface="Arial"/>
+              </a:rPr>
+              <a:t>Where the interconnection customer funds the network upgrade, the assigned cost falls with it.</a:t>
+            </a:r>
+          </a:p>
+        </p:txBody>
+      </p:sp>
+      <p:sp>
+        <p:nvSpPr>
+          <p:cNvPr id="1129" name=""/>
+          <p:cNvSpPr>
+            <a:spLocks noGrp="1"/>
+          </p:cNvSpPr>
+          <p:nvPr/>
+        </p:nvSpPr>
+        <p:spPr>
+          <a:xfrm>
+            <a:off x="6234000" y="4951040"/>
+            <a:ext cx="91440" cy="91440"/>
+          </a:xfrm>
+          <a:prstGeom prst="rect">
+            <a:avLst/>
+          </a:prstGeom>
+          <a:solidFill>
+            <a:srgbClr val="C9783E"/>
+          </a:solidFill>
+          <a:ln w="0">
+            <a:noFill/>
+            <a:prstDash val="solid"/>
+          </a:ln>
+        </p:spPr>
+      </p:sp>
+      <p:sp>
+        <p:nvSpPr>
+          <p:cNvPr id="1130" name=""/>
+          <p:cNvSpPr>
+            <a:spLocks noGrp="1"/>
+          </p:cNvSpPr>
+          <p:nvPr/>
+        </p:nvSpPr>
+        <p:spPr>
+          <a:xfrm>
+            <a:off x="6462600" y="4892040"/>
+            <a:ext cx="5010262" cy="340000"/>
+          </a:xfrm>
+          <a:prstGeom prst="rect">
+            <a:avLst/>
+          </a:prstGeom>
+          <a:noFill/>
+          <a:ln w="0">
+            <a:noFill/>
+            <a:prstDash val="solid"/>
+          </a:ln>
+        </p:spPr>
+        <p:txBody>
+          <a:bodyPr wrap="square" lIns="0" tIns="0" rIns="0" bIns="0" anchor="t">
+            <a:normAutofit fontScale="100000"/>
+          </a:bodyPr>
+          <a:lstStyle/>
+          <a:p>
+            <a:pPr algn="l">
+              <a:lnSpc>
+                <a:spcPct val="104000"/>
+              </a:lnSpc>
+              <a:buNone/>
+            </a:pPr>
+            <a:r>
+              <a:rPr sz="1050" b="0" i="0">
+                <a:solidFill>
+                  <a:srgbClr val="6A6F73"/>
+                </a:solidFill>
+                <a:latin typeface="Arial"/>
+                <a:ea typeface="Arial"/>
+                <a:cs typeface="Arial"/>
+              </a:rPr>
+              <a:t>Gen-tie thermal limits cleared on uprates without rebuilding structures.</a:t>
+            </a:r>
+          </a:p>
+        </p:txBody>
+      </p:sp>
+      <p:sp>
+        <p:nvSpPr>
+          <p:cNvPr id="1131" name=""/>
+          <p:cNvSpPr>
+            <a:spLocks noGrp="1"/>
+          </p:cNvSpPr>
+          <p:nvPr/>
+        </p:nvSpPr>
+        <p:spPr>
+          <a:xfrm>
+            <a:off x="6234000" y="5362520"/>
+            <a:ext cx="91440" cy="91440"/>
+          </a:xfrm>
+          <a:prstGeom prst="rect">
+            <a:avLst/>
+          </a:prstGeom>
+          <a:solidFill>
+            <a:srgbClr val="C9783E"/>
+          </a:solidFill>
+          <a:ln w="0">
+            <a:noFill/>
+            <a:prstDash val="solid"/>
+          </a:ln>
+        </p:spPr>
+      </p:sp>
+      <p:sp>
+        <p:nvSpPr>
+          <p:cNvPr id="1132" name=""/>
+          <p:cNvSpPr>
+            <a:spLocks noGrp="1"/>
+          </p:cNvSpPr>
+          <p:nvPr/>
+        </p:nvSpPr>
+        <p:spPr>
+          <a:xfrm>
+            <a:off x="6462600" y="5303520"/>
+            <a:ext cx="5010262" cy="340000"/>
+          </a:xfrm>
+          <a:prstGeom prst="rect">
+            <a:avLst/>
+          </a:prstGeom>
+          <a:noFill/>
+          <a:ln w="0">
+            <a:noFill/>
+            <a:prstDash val="solid"/>
+          </a:ln>
+        </p:spPr>
+        <p:txBody>
+          <a:bodyPr wrap="square" lIns="0" tIns="0" rIns="0" bIns="0" anchor="t">
+            <a:normAutofit fontScale="100000"/>
+          </a:bodyPr>
+          <a:lstStyle/>
+          <a:p>
+            <a:pPr algn="l">
+              <a:lnSpc>
+                <a:spcPct val="104000"/>
+              </a:lnSpc>
+              <a:buNone/>
+            </a:pPr>
+            <a:r>
+              <a:rPr sz="1050" b="0" i="0">
+                <a:solidFill>
+                  <a:srgbClr val="6A6F73"/>
+                </a:solidFill>
+                <a:latin typeface="Arial"/>
+                <a:ea typeface="Arial"/>
+                <a:cs typeface="Arial"/>
+              </a:rPr>
+              <a:t>Capacity out of a corridor already in service, instead of another position in the queue.</a:t>
+            </a:r>
+          </a:p>
+        </p:txBody>
+      </p:sp>
+      <p:sp>
+        <p:nvSpPr>
+          <p:cNvPr id="1133" name=""/>
+          <p:cNvSpPr>
+            <a:spLocks noGrp="1"/>
+          </p:cNvSpPr>
+          <p:nvPr/>
+        </p:nvSpPr>
+        <p:spPr>
+          <a:xfrm>
+            <a:off x="719138" y="5623560"/>
+            <a:ext cx="10753724" cy="460000"/>
+          </a:xfrm>
+          <a:prstGeom prst="rect">
+            <a:avLst/>
+          </a:prstGeom>
+          <a:noFill/>
+          <a:ln w="0">
+            <a:noFill/>
+            <a:prstDash val="solid"/>
+          </a:ln>
+        </p:spPr>
+        <p:txBody>
+          <a:bodyPr wrap="square" lIns="0" tIns="0" rIns="0" bIns="0" anchor="t">
+            <a:normAutofit fontScale="100000"/>
+          </a:bodyPr>
+          <a:lstStyle/>
+          <a:p>
+            <a:pPr algn="l">
+              <a:lnSpc>
+                <a:spcPct val="106000"/>
+              </a:lnSpc>
+              <a:buNone/>
+            </a:pPr>
+            <a:r>
+              <a:rPr sz="900" b="0" i="1">
+                <a:solidFill>
+                  <a:srgbClr val="17191C"/>
+                </a:solidFill>
+                <a:latin typeface="Arial"/>
+                <a:ea typeface="Arial"/>
+                <a:cs typeface="Arial"/>
+              </a:rPr>
+              <a:t>HOW IT ACTUALLY HAPPENS:  the network line belongs to the transmission owner, not the generator. A reconductor is proposed and funded through the interconnection study process and needs the TO and the ISO to agree. What Southwire supplies is the conductor and the engineering that makes the alternative credible enough to be studied — plus the gen-tie itself, which the generator does own.</a:t>
+            </a:r>
+          </a:p>
+        </p:txBody>
+      </p:sp>
+      <p:sp>
+        <p:nvSpPr>
+          <p:cNvPr id="1134" name=""/>
+          <p:cNvSpPr>
+            <a:spLocks noGrp="1"/>
+          </p:cNvSpPr>
+          <p:nvPr/>
+        </p:nvSpPr>
+        <p:spPr>
+          <a:xfrm>
+            <a:off x="719138" y="6315000"/>
+            <a:ext cx="10753724" cy="400000"/>
+          </a:xfrm>
+          <a:prstGeom prst="rect">
+            <a:avLst/>
+          </a:prstGeom>
+          <a:solidFill>
+            <a:srgbClr val="17191C"/>
+          </a:solidFill>
+          <a:ln w="0">
+            <a:noFill/>
+            <a:prstDash val="solid"/>
+          </a:ln>
+        </p:spPr>
+      </p:sp>
+      <p:sp>
+        <p:nvSpPr>
+          <p:cNvPr id="1135" name=""/>
+          <p:cNvSpPr>
+            <a:spLocks noGrp="1"/>
+          </p:cNvSpPr>
+          <p:nvPr/>
+        </p:nvSpPr>
+        <p:spPr>
+          <a:xfrm>
+            <a:off x="719138" y="6315000"/>
+            <a:ext cx="10753724" cy="400000"/>
+          </a:xfrm>
+          <a:prstGeom prst="rect">
+            <a:avLst/>
+          </a:prstGeom>
+          <a:noFill/>
+          <a:ln w="0">
+            <a:noFill/>
+            <a:prstDash val="solid"/>
+          </a:ln>
+        </p:spPr>
+        <p:txBody>
+          <a:bodyPr wrap="square" lIns="0" tIns="0" rIns="0" bIns="0" anchor="ctr">
+            <a:normAutofit fontScale="100000"/>
+          </a:bodyPr>
+          <a:lstStyle/>
+          <a:p>
+            <a:pPr algn="ctr">
+              <a:lnSpc>
+                <a:spcPct val="100000"/>
+              </a:lnSpc>
+              <a:buNone/>
+            </a:pPr>
+            <a:r>
+              <a:rPr sz="1050" b="1" i="0">
+                <a:solidFill>
+                  <a:srgbClr val="FFFFFF"/>
+                </a:solidFill>
+                <a:latin typeface="Arial Narrow"/>
+                <a:ea typeface="Arial Narrow"/>
+                <a:cs typeface="Arial Narrow"/>
+              </a:rPr>
+              <a:t>ILLUSTRATIVE 25-MILE CASE — STRUCTURE AND ROW REUSE ASSUMED; COST AND SCHEDULE FIGURES ARE MODELED, NOT QUOTED.</a:t>
+            </a:r>
+          </a:p>
+        </p:txBody>
+      </p:sp>
+    </p:spTree>
+  </p:cSld>
+</p:sld>
+</file>
+
 <file path=ppt/slides/slide3.xml><?xml version="1.0" encoding="utf-8"?>
 <p:sld xmlns:p="http://schemas.openxmlformats.org/presentationml/2006/main">
   <p:cSld>

</xml_diff>

<commit_message>
Soften Cedar Bayou wording from recommendation to worked example
External review caught that A9's headline and band were more presumptive
than slide 8's your-call framing. Aligns both to the deck's
no-presumption posture; project facts unchanged.

Co-Authored-By: Claude Opus 5 <noreply@anthropic.com>
Claude-Session: https://claude.ai/code/session_01DUeyPCeDvcPsyTcH6oQXEK
</commit_message>
<xml_diff>
--- a/teaser-rework/Southwire_NRG_Protecting_Time_to_Power_Rev10.pptx
+++ b/teaser-rework/Southwire_NRG_Protecting_Time_to_Power_Rev10.pptx
@@ -12383,7 +12383,7 @@
                 <a:ea typeface="Arial"/>
                 <a:cs typeface="Arial"/>
               </a:rPr>
-              <a:t>Cedar Bayou 5 is the natural first live scope.</a:t>
+              <a:t>Cedar Bayou Unit 5 — an example, not a recommendation.</a:t>
             </a:r>
           </a:p>
         </p:txBody>
@@ -12911,7 +12911,7 @@
                 <a:ea typeface="Arial Narrow"/>
                 <a:cs typeface="Arial Narrow"/>
               </a:rPr>
-              <a:t>POTENTIAL SCOPE SELECTIONS</a:t>
+              <a:t>SCOPE THAT WOULD BE IN PLAY</a:t>
             </a:r>
           </a:p>
         </p:txBody>
@@ -13543,7 +13543,7 @@
                 <a:ea typeface="Arial Narrow"/>
                 <a:cs typeface="Arial Narrow"/>
               </a:rPr>
-              <a:t>IN ACTIVE PROCUREMENT NOW — THE OBVIOUS CANDIDATE FOR THE ONE-LIVE-SCOPE VALIDATION PATH ON SLIDE 8.</a:t>
+              <a:t>IN ACTIVE PROCUREMENT — INCLUDED AS A WORKED EXAMPLE; NRG SELECTS THE STARTING SCOPE (SEE SLIDE 8).</a:t>
             </a:r>
           </a:p>
         </p:txBody>
@@ -31962,7 +31962,7 @@
                 <a:ea typeface="Arial Narrow"/>
                 <a:cs typeface="Arial Narrow"/>
               </a:rPr>
-              <a:t>SUGGESTED FIRST SCOPE:  </a:t>
+              <a:t>EXAMPLE SCOPE FOR DISCUSSION:  </a:t>
             </a:r>
             <a:r xmlns:a="http://schemas.openxmlformats.org/drawingml/2006/main">
               <a:rPr sz="1050" b="1" i="0">
@@ -31984,7 +31984,7 @@
                 <a:ea typeface="Arial Narrow"/>
                 <a:cs typeface="Arial Narrow"/>
               </a:rPr>
-              <a:t>   ·   OUR SUGGESTION, YOUR CALL   ·   DETAIL IN APPENDIX A9</a:t>
+              <a:t>   ·   NRG SELECTS THE SCOPE   ·   DETAIL IN APPENDIX A9</a:t>
             </a:r>
           </a:p>
         </p:txBody>

</xml_diff>